<commit_message>
Update deck and READMEs with the Graviton3 results
- Deck: slides 1, 2, 5, 10, 11 and 12 now reflect tiers T0-T3 complete, the KleidiAI Q8_0 accuracy loss on Phi-3, the decode roofline and the kernel results on real hardware
- README.md: point to the Arm port, note that the per-block INT8 claim (block 0 = 70%) is revised to about 33% by the KL-divergence measurement, extend the layout section
- README_arm.md: rewrite the handoff note as the Arm-port README (status, findings, layout, how to run, energy meter, Mac rules, limits)
</commit_message>
<xml_diff>
--- a/presentation/Evol_inference_mac-m4.pptx
+++ b/presentation/Evol_inference_mac-m4.pptx
@@ -118,20 +118,20 @@
   <p:extLst>
     <p:ext uri="{521415D9-36F7-43E2-AB2F-B90AF26B5E84}">
       <p14:sectionLst xmlns:p14="http://schemas.microsoft.com/office/powerpoint/2010/main">
-        <p14:section name="Context" id="{f7feb9a9-3736-61a4-db5d-0390a3b76591}">
+        <p14:section name="Context" id="{021a97e0-0d89-6f0d-e9f8-8b4c2308b558}">
           <p14:sldIdLst>
             <p14:sldId id="256"/>
             <p14:sldId id="257"/>
             <p14:sldId id="258"/>
           </p14:sldIdLst>
         </p14:section>
-        <p14:section name="Method" id="{0cea7062-47e2-b2e8-06ed-ac8e81684603}">
+        <p14:section name="Method" id="{388de985-fb97-518d-2ea3-b6f6ab20488c}">
           <p14:sldIdLst>
             <p14:sldId id="259"/>
             <p14:sldId id="260"/>
           </p14:sldIdLst>
         </p14:section>
-        <p14:section name="Results" id="{5e0705cc-3703-109c-1c98-41dae6f04ad6}">
+        <p14:section name="Results" id="{54383ae4-e2c6-e9bc-0445-683589727d09}">
           <p14:sldIdLst>
             <p14:sldId id="261"/>
             <p14:sldId id="262"/>
@@ -1764,7 +1764,7 @@
                 </a:solidFill>
                 <a:latin typeface="+mn-lt"/>
               </a:rPr>
-              <a:t>SmolLM2-360M Q8_0 under QEMU: KL divergence (nats)</a:t>
+              <a:t>Phi-3-mini on c7g.2xlarge: accuracy cost (% perplexity increase)</a:t>
             </a:r>
           </a:p>
         </c:rich>
@@ -1788,7 +1788,7 @@
               <c:strCache>
                 <c:ptCount val="1"/>
                 <c:pt idx="0">
-                  <c:v>Q8_0 KL divergence vs x86 F16 logits</c:v>
+                  <c:v>Perplexity increase vs F16 (%)</c:v>
                 </c:pt>
               </c:strCache>
             </c:strRef>
@@ -1801,7 +1801,7 @@
           </c:spPr>
           <c:invertIfNegative val="0"/>
           <c:dLbls>
-            <c:numFmt formatCode="0.0000" sourceLinked="0"/>
+            <c:numFmt formatCode="0.00" sourceLinked="0"/>
             <c:txPr>
               <a:bodyPr/>
               <a:lstStyle/>
@@ -1841,7 +1841,7 @@
             <c:bubble3D val="0"/>
             <c:spPr>
               <a:solidFill>
-                <a:srgbClr val="6C7A89"/>
+                <a:srgbClr val="D1495B"/>
               </a:solidFill>
               <a:effectLst/>
             </c:spPr>
@@ -1868,37 +1868,23 @@
               <a:effectLst/>
             </c:spPr>
           </c:dPt>
-          <c:dPt>
-            <c:idx val="4"/>
-            <c:invertIfNegative val="0"/>
-            <c:bubble3D val="0"/>
-            <c:spPr>
-              <a:solidFill>
-                <a:srgbClr val="D1495B"/>
-              </a:solidFill>
-              <a:effectLst/>
-            </c:spPr>
-          </c:dPt>
           <c:cat>
             <c:multiLvlStrRef>
-              <c:f>Sheet1!$A$2:$A$6</c:f>
+              <c:f>Sheet1!$A$2:$A$5</c:f>
               <c:multiLvlStrCache>
-                <c:ptCount val="5"/>
+                <c:ptCount val="4"/>
                 <c:lvl>
                   <c:pt idx="0">
-                    <c:v>x86 AVX512</c:v>
+                    <c:v>Q8_0 stock</c:v>
                   </c:pt>
                   <c:pt idx="1">
-                    <c:v>NEON generic</c:v>
+                    <c:v>Q8_0 KleidiAI</c:v>
                   </c:pt>
                   <c:pt idx="2">
-                    <c:v>+I8MM</c:v>
+                    <c:v>Q4_0 stock</c:v>
                   </c:pt>
                   <c:pt idx="3">
-                    <c:v>+SVE</c:v>
-                  </c:pt>
-                  <c:pt idx="4">
-                    <c:v>KleidiAI</c:v>
+                    <c:v>Q4_0 KleidiAI</c:v>
                   </c:pt>
                 </c:lvl>
               </c:multiLvlStrCache>
@@ -1906,31 +1892,28 @@
           </c:cat>
           <c:val>
             <c:numRef>
-              <c:f>Sheet1!$B$2:$B$6</c:f>
+              <c:f>Sheet1!$B$2:$B$5</c:f>
               <c:numCache>
                 <c:formatCode>General</c:formatCode>
-                <c:ptCount val="5"/>
+                <c:ptCount val="4"/>
                 <c:pt idx="0">
-                  <c:v>0.00389</c:v>
+                  <c:v>0.08</c:v>
                 </c:pt>
                 <c:pt idx="1">
-                  <c:v>0.00403</c:v>
+                  <c:v>2.87</c:v>
                 </c:pt>
                 <c:pt idx="2">
-                  <c:v>0.00383</c:v>
+                  <c:v>8.97</c:v>
                 </c:pt>
                 <c:pt idx="3">
-                  <c:v>0.00435</c:v>
-                </c:pt>
-                <c:pt idx="4">
-                  <c:v>0.03268</c:v>
+                  <c:v>8.97</c:v>
                 </c:pt>
               </c:numCache>
             </c:numRef>
           </c:val>
         </c:ser>
         <c:dLbls>
-          <c:numFmt formatCode="0.0000" sourceLinked="0"/>
+          <c:numFmt formatCode="0.00" sourceLinked="0"/>
           <c:txPr>
             <a:bodyPr/>
             <a:lstStyle/>
@@ -2004,6 +1987,311 @@
         <c:axId val="2094734552"/>
         <c:scaling>
           <c:orientation val="minMax"/>
+          <c:max val="10"/>
+          <c:min val="0"/>
+        </c:scaling>
+        <c:delete val="0"/>
+        <c:axPos val="l"/>
+        <c:majorGridlines>
+          <c:spPr>
+            <a:ln w="9525" cap="flat">
+              <a:solidFill>
+                <a:srgbClr val="D5DEE4"/>
+              </a:solidFill>
+              <a:prstDash val="solid"/>
+              <a:round/>
+            </a:ln>
+          </c:spPr>
+        </c:majorGridlines>
+        <c:numFmt formatCode="General" sourceLinked="0"/>
+        <c:majorTickMark val="out"/>
+        <c:minorTickMark val="none"/>
+        <c:tickLblPos val="nextTo"/>
+        <c:spPr>
+          <a:ln w="12700" cap="flat">
+            <a:solidFill>
+              <a:srgbClr val="888888"/>
+            </a:solidFill>
+            <a:prstDash val="solid"/>
+            <a:round/>
+          </a:ln>
+        </c:spPr>
+        <c:txPr>
+          <a:bodyPr/>
+          <a:lstStyle/>
+          <a:p>
+            <a:pPr>
+              <a:defRPr sz="1100" b="0" i="0" u="none" strike="noStrike">
+                <a:solidFill>
+                  <a:srgbClr val="6C7A89"/>
+                </a:solidFill>
+                <a:latin typeface="+mn-lt"/>
+              </a:defRPr>
+            </a:pPr>
+            <a:endParaRPr lang="en-US"/>
+          </a:p>
+        </c:txPr>
+        <c:crossAx val="2094734554"/>
+        <c:crosses val="autoZero"/>
+        <c:crossBetween val="between"/>
+      </c:valAx>
+      <c:spPr>
+        <a:noFill/>
+        <a:ln>
+          <a:noFill/>
+        </a:ln>
+        <a:effectLst/>
+      </c:spPr>
+    </c:plotArea>
+    <c:plotVisOnly val="1"/>
+    <c:dispBlanksAs val="span"/>
+  </c:chart>
+  <c:spPr>
+    <a:noFill/>
+    <a:ln>
+      <a:noFill/>
+    </a:ln>
+    <a:effectLst/>
+  </c:spPr>
+  <c:externalData r:id="rId1">
+    <c:autoUpdate val="0"/>
+  </c:externalData>
+</c:chartSpace>
+</file>
+
+<file path=ppt/charts/chart6.xml><?xml version="1.0" encoding="utf-8"?>
+<c:chartSpace xmlns:c="http://schemas.openxmlformats.org/drawingml/2006/chart" xmlns:a="http://schemas.openxmlformats.org/drawingml/2006/main" xmlns:r="http://schemas.openxmlformats.org/officeDocument/2006/relationships">
+  <c:date1904 val="0"/>
+  <c:roundedCorners val="1"/>
+  <c:chart>
+    <c:title>
+      <c:tx>
+        <c:rich>
+          <a:bodyPr/>
+          <a:lstStyle/>
+          <a:p>
+            <a:pPr>
+              <a:defRPr sz="1400" b="0" i="0" u="none" strike="noStrike">
+                <a:solidFill>
+                  <a:srgbClr val="0B3C4F"/>
+                </a:solidFill>
+                <a:latin typeface="+mn-lt"/>
+              </a:defRPr>
+            </a:pPr>
+            <a:r>
+              <a:rPr sz="1400" b="0" i="0" u="none" strike="noStrike">
+                <a:solidFill>
+                  <a:srgbClr val="0B3C4F"/>
+                </a:solidFill>
+                <a:latin typeface="+mn-lt"/>
+              </a:rPr>
+              <a:t>Phi-3 decode, 8 threads: % of measured read bandwidth (158.7 GB/s)</a:t>
+            </a:r>
+          </a:p>
+        </c:rich>
+      </c:tx>
+      <c:layout/>
+      <c:overlay val="0"/>
+    </c:title>
+    <c:autoTitleDeleted val="0"/>
+    <c:plotArea>
+      <c:layout/>
+      <c:barChart>
+        <c:barDir val="col"/>
+        <c:grouping val="clustered"/>
+        <c:varyColors val="0"/>
+        <c:ser>
+          <c:idx val="0"/>
+          <c:order val="0"/>
+          <c:tx>
+            <c:strRef>
+              <c:f>Sheet1!$B$1</c:f>
+              <c:strCache>
+                <c:ptCount val="1"/>
+                <c:pt idx="0">
+                  <c:v>Decode bandwidth as % of the memory roof</c:v>
+                </c:pt>
+              </c:strCache>
+            </c:strRef>
+          </c:tx>
+          <c:spPr>
+            <a:solidFill>
+              <a:srgbClr val="6C7A89"/>
+            </a:solidFill>
+            <a:effectLst/>
+          </c:spPr>
+          <c:invertIfNegative val="0"/>
+          <c:dLbls>
+            <c:numFmt formatCode="0" sourceLinked="0"/>
+            <c:txPr>
+              <a:bodyPr/>
+              <a:lstStyle/>
+              <a:p>
+                <a:pPr>
+                  <a:defRPr b="0" i="0" strike="noStrike" sz="1100" u="none">
+                    <a:solidFill>
+                      <a:srgbClr val="000000"/>
+                    </a:solidFill>
+                    <a:latin typeface="+mn-lt"/>
+                  </a:defRPr>
+                </a:pPr>
+              </a:p>
+            </c:txPr>
+            <c:showLegendKey val="0"/>
+            <c:showVal val="1"/>
+            <c:showCatName val="0"/>
+            <c:showSerName val="0"/>
+            <c:showPercent val="0"/>
+            <c:showBubbleSize val="0"/>
+            <c:showLeaderLines val="0"/>
+          </c:dLbls>
+          <c:dPt>
+            <c:idx val="0"/>
+            <c:invertIfNegative val="0"/>
+            <c:bubble3D val="0"/>
+            <c:spPr>
+              <a:solidFill>
+                <a:srgbClr val="6C7A89"/>
+              </a:solidFill>
+              <a:effectLst/>
+            </c:spPr>
+          </c:dPt>
+          <c:dPt>
+            <c:idx val="1"/>
+            <c:invertIfNegative val="0"/>
+            <c:bubble3D val="0"/>
+            <c:spPr>
+              <a:solidFill>
+                <a:srgbClr val="2E9E8A"/>
+              </a:solidFill>
+              <a:effectLst/>
+            </c:spPr>
+          </c:dPt>
+          <c:dPt>
+            <c:idx val="2"/>
+            <c:invertIfNegative val="0"/>
+            <c:bubble3D val="0"/>
+            <c:spPr>
+              <a:solidFill>
+                <a:srgbClr val="F2A541"/>
+              </a:solidFill>
+              <a:effectLst/>
+            </c:spPr>
+          </c:dPt>
+          <c:cat>
+            <c:multiLvlStrRef>
+              <c:f>Sheet1!$A$2:$A$4</c:f>
+              <c:multiLvlStrCache>
+                <c:ptCount val="3"/>
+                <c:lvl>
+                  <c:pt idx="0">
+                    <c:v>F16</c:v>
+                  </c:pt>
+                  <c:pt idx="1">
+                    <c:v>Q8_0</c:v>
+                  </c:pt>
+                  <c:pt idx="2">
+                    <c:v>Q4_0</c:v>
+                  </c:pt>
+                </c:lvl>
+              </c:multiLvlStrCache>
+            </c:multiLvlStrRef>
+          </c:cat>
+          <c:val>
+            <c:numRef>
+              <c:f>Sheet1!$B$2:$B$4</c:f>
+              <c:numCache>
+                <c:formatCode>General</c:formatCode>
+                <c:ptCount val="3"/>
+                <c:pt idx="0">
+                  <c:v>48</c:v>
+                </c:pt>
+                <c:pt idx="1">
+                  <c:v>95</c:v>
+                </c:pt>
+                <c:pt idx="2">
+                  <c:v>72</c:v>
+                </c:pt>
+              </c:numCache>
+            </c:numRef>
+          </c:val>
+        </c:ser>
+        <c:dLbls>
+          <c:numFmt formatCode="0" sourceLinked="0"/>
+          <c:txPr>
+            <a:bodyPr/>
+            <a:lstStyle/>
+            <a:p>
+              <a:pPr>
+                <a:defRPr b="0" i="0" strike="noStrike" sz="1100" u="none">
+                  <a:solidFill>
+                    <a:srgbClr val="000000"/>
+                  </a:solidFill>
+                  <a:latin typeface="+mn-lt"/>
+                </a:defRPr>
+              </a:pPr>
+            </a:p>
+          </c:txPr>
+          <c:showLegendKey val="0"/>
+          <c:showVal val="1"/>
+          <c:showCatName val="0"/>
+          <c:showSerName val="0"/>
+          <c:showPercent val="0"/>
+          <c:showBubbleSize val="0"/>
+          <c:showLeaderLines val="0"/>
+        </c:dLbls>
+        <c:gapWidth val="60"/>
+        <c:overlap val="0"/>
+        <c:axId val="2094734554"/>
+        <c:axId val="2094734552"/>
+        <c:axId val="2094734556"/>
+      </c:barChart>
+      <c:catAx>
+        <c:axId val="2094734554"/>
+        <c:scaling>
+          <c:orientation val="minMax"/>
+        </c:scaling>
+        <c:delete val="0"/>
+        <c:axPos val="b"/>
+        <c:numFmt formatCode="General" sourceLinked="1"/>
+        <c:majorTickMark val="out"/>
+        <c:minorTickMark val="none"/>
+        <c:tickLblPos val="low"/>
+        <c:spPr>
+          <a:ln w="12700" cap="flat">
+            <a:solidFill>
+              <a:srgbClr val="888888"/>
+            </a:solidFill>
+            <a:prstDash val="solid"/>
+            <a:round/>
+          </a:ln>
+        </c:spPr>
+        <c:txPr>
+          <a:bodyPr/>
+          <a:lstStyle/>
+          <a:p>
+            <a:pPr>
+              <a:defRPr sz="1200" b="0" i="0" u="none" strike="noStrike">
+                <a:solidFill>
+                  <a:srgbClr val="10212B"/>
+                </a:solidFill>
+                <a:latin typeface="+mn-lt"/>
+              </a:defRPr>
+            </a:pPr>
+            <a:endParaRPr lang="en-US"/>
+          </a:p>
+        </c:txPr>
+        <c:crossAx val="2094734552"/>
+        <c:crosses val="autoZero"/>
+        <c:auto val="1"/>
+        <c:lblAlgn val="ctr"/>
+        <c:noMultiLvlLbl val="1"/>
+      </c:catAx>
+      <c:valAx>
+        <c:axId val="2094734552"/>
+        <c:scaling>
+          <c:orientation val="minMax"/>
+          <c:max val="110"/>
           <c:min val="0"/>
         </c:scaling>
         <c:delete val="0"/>
@@ -2470,7 +2758,7 @@
           <a:p>
             <a:r>
               <a:rPr lang="en-US" dirty="0"/>
-              <a:t>Overview of the Arm port of the evolutionary quantization project: what was built, what was measured, what was learned. Tiers T0-T2 (free) are done; Graviton (T3) and Apple M4 (T4) are the next paid steps.</a:t>
+              <a:t>Overview of the Arm port of the evolutionary quantization project: what was built, what was measured, what was learned. Tiers T0-T3 are done (the Graviton3 run cost about two dollars); the Apple M4 block (T4) is the one remaining paid step.</a:t>
             </a:r>
             <a:endParaRPr lang="en-US" dirty="0"/>
           </a:p>
@@ -2558,7 +2846,7 @@
           <a:p>
             <a:r>
               <a:rPr lang="en-US" dirty="0"/>
-              <a:t>Cross-compiled aarch64 llama.cpp builds run under QEMU user-mode; correctness only. The M4 build uses KleidiAI by default, so Q8_0 accuracy must be measured on the target with KleidiAI on. SME2 could not be tested because QEMU 8.2.2 lacks it.</a:t>
+              <a:t>Measured on an AWS c7g.2xlarge (Graviton3, 8 vCPUs). The stock bars are the build without KleidiAI, which keeps llama.cpp's own optimized Arm path. KleidiAI's Q8_0 loss is 37.5x in KL divergence (0.0283 vs 0.00076). Kernels chosen on Graviton3: Q4_0 SVE, Q8_0 I8MM, as predicted by emulation. The result does not predict the M4, where KleidiAI uses SME2 kernels and the stock path has nothing comparable.</a:t>
             </a:r>
             <a:endParaRPr lang="en-US" dirty="0"/>
           </a:p>
@@ -2646,7 +2934,7 @@
           <a:p>
             <a:r>
               <a:rPr lang="en-US" dirty="0"/>
-              <a:t>The reference is checked against an independent double-precision oracle with the standard rounding-error bound. The NEON kernels are then required to match the reference exactly. The mutation check proves the test can fail.</a:t>
+              <a:t>Roofline: decode tokens per second times the bytes read per token, against the bw_probe read bandwidth at the same thread count. The own kernels (kernels/arm/qdot) are exact but reach 12 GB/s (Q8_0 SDOT) and 6.4 GB/s (Q4_0 SDOT) single-threaded, against 25.7 and 20.7 GB/s for llama.cpp's repacked kernels; likely reasons are listed in the plan as hypotheses, not yet verified.</a:t>
             </a:r>
             <a:endParaRPr lang="en-US" dirty="0"/>
           </a:p>
@@ -2734,7 +3022,7 @@
           <a:p>
             <a:r>
               <a:rPr lang="en-US" dirty="0"/>
-              <a:t>Closing slide: four lessons and the concrete next steps. The limits are stated explicitly so the results are not over-read.</a:t>
+              <a:t>Closing slide: four lessons and the concrete next steps. The limits are stated explicitly so the results are not over-read. Tiers T0-T3 are complete; only the M4 block remains.</a:t>
             </a:r>
             <a:endParaRPr lang="en-US" dirty="0"/>
           </a:p>
@@ -2822,7 +3110,7 @@
           <a:p>
             <a:r>
               <a:rPr lang="en-US" dirty="0"/>
-              <a:t>Mapping of the target role's requirements to what the project demonstrates. Profiling and the real power measurements are the parts still to be done on hardware.</a:t>
+              <a:t>Mapping of the target role's requirements to what the project demonstrates. The roofline is measured on Graviton3; perf counters and the real power measurements are still to be done on hardware.</a:t>
             </a:r>
             <a:endParaRPr lang="en-US" dirty="0"/>
           </a:p>
@@ -3086,7 +3374,7 @@
           <a:p>
             <a:r>
               <a:rPr lang="en-US" dirty="0"/>
-              <a:t>Green badges are complete. The Mac is $40/day with a 24-hour minimum, so every check that does not need M4 hardware was moved to the desktop, the 3080 or emulation.</a:t>
+              <a:t>Green badges are complete (T0-T3). The Graviton3 run found the KleidiAI Q8_0 accuracy loss at full scale. The Mac is $40/day with a 24-hour minimum, so every check that does not need M4 hardware was moved to the desktop, the 3080 or emulation.</a:t>
             </a:r>
             <a:endParaRPr lang="en-US" dirty="0"/>
           </a:p>
@@ -4369,7 +4657,7 @@
                 <a:ea typeface="Calibri" pitchFamily="34" charset="-122"/>
                 <a:cs typeface="Calibri" pitchFamily="34" charset="-120"/>
               </a:rPr>
-              <a:t>Branch mac-m4  |  tiers T0-T2 complete (desktop, RTX 3080, aarch64 emulation)  |  AWS Graviton and Apple M4 runs pending</a:t>
+              <a:t>Branch mac-m4  |  tiers T0-T3 complete (desktop, RTX 3080, aarch64 emulation, AWS Graviton3)  |  Apple M4 run pending</a:t>
             </a:r>
             <a:endParaRPr lang="en-US" sz="1400" dirty="0"/>
           </a:p>
@@ -4484,7 +4772,7 @@
                 <a:ea typeface="+mj-lt" pitchFamily="34" charset="-122"/>
                 <a:cs typeface="+mj-lt" pitchFamily="34" charset="-120"/>
               </a:rPr>
-              <a:t>On Arm, KleidiAI's Q8_0 path costs about 8x the accuracy</a:t>
+              <a:t>On Graviton3, KleidiAI's Q8_0 path costs 37x the accuracy</a:t>
             </a:r>
             <a:endParaRPr lang="en-US" sz="2800" dirty="0"/>
           </a:p>
@@ -4498,7 +4786,7 @@
         </p:nvGraphicFramePr>
         <p:xfrm>
           <a:off x="548640" y="1371600"/>
-          <a:ext cx="6035040" cy="4663440"/>
+          <a:ext cx="5852160" cy="4663440"/>
         </p:xfrm>
         <a:graphic xmlns:a="http://schemas.openxmlformats.org/drawingml/2006/main">
           <a:graphicData uri="http://schemas.openxmlformats.org/drawingml/2006/chart">
@@ -4514,8 +4802,8 @@
         </p:nvSpPr>
         <p:spPr>
           <a:xfrm>
-            <a:off x="6949440" y="1417320"/>
-            <a:ext cx="4663440" cy="1097280"/>
+            <a:off x="6766560" y="1417320"/>
+            <a:ext cx="4846320" cy="1097280"/>
           </a:xfrm>
           <a:prstGeom prst="rect">
             <a:avLst/>
@@ -4539,7 +4827,7 @@
                 <a:ea typeface="Calibri" pitchFamily="34" charset="-122"/>
                 <a:cs typeface="Calibri" pitchFamily="34" charset="-120"/>
               </a:rPr>
-              <a:t>Cause (from the source): KleidiAI re-quantizes each Q8_0 weight row from block-wise scales to one per-row scale. Q4_0 is unaffected.</a:t>
+              <a:t>Cause (from the source): KleidiAI re-quantizes each Q8_0 weight row to a single per-row scale. Q4_0 is unaffected: bit-identical to the stock path.</a:t>
             </a:r>
             <a:endParaRPr lang="en-US" sz="1500" dirty="0"/>
           </a:p>
@@ -4547,14 +4835,14 @@
       </p:sp>
       <p:sp>
         <p:nvSpPr>
-          <p:cNvPr id="5" name="t2 bullets"/>
+          <p:cNvPr id="5" name="t3 bullets"/>
           <p:cNvSpPr txBox="1"/>
           <p:nvPr/>
         </p:nvSpPr>
         <p:spPr>
           <a:xfrm>
-            <a:off x="6949440" y="2560320"/>
-            <a:ext cx="4663440" cy="2194560"/>
+            <a:off x="6766560" y="2560320"/>
+            <a:ext cx="4846320" cy="2286000"/>
           </a:xfrm>
           <a:prstGeom prst="rect">
             <a:avLst/>
@@ -4582,7 +4870,7 @@
                 <a:ea typeface="Calibri" pitchFamily="34" charset="-122"/>
                 <a:cs typeface="Calibri" pitchFamily="34" charset="-120"/>
               </a:rPr>
-              <a:t>Identical 0.0327 on the DOTPROD and I8MM kernels: algorithmic, not an emulator artifact</a:t>
+              <a:t>Against the stock Arm path KleidiAI adds no decode speed (0.94-1.05x) and no Q4_0 prefill; Q8_0 prefill +1.34-1.47x</a:t>
             </a:r>
             <a:endParaRPr lang="en-US" sz="1400" dirty="0"/>
           </a:p>
@@ -4603,7 +4891,7 @@
                 <a:ea typeface="Calibri" pitchFamily="34" charset="-122"/>
                 <a:cs typeface="Calibri" pitchFamily="34" charset="-120"/>
               </a:rPr>
-              <a:t>Q4_0 gives 0.3069 on ggml I8MM, KleidiAI I8MM and KleidiAI SVE alike</a:t>
+              <a:t>The 360M proxy under QEMU showed 8x; Phi-3 on real silicon shows 37x</a:t>
             </a:r>
             <a:endParaRPr lang="en-US" sz="1400" dirty="0"/>
           </a:p>
@@ -4624,28 +4912,7 @@
                 <a:ea typeface="Calibri" pitchFamily="34" charset="-122"/>
                 <a:cs typeface="Calibri" pitchFamily="34" charset="-120"/>
               </a:rPr>
-              <a:t>F16 matches x86 to 1e-6 on every build</a:t>
-            </a:r>
-            <a:endParaRPr lang="en-US" sz="1400" dirty="0"/>
-          </a:p>
-          <a:p>
-            <a:pPr marL="203200" indent="-203200">
-              <a:spcAft>
-                <a:spcPts val="700"/>
-              </a:spcAft>
-              <a:buSzPct val="100000"/>
-              <a:buChar char="•"/>
-            </a:pPr>
-            <a:r>
-              <a:rPr lang="en-US" sz="1400" dirty="0">
-                <a:solidFill>
-                  <a:schemeClr val="tx1"/>
-                </a:solidFill>
-                <a:latin typeface="Calibri" pitchFamily="34" charset="0"/>
-                <a:ea typeface="Calibri" pitchFamily="34" charset="-122"/>
-                <a:cs typeface="Calibri" pitchFamily="34" charset="-120"/>
-              </a:rPr>
-              <a:t>Runtime A/B without rebuilding: --no-repack</a:t>
+              <a:t>Fair baseline matters: --no-repack makes KleidiAI look 2.3x faster</a:t>
             </a:r>
             <a:endParaRPr lang="en-US" sz="1400" dirty="0"/>
           </a:p>
@@ -4659,12 +4926,12 @@
         </p:nvSpPr>
         <p:spPr>
           <a:xfrm>
-            <a:off x="6949440" y="4846320"/>
-            <a:ext cx="4663440" cy="1234440"/>
+            <a:off x="6766560" y="4892040"/>
+            <a:ext cx="4846320" cy="1188720"/>
           </a:xfrm>
           <a:prstGeom prst="roundRect">
             <a:avLst>
-              <a:gd name="adj" fmla="val 5926"/>
+              <a:gd name="adj" fmla="val 6154"/>
             </a:avLst>
           </a:prstGeom>
           <a:solidFill>
@@ -4686,7 +4953,7 @@
         </p:nvSpPr>
         <p:spPr>
           <a:xfrm>
-            <a:off x="7086600" y="5074920"/>
+            <a:off x="6903720" y="5102352"/>
             <a:ext cx="685800" cy="685800"/>
           </a:xfrm>
           <a:prstGeom prst="ellipse">
@@ -4719,7 +4986,7 @@
         </p:blipFill>
         <p:spPr>
           <a:xfrm>
-            <a:off x="7258050" y="5246370"/>
+            <a:off x="7075170" y="5273802"/>
             <a:ext cx="342900" cy="342900"/>
           </a:xfrm>
           <a:prstGeom prst="rect">
@@ -4735,8 +5002,8 @@
         </p:nvSpPr>
         <p:spPr>
           <a:xfrm>
-            <a:off x="7909560" y="4892040"/>
-            <a:ext cx="3611880" cy="1143000"/>
+            <a:off x="7726680" y="4937760"/>
+            <a:ext cx="3794760" cy="1097280"/>
           </a:xfrm>
           <a:prstGeom prst="rect">
             <a:avLst/>
@@ -4874,49 +5141,38 @@
                 <a:ea typeface="+mj-lt" pitchFamily="34" charset="-122"/>
                 <a:cs typeface="+mj-lt" pitchFamily="34" charset="-120"/>
               </a:rPr>
-              <a:t>Kernels: NEON SDOT and SMMLA, bit-exact to a reference</a:t>
+              <a:t>Kernels bit-exact on Graviton3; the roofline shows where speed remains</a:t>
             </a:r>
             <a:endParaRPr lang="en-US" sz="2800" dirty="0"/>
           </a:p>
         </p:txBody>
       </p:sp>
-      <p:sp>
-        <p:nvSpPr>
-          <p:cNvPr id="3" name="kernel card"/>
-          <p:cNvSpPr/>
-          <p:nvPr/>
-        </p:nvSpPr>
-        <p:spPr>
-          <a:xfrm>
-            <a:off x="548640" y="1417320"/>
-            <a:ext cx="5760720" cy="4663440"/>
-          </a:xfrm>
-          <a:prstGeom prst="roundRect">
-            <a:avLst>
-              <a:gd name="adj" fmla="val 1569"/>
-            </a:avLst>
-          </a:prstGeom>
-          <a:solidFill>
-            <a:schemeClr val="bg2"/>
-          </a:solidFill>
-          <a:ln w="12700">
-            <a:solidFill>
-              <a:schemeClr val="bg2"/>
-            </a:solidFill>
-            <a:prstDash val="solid"/>
-          </a:ln>
-        </p:spPr>
-      </p:sp>
-      <p:sp>
-        <p:nvSpPr>
-          <p:cNvPr id="4" name="kernel head"/>
+      <p:graphicFrame>
+        <p:nvGraphicFramePr>
+          <p:cNvPr id="3" name="Chart 0" descr=""/>
+          <p:cNvGraphicFramePr/>
+          <p:nvPr/>
+        </p:nvGraphicFramePr>
+        <p:xfrm>
+          <a:off x="548640" y="1325880"/>
+          <a:ext cx="5486400" cy="2926080"/>
+        </p:xfrm>
+        <a:graphic xmlns:a="http://schemas.openxmlformats.org/drawingml/2006/main">
+          <a:graphicData uri="http://schemas.openxmlformats.org/drawingml/2006/chart">
+            <c:chart xmlns:c="http://schemas.openxmlformats.org/drawingml/2006/chart" r:id="rId1"/>
+          </a:graphicData>
+        </a:graphic>
+      </p:graphicFrame>
+      <p:sp>
+        <p:nvSpPr>
+          <p:cNvPr id="4" name="roof bullets"/>
           <p:cNvSpPr txBox="1"/>
           <p:nvPr/>
         </p:nvSpPr>
         <p:spPr>
           <a:xfrm>
-            <a:off x="777240" y="1554480"/>
-            <a:ext cx="5303520" cy="411480"/>
+            <a:off x="548640" y="4389120"/>
+            <a:ext cx="5486400" cy="1737360"/>
           </a:xfrm>
           <a:prstGeom prst="rect">
             <a:avLst/>
@@ -4925,57 +5181,18 @@
           <a:ln/>
         </p:spPr>
         <p:txBody>
-          <a:bodyPr wrap="square" lIns="0" tIns="0" rIns="0" bIns="0" rtlCol="0" anchor="ctr"/>
-          <a:lstStyle/>
-          <a:p>
-            <a:pPr indent="0" marL="0">
-              <a:buNone/>
-            </a:pPr>
-            <a:r>
-              <a:rPr lang="en-US" sz="1800" b="1" dirty="0">
-                <a:solidFill>
-                  <a:schemeClr val="tx2"/>
-                </a:solidFill>
-                <a:latin typeface="Courier New" pitchFamily="34" charset="0"/>
-                <a:ea typeface="Courier New" pitchFamily="34" charset="-122"/>
-                <a:cs typeface="Courier New" pitchFamily="34" charset="-120"/>
-              </a:rPr>
-              <a:t>kernels/arm/qdot</a:t>
-            </a:r>
-            <a:endParaRPr lang="en-US" sz="1800" dirty="0"/>
-          </a:p>
-        </p:txBody>
-      </p:sp>
-      <p:sp>
-        <p:nvSpPr>
-          <p:cNvPr id="5" name="kernel bullets"/>
-          <p:cNvSpPr txBox="1"/>
-          <p:nvPr/>
-        </p:nvSpPr>
-        <p:spPr>
-          <a:xfrm>
-            <a:off x="777240" y="2057400"/>
-            <a:ext cx="5303520" cy="3931920"/>
-          </a:xfrm>
-          <a:prstGeom prst="rect">
-            <a:avLst/>
-          </a:prstGeom>
-          <a:noFill/>
-          <a:ln/>
-        </p:spPr>
-        <p:txBody>
           <a:bodyPr wrap="square" lIns="0" tIns="0" rIns="0" bIns="0" rtlCol="0" anchor="t"/>
           <a:lstStyle/>
           <a:p>
             <a:pPr marL="203200" indent="-203200">
               <a:spcAft>
-                <a:spcPts val="900"/>
+                <a:spcPts val="500"/>
               </a:spcAft>
               <a:buSzPct val="100000"/>
               <a:buChar char="•"/>
             </a:pPr>
             <a:r>
-              <a:rPr lang="en-US" sz="1500" dirty="0">
+              <a:rPr lang="en-US" sz="1300" dirty="0">
                 <a:solidFill>
                   <a:schemeClr val="tx1"/>
                 </a:solidFill>
@@ -4983,20 +5200,20 @@
                 <a:ea typeface="Calibri" pitchFamily="34" charset="-122"/>
                 <a:cs typeface="Calibri" pitchFamily="34" charset="-120"/>
               </a:rPr>
-              <a:t>Formats the genome selects: Q8_0 x Q8_0 and Q4_0 x Q8_0, in ggml's block layouts</a:t>
-            </a:r>
-            <a:endParaRPr lang="en-US" sz="1500" dirty="0"/>
+              <a:t>Q8_0 decode is on the roof (95%): only moving fewer bytes helps</a:t>
+            </a:r>
+            <a:endParaRPr lang="en-US" sz="1300" dirty="0"/>
           </a:p>
           <a:p>
             <a:pPr marL="203200" indent="-203200">
               <a:spcAft>
-                <a:spcPts val="900"/>
+                <a:spcPts val="500"/>
               </a:spcAft>
               <a:buSzPct val="100000"/>
               <a:buChar char="•"/>
             </a:pPr>
             <a:r>
-              <a:rPr lang="en-US" sz="1500" dirty="0">
+              <a:rPr lang="en-US" sz="1300" dirty="0">
                 <a:solidFill>
                   <a:schemeClr val="tx1"/>
                 </a:solidFill>
@@ -5004,20 +5221,20 @@
                 <a:ea typeface="Calibri" pitchFamily="34" charset="-122"/>
                 <a:cs typeface="Calibri" pitchFamily="34" charset="-120"/>
               </a:rPr>
-              <a:t>Scalar reference, portable (runs on x86 too)</a:t>
-            </a:r>
-            <a:endParaRPr lang="en-US" sz="1500" dirty="0"/>
+              <a:t>Q4_0 reaches 72%: nibble unpacking limits it (up to ~1.3x left)</a:t>
+            </a:r>
+            <a:endParaRPr lang="en-US" sz="1300" dirty="0"/>
           </a:p>
           <a:p>
             <a:pPr marL="203200" indent="-203200">
               <a:spcAft>
-                <a:spcPts val="900"/>
+                <a:spcPts val="500"/>
               </a:spcAft>
               <a:buSzPct val="100000"/>
               <a:buChar char="•"/>
             </a:pPr>
             <a:r>
-              <a:rPr lang="en-US" sz="1500" dirty="0">
+              <a:rPr lang="en-US" sz="1300" dirty="0">
                 <a:solidFill>
                   <a:schemeClr val="tx1"/>
                 </a:solidFill>
@@ -5025,20 +5242,20 @@
                 <a:ea typeface="Calibri" pitchFamily="34" charset="-122"/>
                 <a:cs typeface="Calibri" pitchFamily="34" charset="-120"/>
               </a:rPr>
-              <a:t>NEON + SDOT GEMV for decode</a:t>
-            </a:r>
-            <a:endParaRPr lang="en-US" sz="1500" dirty="0"/>
+              <a:t>F16 has no optimized kernel (48%): a poor baseline that inflates speedups</a:t>
+            </a:r>
+            <a:endParaRPr lang="en-US" sz="1300" dirty="0"/>
           </a:p>
           <a:p>
             <a:pPr marL="203200" indent="-203200">
               <a:spcAft>
-                <a:spcPts val="900"/>
+                <a:spcPts val="500"/>
               </a:spcAft>
               <a:buSzPct val="100000"/>
               <a:buChar char="•"/>
             </a:pPr>
             <a:r>
-              <a:rPr lang="en-US" sz="1500" dirty="0">
+              <a:rPr lang="en-US" sz="1300" dirty="0">
                 <a:solidFill>
                   <a:schemeClr val="tx1"/>
                 </a:solidFill>
@@ -5046,20 +5263,77 @@
                 <a:ea typeface="Calibri" pitchFamily="34" charset="-122"/>
                 <a:cs typeface="Calibri" pitchFamily="34" charset="-120"/>
               </a:rPr>
-              <a:t>NEON + SMMLA 2x2 tile for prefill</a:t>
-            </a:r>
-            <a:endParaRPr lang="en-US" sz="1500" dirty="0"/>
-          </a:p>
-          <a:p>
-            <a:pPr marL="203200" indent="-203200">
-              <a:spcAft>
-                <a:spcPts val="900"/>
-              </a:spcAft>
-              <a:buSzPct val="100000"/>
-              <a:buChar char="•"/>
-            </a:pPr>
-            <a:r>
-              <a:rPr lang="en-US" sz="1500" dirty="0">
+              <a:t>Smaller is faster at decode: Q4_0 = 1.4-1.5x Q8_0 (opposite of the GPU)</a:t>
+            </a:r>
+            <a:endParaRPr lang="en-US" sz="1300" dirty="0"/>
+          </a:p>
+        </p:txBody>
+      </p:sp>
+      <p:sp>
+        <p:nvSpPr>
+          <p:cNvPr id="5" name="stat cases value"/>
+          <p:cNvSpPr txBox="1"/>
+          <p:nvPr/>
+        </p:nvSpPr>
+        <p:spPr>
+          <a:xfrm>
+            <a:off x="6400800" y="1417320"/>
+            <a:ext cx="2560320" cy="685800"/>
+          </a:xfrm>
+          <a:prstGeom prst="rect">
+            <a:avLst/>
+          </a:prstGeom>
+          <a:noFill/>
+          <a:ln/>
+        </p:spPr>
+        <p:txBody>
+          <a:bodyPr wrap="square" lIns="0" tIns="0" rIns="0" bIns="0" rtlCol="0" anchor="b"/>
+          <a:lstStyle/>
+          <a:p>
+            <a:pPr indent="0" marL="0">
+              <a:buNone/>
+            </a:pPr>
+            <a:r>
+              <a:rPr lang="en-US" sz="4000" b="1" dirty="0">
+                <a:solidFill>
+                  <a:srgbClr val="2E9E8A"/>
+                </a:solidFill>
+                <a:latin typeface="Cambria" pitchFamily="34" charset="0"/>
+                <a:ea typeface="Cambria" pitchFamily="34" charset="-122"/>
+                <a:cs typeface="Cambria" pitchFamily="34" charset="-120"/>
+              </a:rPr>
+              <a:t>108</a:t>
+            </a:r>
+            <a:endParaRPr lang="en-US" sz="4000" dirty="0"/>
+          </a:p>
+        </p:txBody>
+      </p:sp>
+      <p:sp>
+        <p:nvSpPr>
+          <p:cNvPr id="6" name="stat cases label"/>
+          <p:cNvSpPr txBox="1"/>
+          <p:nvPr/>
+        </p:nvSpPr>
+        <p:spPr>
+          <a:xfrm>
+            <a:off x="6400800" y="2130552"/>
+            <a:ext cx="2560320" cy="640080"/>
+          </a:xfrm>
+          <a:prstGeom prst="rect">
+            <a:avLst/>
+          </a:prstGeom>
+          <a:noFill/>
+          <a:ln/>
+        </p:spPr>
+        <p:txBody>
+          <a:bodyPr wrap="square" lIns="0" tIns="0" rIns="0" bIns="0" rtlCol="0" anchor="t"/>
+          <a:lstStyle/>
+          <a:p>
+            <a:pPr indent="0" marL="0">
+              <a:buNone/>
+            </a:pPr>
+            <a:r>
+              <a:rPr lang="en-US" sz="1400" dirty="0">
                 <a:solidFill>
                   <a:schemeClr val="tx1"/>
                 </a:solidFill>
@@ -5067,20 +5341,77 @@
                 <a:ea typeface="Calibri" pitchFamily="34" charset="-122"/>
                 <a:cs typeface="Calibri" pitchFamily="34" charset="-120"/>
               </a:rPr>
-              <a:t>Per-function target attributes and runtime dispatch, so one binary carries every path</a:t>
-            </a:r>
-            <a:endParaRPr lang="en-US" sz="1500" dirty="0"/>
-          </a:p>
-          <a:p>
-            <a:pPr marL="203200" indent="-203200">
-              <a:spcAft>
-                <a:spcPts val="900"/>
-              </a:spcAft>
-              <a:buSzPct val="100000"/>
-              <a:buChar char="•"/>
-            </a:pPr>
-            <a:r>
-              <a:rPr lang="en-US" sz="1500" dirty="0">
+              <a:t>cases bit-identical to the reference, on real Graviton3 and under emulation</a:t>
+            </a:r>
+            <a:endParaRPr lang="en-US" sz="1400" dirty="0"/>
+          </a:p>
+        </p:txBody>
+      </p:sp>
+      <p:sp>
+        <p:nvSpPr>
+          <p:cNvPr id="7" name="stat mutation value"/>
+          <p:cNvSpPr txBox="1"/>
+          <p:nvPr/>
+        </p:nvSpPr>
+        <p:spPr>
+          <a:xfrm>
+            <a:off x="9144000" y="1417320"/>
+            <a:ext cx="2468880" cy="685800"/>
+          </a:xfrm>
+          <a:prstGeom prst="rect">
+            <a:avLst/>
+          </a:prstGeom>
+          <a:noFill/>
+          <a:ln/>
+        </p:spPr>
+        <p:txBody>
+          <a:bodyPr wrap="square" lIns="0" tIns="0" rIns="0" bIns="0" rtlCol="0" anchor="b"/>
+          <a:lstStyle/>
+          <a:p>
+            <a:pPr indent="0" marL="0">
+              <a:buNone/>
+            </a:pPr>
+            <a:r>
+              <a:rPr lang="en-US" sz="4000" b="1" dirty="0">
+                <a:solidFill>
+                  <a:srgbClr val="D1495B"/>
+                </a:solidFill>
+                <a:latin typeface="Cambria" pitchFamily="34" charset="0"/>
+                <a:ea typeface="Cambria" pitchFamily="34" charset="-122"/>
+                <a:cs typeface="Cambria" pitchFamily="34" charset="-120"/>
+              </a:rPr>
+              <a:t>1,710</a:t>
+            </a:r>
+            <a:endParaRPr lang="en-US" sz="4000" dirty="0"/>
+          </a:p>
+        </p:txBody>
+      </p:sp>
+      <p:sp>
+        <p:nvSpPr>
+          <p:cNvPr id="8" name="stat mutation label"/>
+          <p:cNvSpPr txBox="1"/>
+          <p:nvPr/>
+        </p:nvSpPr>
+        <p:spPr>
+          <a:xfrm>
+            <a:off x="9144000" y="2130552"/>
+            <a:ext cx="2468880" cy="640080"/>
+          </a:xfrm>
+          <a:prstGeom prst="rect">
+            <a:avLst/>
+          </a:prstGeom>
+          <a:noFill/>
+          <a:ln/>
+        </p:spPr>
+        <p:txBody>
+          <a:bodyPr wrap="square" lIns="0" tIns="0" rIns="0" bIns="0" rtlCol="0" anchor="t"/>
+          <a:lstStyle/>
+          <a:p>
+            <a:pPr indent="0" marL="0">
+              <a:buNone/>
+            </a:pPr>
+            <a:r>
+              <a:rPr lang="en-US" sz="1400" dirty="0">
                 <a:solidFill>
                   <a:schemeClr val="tx1"/>
                 </a:solidFill>
@@ -5088,22 +5419,22 @@
                 <a:ea typeface="Calibri" pitchFamily="34" charset="-122"/>
                 <a:cs typeface="Calibri" pitchFamily="34" charset="-120"/>
               </a:rPr>
-              <a:t>Float accumulation in a fixed block order with contraction off, so results match bit for bit</a:t>
-            </a:r>
-            <a:endParaRPr lang="en-US" sz="1500" dirty="0"/>
-          </a:p>
-        </p:txBody>
-      </p:sp>
-      <p:sp>
-        <p:nvSpPr>
-          <p:cNvPr id="6" name="stat cases value"/>
+              <a:t>failures caught when the nibble offset is deliberately broken</a:t>
+            </a:r>
+            <a:endParaRPr lang="en-US" sz="1400" dirty="0"/>
+          </a:p>
+        </p:txBody>
+      </p:sp>
+      <p:sp>
+        <p:nvSpPr>
+          <p:cNvPr id="9" name="stat kernel speed value"/>
           <p:cNvSpPr txBox="1"/>
           <p:nvPr/>
         </p:nvSpPr>
         <p:spPr>
           <a:xfrm>
-            <a:off x="6675120" y="1417320"/>
-            <a:ext cx="2377440" cy="685800"/>
+            <a:off x="6400800" y="2926080"/>
+            <a:ext cx="5212080" cy="685800"/>
           </a:xfrm>
           <a:prstGeom prst="rect">
             <a:avLst/>
@@ -5121,13 +5452,13 @@
             <a:r>
               <a:rPr lang="en-US" sz="4000" b="1" dirty="0">
                 <a:solidFill>
-                  <a:srgbClr val="2E9E8A"/>
+                  <a:srgbClr val="7B6FB5"/>
                 </a:solidFill>
                 <a:latin typeface="Cambria" pitchFamily="34" charset="0"/>
                 <a:ea typeface="Cambria" pitchFamily="34" charset="-122"/>
                 <a:cs typeface="Cambria" pitchFamily="34" charset="-120"/>
               </a:rPr>
-              <a:t>108</a:t>
+              <a:t>47% / 31%</a:t>
             </a:r>
             <a:endParaRPr lang="en-US" sz="4000" dirty="0"/>
           </a:p>
@@ -5135,14 +5466,14 @@
       </p:sp>
       <p:sp>
         <p:nvSpPr>
-          <p:cNvPr id="7" name="stat cases label"/>
+          <p:cNvPr id="10" name="stat kernel speed label"/>
           <p:cNvSpPr txBox="1"/>
           <p:nvPr/>
         </p:nvSpPr>
         <p:spPr>
           <a:xfrm>
-            <a:off x="6675120" y="2130552"/>
-            <a:ext cx="2377440" cy="640080"/>
+            <a:off x="6400800" y="3639312"/>
+            <a:ext cx="5212080" cy="640080"/>
           </a:xfrm>
           <a:prstGeom prst="rect">
             <a:avLst/>
@@ -5166,7 +5497,7 @@
                 <a:ea typeface="Calibri" pitchFamily="34" charset="-122"/>
                 <a:cs typeface="Calibri" pitchFamily="34" charset="-120"/>
               </a:rPr>
-              <a:t>shape and data cases bit-identical to the reference</a:t>
+              <a:t>of llama.cpp's single-thread bandwidth reached by my SDOT kernels (Q8_0 / Q4_0): correct, not yet fast</a:t>
             </a:r>
             <a:endParaRPr lang="en-US" sz="1400" dirty="0"/>
           </a:p>
@@ -5174,252 +5505,18 @@
       </p:sp>
       <p:sp>
         <p:nvSpPr>
-          <p:cNvPr id="8" name="stat cpus value"/>
-          <p:cNvSpPr txBox="1"/>
-          <p:nvPr/>
-        </p:nvSpPr>
-        <p:spPr>
-          <a:xfrm>
-            <a:off x="9235440" y="1417320"/>
-            <a:ext cx="2377440" cy="685800"/>
-          </a:xfrm>
-          <a:prstGeom prst="rect">
-            <a:avLst/>
-          </a:prstGeom>
-          <a:noFill/>
-          <a:ln/>
-        </p:spPr>
-        <p:txBody>
-          <a:bodyPr wrap="square" lIns="0" tIns="0" rIns="0" bIns="0" rtlCol="0" anchor="b"/>
-          <a:lstStyle/>
-          <a:p>
-            <a:pPr indent="0" marL="0">
-              <a:buNone/>
-            </a:pPr>
-            <a:r>
-              <a:rPr lang="en-US" sz="4000" b="1" dirty="0">
-                <a:solidFill>
-                  <a:srgbClr val="0A7EA4"/>
-                </a:solidFill>
-                <a:latin typeface="Cambria" pitchFamily="34" charset="0"/>
-                <a:ea typeface="Cambria" pitchFamily="34" charset="-122"/>
-                <a:cs typeface="Cambria" pitchFamily="34" charset="-120"/>
-              </a:rPr>
-              <a:t>3</a:t>
-            </a:r>
-            <a:endParaRPr lang="en-US" sz="4000" dirty="0"/>
-          </a:p>
-        </p:txBody>
-      </p:sp>
-      <p:sp>
-        <p:nvSpPr>
-          <p:cNvPr id="9" name="stat cpus label"/>
-          <p:cNvSpPr txBox="1"/>
-          <p:nvPr/>
-        </p:nvSpPr>
-        <p:spPr>
-          <a:xfrm>
-            <a:off x="9235440" y="2130552"/>
-            <a:ext cx="2377440" cy="640080"/>
-          </a:xfrm>
-          <a:prstGeom prst="rect">
-            <a:avLst/>
-          </a:prstGeom>
-          <a:noFill/>
-          <a:ln/>
-        </p:spPr>
-        <p:txBody>
-          <a:bodyPr wrap="square" lIns="0" tIns="0" rIns="0" bIns="0" rtlCol="0" anchor="t"/>
-          <a:lstStyle/>
-          <a:p>
-            <a:pPr indent="0" marL="0">
-              <a:buNone/>
-            </a:pPr>
-            <a:r>
-              <a:rPr lang="en-US" sz="1400" dirty="0">
-                <a:solidFill>
-                  <a:schemeClr val="tx1"/>
-                </a:solidFill>
-                <a:latin typeface="Calibri" pitchFamily="34" charset="0"/>
-                <a:ea typeface="Calibri" pitchFamily="34" charset="-122"/>
-                <a:cs typeface="Calibri" pitchFamily="34" charset="-120"/>
-              </a:rPr>
-              <a:t>emulated CPUs: Neoverse-N1, Neoverse-V1, max</a:t>
-            </a:r>
-            <a:endParaRPr lang="en-US" sz="1400" dirty="0"/>
-          </a:p>
-        </p:txBody>
-      </p:sp>
-      <p:sp>
-        <p:nvSpPr>
-          <p:cNvPr id="10" name="stat mutation value"/>
-          <p:cNvSpPr txBox="1"/>
-          <p:nvPr/>
-        </p:nvSpPr>
-        <p:spPr>
-          <a:xfrm>
-            <a:off x="6675120" y="3063240"/>
-            <a:ext cx="2377440" cy="685800"/>
-          </a:xfrm>
-          <a:prstGeom prst="rect">
-            <a:avLst/>
-          </a:prstGeom>
-          <a:noFill/>
-          <a:ln/>
-        </p:spPr>
-        <p:txBody>
-          <a:bodyPr wrap="square" lIns="0" tIns="0" rIns="0" bIns="0" rtlCol="0" anchor="b"/>
-          <a:lstStyle/>
-          <a:p>
-            <a:pPr indent="0" marL="0">
-              <a:buNone/>
-            </a:pPr>
-            <a:r>
-              <a:rPr lang="en-US" sz="4000" b="1" dirty="0">
-                <a:solidFill>
-                  <a:srgbClr val="D1495B"/>
-                </a:solidFill>
-                <a:latin typeface="Cambria" pitchFamily="34" charset="0"/>
-                <a:ea typeface="Cambria" pitchFamily="34" charset="-122"/>
-                <a:cs typeface="Cambria" pitchFamily="34" charset="-120"/>
-              </a:rPr>
-              <a:t>1,710</a:t>
-            </a:r>
-            <a:endParaRPr lang="en-US" sz="4000" dirty="0"/>
-          </a:p>
-        </p:txBody>
-      </p:sp>
-      <p:sp>
-        <p:nvSpPr>
-          <p:cNvPr id="11" name="stat mutation label"/>
-          <p:cNvSpPr txBox="1"/>
-          <p:nvPr/>
-        </p:nvSpPr>
-        <p:spPr>
-          <a:xfrm>
-            <a:off x="6675120" y="3776472"/>
-            <a:ext cx="2377440" cy="640080"/>
-          </a:xfrm>
-          <a:prstGeom prst="rect">
-            <a:avLst/>
-          </a:prstGeom>
-          <a:noFill/>
-          <a:ln/>
-        </p:spPr>
-        <p:txBody>
-          <a:bodyPr wrap="square" lIns="0" tIns="0" rIns="0" bIns="0" rtlCol="0" anchor="t"/>
-          <a:lstStyle/>
-          <a:p>
-            <a:pPr indent="0" marL="0">
-              <a:buNone/>
-            </a:pPr>
-            <a:r>
-              <a:rPr lang="en-US" sz="1400" dirty="0">
-                <a:solidFill>
-                  <a:schemeClr val="tx1"/>
-                </a:solidFill>
-                <a:latin typeface="Calibri" pitchFamily="34" charset="0"/>
-                <a:ea typeface="Calibri" pitchFamily="34" charset="-122"/>
-                <a:cs typeface="Calibri" pitchFamily="34" charset="-120"/>
-              </a:rPr>
-              <a:t>failures caught when the nibble offset is deliberately broken</a:t>
-            </a:r>
-            <a:endParaRPr lang="en-US" sz="1400" dirty="0"/>
-          </a:p>
-        </p:txBody>
-      </p:sp>
-      <p:sp>
-        <p:nvSpPr>
-          <p:cNvPr id="12" name="stat fp16 value"/>
-          <p:cNvSpPr txBox="1"/>
-          <p:nvPr/>
-        </p:nvSpPr>
-        <p:spPr>
-          <a:xfrm>
-            <a:off x="9235440" y="3063240"/>
-            <a:ext cx="2377440" cy="685800"/>
-          </a:xfrm>
-          <a:prstGeom prst="rect">
-            <a:avLst/>
-          </a:prstGeom>
-          <a:noFill/>
-          <a:ln/>
-        </p:spPr>
-        <p:txBody>
-          <a:bodyPr wrap="square" lIns="0" tIns="0" rIns="0" bIns="0" rtlCol="0" anchor="b"/>
-          <a:lstStyle/>
-          <a:p>
-            <a:pPr indent="0" marL="0">
-              <a:buNone/>
-            </a:pPr>
-            <a:r>
-              <a:rPr lang="en-US" sz="4000" b="1" dirty="0">
-                <a:solidFill>
-                  <a:srgbClr val="7B6FB5"/>
-                </a:solidFill>
-                <a:latin typeface="Cambria" pitchFamily="34" charset="0"/>
-                <a:ea typeface="Cambria" pitchFamily="34" charset="-122"/>
-                <a:cs typeface="Cambria" pitchFamily="34" charset="-120"/>
-              </a:rPr>
-              <a:t>65,536</a:t>
-            </a:r>
-            <a:endParaRPr lang="en-US" sz="4000" dirty="0"/>
-          </a:p>
-        </p:txBody>
-      </p:sp>
-      <p:sp>
-        <p:nvSpPr>
-          <p:cNvPr id="13" name="stat fp16 label"/>
-          <p:cNvSpPr txBox="1"/>
-          <p:nvPr/>
-        </p:nvSpPr>
-        <p:spPr>
-          <a:xfrm>
-            <a:off x="9235440" y="3776472"/>
-            <a:ext cx="2377440" cy="640080"/>
-          </a:xfrm>
-          <a:prstGeom prst="rect">
-            <a:avLst/>
-          </a:prstGeom>
-          <a:noFill/>
-          <a:ln/>
-        </p:spPr>
-        <p:txBody>
-          <a:bodyPr wrap="square" lIns="0" tIns="0" rIns="0" bIns="0" rtlCol="0" anchor="t"/>
-          <a:lstStyle/>
-          <a:p>
-            <a:pPr indent="0" marL="0">
-              <a:buNone/>
-            </a:pPr>
-            <a:r>
-              <a:rPr lang="en-US" sz="1400" dirty="0">
-                <a:solidFill>
-                  <a:schemeClr val="tx1"/>
-                </a:solidFill>
-                <a:latin typeface="Calibri" pitchFamily="34" charset="0"/>
-                <a:ea typeface="Calibri" pitchFamily="34" charset="-122"/>
-                <a:cs typeface="Calibri" pitchFamily="34" charset="-120"/>
-              </a:rPr>
-              <a:t>fp16 values checked against the hardware conversion</a:t>
-            </a:r>
-            <a:endParaRPr lang="en-US" sz="1400" dirty="0"/>
-          </a:p>
-        </p:txBody>
-      </p:sp>
-      <p:sp>
-        <p:nvSpPr>
-          <p:cNvPr id="14" name="kernel next"/>
+          <p:cNvPr id="11" name="kernel next"/>
           <p:cNvSpPr/>
           <p:nvPr/>
         </p:nvSpPr>
         <p:spPr>
           <a:xfrm>
-            <a:off x="6675120" y="4754880"/>
-            <a:ext cx="4937760" cy="1325880"/>
+            <a:off x="6400800" y="4572000"/>
+            <a:ext cx="5212080" cy="1508760"/>
           </a:xfrm>
           <a:prstGeom prst="roundRect">
             <a:avLst>
-              <a:gd name="adj" fmla="val 5517"/>
+              <a:gd name="adj" fmla="val 4848"/>
             </a:avLst>
           </a:prstGeom>
           <a:solidFill>
@@ -5435,14 +5532,14 @@
       </p:sp>
       <p:sp>
         <p:nvSpPr>
-          <p:cNvPr id="15" name="kernel next text"/>
+          <p:cNvPr id="12" name="kernel next text"/>
           <p:cNvSpPr txBox="1"/>
           <p:nvPr/>
         </p:nvSpPr>
         <p:spPr>
           <a:xfrm>
-            <a:off x="6858000" y="4800600"/>
-            <a:ext cx="4572000" cy="1234440"/>
+            <a:off x="6583680" y="4617720"/>
+            <a:ext cx="4846320" cy="1417320"/>
           </a:xfrm>
           <a:prstGeom prst="rect">
             <a:avLst/>
@@ -5466,7 +5563,7 @@
                 <a:ea typeface="Calibri" pitchFamily="34" charset="-122"/>
                 <a:cs typeface="Calibri" pitchFamily="34" charset="-120"/>
               </a:rPr>
-              <a:t>Next on hardware: GB/s against STREAM on Graviton and M4 (roofline), SVE variant, SME2 variant, and a Triton/CUDA counterpart on the 3080.</a:t>
+              <a:t>Next: vector accumulation across blocks, several rows per pass, a repacked layout with SMMLA; then SME2 and a Triton/CUDA counterpart.</a:t>
             </a:r>
             <a:endParaRPr lang="en-US" sz="1400" dirty="0"/>
           </a:p>
@@ -6006,7 +6103,7 @@
                 <a:ea typeface="Calibri" pitchFamily="34" charset="-122"/>
                 <a:cs typeface="Calibri" pitchFamily="34" charset="-120"/>
               </a:rPr>
-              <a:t>KleidiAI's Q8_0 re-quantization and the kernel path change the numbers; measure on the target.</a:t>
+              <a:t>KleidiAI's Q8_0 re-quantization costs 37x accuracy on Phi-3 and adds no decode speed over the stock path.</a:t>
             </a:r>
             <a:endParaRPr lang="en-US" sz="1300" dirty="0"/>
           </a:p>
@@ -6148,7 +6245,7 @@
                 <a:ea typeface="Calibri" pitchFamily="34" charset="-122"/>
                 <a:cs typeface="Calibri" pitchFamily="34" charset="-120"/>
               </a:rPr>
-              <a:t>Emulation and a Graviton dry run keep the 24-hour Mac block for questions only it can answer.</a:t>
+              <a:t>Emulation and a $2 Graviton run found three issues before the 24-hour Mac block.</a:t>
             </a:r>
             <a:endParaRPr lang="en-US" sz="1300" dirty="0"/>
           </a:p>
@@ -6243,7 +6340,7 @@
           <a:p>
             <a:pPr marL="203200" indent="-203200">
               <a:spcAft>
-                <a:spcPts val="1000"/>
+                <a:spcPts val="900"/>
               </a:spcAft>
               <a:buSzPct val="100000"/>
               <a:buChar char="•"/>
@@ -6257,14 +6354,14 @@
                 <a:ea typeface="Calibri" pitchFamily="34" charset="-122"/>
                 <a:cs typeface="Calibri" pitchFamily="34" charset="-120"/>
               </a:rPr>
-              <a:t>T3, Graviton (c7g): KleidiAI on/off accuracy and speed on Phi-3, qdot GB/s, perf counters</a:t>
+              <a:t>T4, Apple M4: selftest gates (KleidiAI vs stock vs SME), thread scan, Pareto runs on two models; judge KleidiAI SME2 against a stock build</a:t>
             </a:r>
             <a:endParaRPr lang="en-US" sz="1400" dirty="0"/>
           </a:p>
           <a:p>
             <a:pPr marL="203200" indent="-203200">
               <a:spcAft>
-                <a:spcPts val="1000"/>
+                <a:spcPts val="900"/>
               </a:spcAft>
               <a:buSzPct val="100000"/>
               <a:buChar char="•"/>
@@ -6278,14 +6375,14 @@
                 <a:ea typeface="Calibri" pitchFamily="34" charset="-122"/>
                 <a:cs typeface="Calibri" pitchFamily="34" charset="-120"/>
               </a:rPr>
-              <a:t>T4, Apple M4: selftest gates (SME path vs --no-repack), thread-count scan, Pareto runs on two models</a:t>
+              <a:t>Replace simulated speed and energy in the searches with measurements; compare the GA with the sensitivity-greedy baseline</a:t>
             </a:r>
             <a:endParaRPr lang="en-US" sz="1400" dirty="0"/>
           </a:p>
           <a:p>
             <a:pPr marL="203200" indent="-203200">
               <a:spcAft>
-                <a:spcPts val="1000"/>
+                <a:spcPts val="900"/>
               </a:spcAft>
               <a:buSzPct val="100000"/>
               <a:buChar char="•"/>
@@ -6299,14 +6396,14 @@
                 <a:ea typeface="Calibri" pitchFamily="34" charset="-122"/>
                 <a:cs typeface="Calibri" pitchFamily="34" charset="-120"/>
               </a:rPr>
-              <a:t>Replace simulated speed and energy with measurements; compare the GA with the sensitivity-greedy baseline</a:t>
+              <a:t>Optimize the Q4_0 kernel toward the memory roof; SME2 and Triton/CUDA variants</a:t>
             </a:r>
             <a:endParaRPr lang="en-US" sz="1400" dirty="0"/>
           </a:p>
           <a:p>
             <a:pPr marL="203200" indent="-203200">
               <a:spcAft>
-                <a:spcPts val="1000"/>
+                <a:spcPts val="900"/>
               </a:spcAft>
               <a:buSzPct val="100000"/>
               <a:buChar char="•"/>
@@ -6320,14 +6417,14 @@
                 <a:ea typeface="Calibri" pitchFamily="34" charset="-122"/>
                 <a:cs typeface="Calibri" pitchFamily="34" charset="-120"/>
               </a:rPr>
-              <a:t>Third model once licence access is granted; SME2 and Triton/CUDA kernel variants</a:t>
+              <a:t>Report the Q8_0 finding upstream; third model once licence access is granted</a:t>
             </a:r>
             <a:endParaRPr lang="en-US" sz="1400" dirty="0"/>
           </a:p>
           <a:p>
             <a:pPr marL="203200" indent="-203200">
               <a:spcAft>
-                <a:spcPts val="1000"/>
+                <a:spcPts val="900"/>
               </a:spcAft>
               <a:buSzPct val="100000"/>
               <a:buChar char="•"/>
@@ -6341,7 +6438,7 @@
                 <a:ea typeface="Calibri" pitchFamily="34" charset="-122"/>
                 <a:cs typeface="Calibri" pitchFamily="34" charset="-120"/>
               </a:rPr>
-              <a:t>Honest limits today: speed and energy in the searches are simulated; SME2 is untested</a:t>
+              <a:t>Honest limits today: search speed and energy are simulated (calibrated to Graviton3, not M4); SME2 untested; no power data yet</a:t>
             </a:r>
             <a:endParaRPr lang="en-US" sz="1400" dirty="0"/>
           </a:p>
@@ -7071,7 +7168,7 @@
                 <a:ea typeface="Calibri" pitchFamily="34" charset="-122"/>
                 <a:cs typeface="Calibri" pitchFamily="34" charset="-120"/>
               </a:rPr>
-              <a:t>Roofline, perf counters and powermetrics planned for the Graviton and M4 runs</a:t>
+              <a:t>Memory roofline measured on Graviton3: Q8_0 decode sits at 95% of the bandwidth roof; perf counters and powermetrics next</a:t>
             </a:r>
             <a:endParaRPr lang="en-US" sz="1500" dirty="0"/>
           </a:p>
@@ -9487,7 +9584,7 @@
                 <a:ea typeface="Calibri" pitchFamily="34" charset="-122"/>
                 <a:cs typeface="Calibri" pitchFamily="34" charset="-120"/>
               </a:rPr>
-              <a:t>Real models, real accuracy, 3 models, dry-run searches</a:t>
+              <a:t>Real models, real accuracy, 2 search models, dry-run searches</a:t>
             </a:r>
             <a:endParaRPr lang="en-US" sz="1400" dirty="0"/>
           </a:p>
@@ -9782,11 +9879,11 @@
             <a:avLst/>
           </a:prstGeom>
           <a:solidFill>
-            <a:schemeClr val="accent2"/>
+            <a:schemeClr val="accent3"/>
           </a:solidFill>
           <a:ln w="12700">
             <a:solidFill>
-              <a:schemeClr val="accent2"/>
+              <a:schemeClr val="accent3"/>
             </a:solidFill>
             <a:prstDash val="solid"/>
           </a:ln>
@@ -9864,7 +9961,7 @@
                 <a:ea typeface="Calibri" pitchFamily="34" charset="-122"/>
                 <a:cs typeface="Calibri" pitchFamily="34" charset="-120"/>
               </a:rPr>
-              <a:t>AWS Graviton</a:t>
+              <a:t>AWS Graviton3</a:t>
             </a:r>
             <a:endParaRPr lang="en-US" sz="1700" dirty="0"/>
           </a:p>
@@ -9903,7 +10000,7 @@
                 <a:ea typeface="Calibri" pitchFamily="34" charset="-122"/>
                 <a:cs typeface="Calibri" pitchFamily="34" charset="-120"/>
               </a:rPr>
-              <a:t>Native Arm Linux: KleidiAI on/off, kernel timing, perf counters</a:t>
+              <a:t>Native Arm Linux: KleidiAI on/off, roofline, kernels on real hardware</a:t>
             </a:r>
             <a:endParaRPr lang="en-US" sz="1400" dirty="0"/>
           </a:p>
@@ -9936,13 +10033,13 @@
             <a:r>
               <a:rPr lang="en-US" sz="1400" b="1" dirty="0">
                 <a:solidFill>
-                  <a:srgbClr val="9A5B00"/>
+                  <a:schemeClr val="accent3"/>
                 </a:solidFill>
                 <a:latin typeface="Calibri" pitchFamily="34" charset="0"/>
                 <a:ea typeface="Calibri" pitchFamily="34" charset="-122"/>
                 <a:cs typeface="Calibri" pitchFamily="34" charset="-120"/>
               </a:rPr>
-              <a:t>cents to dollars</a:t>
+              <a:t>done: about $2</a:t>
             </a:r>
             <a:endParaRPr lang="en-US" sz="1400" dirty="0"/>
           </a:p>

</xml_diff>

<commit_message>
Re-run dry-run searches with the Graviton3-calibrated speed model
- Add --arm-model {generic,graviton3} to the dry-run and front-quality scripts and dryrun_setup
- Track the calibrated results (dryrun_*_pareto_s0_g3.json) and list them in results/README.md
- Plan 19.5: 8B GA now recovers all 9 true front points; Phi-3 front has two regimes with its knee at uniform Q8_0 and fills the whole population
- Deck slide 9: calibrated 8B front, hypervolume ratio 1.000, Phi-3 callout
- Correct the Mac instance type to mac-m4.metal
</commit_message>
<xml_diff>
--- a/presentation/Evol_inference_mac-m4.pptx
+++ b/presentation/Evol_inference_mac-m4.pptx
@@ -118,20 +118,20 @@
   <p:extLst>
     <p:ext uri="{521415D9-36F7-43E2-AB2F-B90AF26B5E84}">
       <p14:sectionLst xmlns:p14="http://schemas.microsoft.com/office/powerpoint/2010/main">
-        <p14:section name="Context" id="{021a97e0-0d89-6f0d-e9f8-8b4c2308b558}">
+        <p14:section name="Context" id="{eba666ec-dce6-525e-cd75-4d764fa2b629}">
           <p14:sldIdLst>
             <p14:sldId id="256"/>
             <p14:sldId id="257"/>
             <p14:sldId id="258"/>
           </p14:sldIdLst>
         </p14:section>
-        <p14:section name="Method" id="{388de985-fb97-518d-2ea3-b6f6ab20488c}">
+        <p14:section name="Method" id="{0da7eaf8-307c-7cdc-4819-7bdaaf902914}">
           <p14:sldIdLst>
             <p14:sldId id="259"/>
             <p14:sldId id="260"/>
           </p14:sldIdLst>
         </p14:section>
-        <p14:section name="Results" id="{54383ae4-e2c6-e9bc-0445-683589727d09}">
+        <p14:section name="Results" id="{836093d2-b888-e47b-40ae-ec8889c0e5aa}">
           <p14:sldIdLst>
             <p14:sldId id="261"/>
             <p14:sldId id="262"/>
@@ -1406,7 +1406,7 @@
                 </a:solidFill>
                 <a:latin typeface="+mn-lt"/>
               </a:rPr>
-              <a:t>Llama-3.1-8B exhaustive front (speed simulated)</a:t>
+              <a:t>Llama-3.1-8B: exhaustive Pareto front</a:t>
             </a:r>
           </a:p>
         </c:rich>
@@ -1510,28 +1510,28 @@
                   <c:v>0</c:v>
                 </c:pt>
                 <c:pt idx="1">
-                  <c:v>5.2</c:v>
+                  <c:v>3.6</c:v>
                 </c:pt>
                 <c:pt idx="2">
-                  <c:v>10.9</c:v>
+                  <c:v>7.6</c:v>
                 </c:pt>
                 <c:pt idx="3">
-                  <c:v>17.2</c:v>
+                  <c:v>11.8</c:v>
                 </c:pt>
                 <c:pt idx="4">
-                  <c:v>24.4</c:v>
+                  <c:v>16.4</c:v>
                 </c:pt>
                 <c:pt idx="5">
-                  <c:v>32.5</c:v>
+                  <c:v>21.3</c:v>
                 </c:pt>
                 <c:pt idx="6">
-                  <c:v>41.7</c:v>
+                  <c:v>26.7</c:v>
                 </c:pt>
                 <c:pt idx="7">
-                  <c:v>52.2</c:v>
+                  <c:v>32.7</c:v>
                 </c:pt>
                 <c:pt idx="8">
-                  <c:v>64.5</c:v>
+                  <c:v>39.2</c:v>
                 </c:pt>
               </c:numCache>
             </c:numRef>
@@ -1673,7 +1673,7 @@
                     </a:solidFill>
                     <a:latin typeface="+mn-lt"/>
                   </a:rPr>
-                  <a:t>simulated decode gain (%)</a:t>
+                  <a:t>simulated decode gain vs Q8_0 (%, Graviton3-calibrated)</a:t>
                 </a:r>
               </a:p>
             </c:rich>
@@ -3726,7 +3726,7 @@
           <a:p>
             <a:r>
               <a:rPr lang="en-US" dirty="0"/>
-              <a:t>All 256 genomes of the 8B model were measured (real KL-divergence accuracy), giving the exact Pareto front. Speed and energy in these dry runs come from a simulated Arm model driven by real tensor sizes and are not Arm measurements.</a:t>
+              <a:t>All 256 genomes of the 8B model were measured (real KL-divergence accuracy), giving the exact Pareto front. Speed comes from a simulated Arm model driven by real tensor sizes and calibrated to the measured Graviton3 Phi-3 run (F16 decode reaches 48% of the memory roof, Q8_0 95%, Q4_0 72%); it is applied to the 8B model as an assumption. Energy is still a placeholder and is not shown. None of this is an Arm measurement of these searches.</a:t>
             </a:r>
             <a:endParaRPr lang="en-US" dirty="0"/>
           </a:p>
@@ -12777,7 +12777,7 @@
                 <a:ea typeface="Cambria" pitchFamily="34" charset="-122"/>
                 <a:cs typeface="Cambria" pitchFamily="34" charset="-120"/>
               </a:rPr>
-              <a:t>0.9999</a:t>
+              <a:t>1.000</a:t>
             </a:r>
             <a:endParaRPr lang="en-US" sz="4000" dirty="0"/>
           </a:p>
@@ -12816,7 +12816,7 @@
                 <a:ea typeface="Calibri" pitchFamily="34" charset="-122"/>
                 <a:cs typeface="Calibri" pitchFamily="34" charset="-120"/>
               </a:rPr>
-              <a:t>GA hypervolume ratio vs the exhaustive front (8 of 9 points)</a:t>
+              <a:t>GA hypervolume ratio vs the exhaustive front (9 of 9 points)</a:t>
             </a:r>
             <a:endParaRPr lang="en-US" sz="1400" dirty="0"/>
           </a:p>
@@ -13003,7 +13003,7 @@
                 <a:ea typeface="Calibri" pitchFamily="34" charset="-122"/>
                 <a:cs typeface="Calibri" pitchFamily="34" charset="-120"/>
               </a:rPr>
-              <a:t>With additive objectives the front is the sensitivity ordering, so the GA is not needed for this model</a:t>
+              <a:t>With additive objectives the front is the sensitivity ordering: the GA is not needed here; its value must come from interactions, tested on measured Arm data</a:t>
             </a:r>
             <a:endParaRPr lang="en-US" sz="1400" dirty="0"/>
           </a:p>
@@ -13045,7 +13045,7 @@
                 <a:ea typeface="Calibri" pitchFamily="34" charset="-122"/>
                 <a:cs typeface="Calibri" pitchFamily="34" charset="-120"/>
               </a:rPr>
-              <a:t>The GA's value must come from interactions the table cannot see: next, on measured Arm data</a:t>
+              <a:t>Phi-3: Q8_0 is +261% decode vs F16 for 0.07% accuracy; Q4_0 then adds only +41% for 6.8%</a:t>
             </a:r>
             <a:endParaRPr lang="en-US" sz="1400" dirty="0"/>
           </a:p>

</xml_diff>

<commit_message>
Update the deck with the Graviton rehearsal findings
- add slides: measured cost per evaluation and 24 h projection, rehearsal problems and the reduced Mac design
- refresh strategy, calibrated-model, lessons and next-steps slides (Mac cost about 30 USD)
</commit_message>
<xml_diff>
--- a/presentation/Evol_inference_mac-m4.pptx
+++ b/presentation/Evol_inference_mac-m4.pptx
@@ -17,9 +17,11 @@
     <p:sldId id="265" r:id="rId11"/>
     <p:sldId id="266" r:id="rId12"/>
     <p:sldId id="267" r:id="rId13"/>
+    <p:sldId id="268" r:id="rId14"/>
+    <p:sldId id="269" r:id="rId15"/>
   </p:sldIdLst>
   <p:notesMasterIdLst>
-    <p:notesMasterId r:id="rId14"/>
+    <p:notesMasterId r:id="rId16"/>
   </p:notesMasterIdLst>
   <p:sldSz cx="12192000" cy="6858000"/>
   <p:notesSz cx="6858000" cy="12192000"/>
@@ -118,20 +120,20 @@
   <p:extLst>
     <p:ext uri="{521415D9-36F7-43E2-AB2F-B90AF26B5E84}">
       <p14:sectionLst xmlns:p14="http://schemas.microsoft.com/office/powerpoint/2010/main">
-        <p14:section name="Context" id="{eba666ec-dce6-525e-cd75-4d764fa2b629}">
+        <p14:section name="Context" id="{f71a51bf-778a-ec10-c4ab-0f112a588009}">
           <p14:sldIdLst>
             <p14:sldId id="256"/>
             <p14:sldId id="257"/>
             <p14:sldId id="258"/>
           </p14:sldIdLst>
         </p14:section>
-        <p14:section name="Method" id="{0da7eaf8-307c-7cdc-4819-7bdaaf902914}">
+        <p14:section name="Method" id="{6cba26fb-a3ca-3b55-1d1a-062a7181758e}">
           <p14:sldIdLst>
             <p14:sldId id="259"/>
             <p14:sldId id="260"/>
           </p14:sldIdLst>
         </p14:section>
-        <p14:section name="Results" id="{836093d2-b888-e47b-40ae-ec8889c0e5aa}">
+        <p14:section name="Results" id="{cad99c3f-944d-86fc-aa4d-6a597b70ee21}">
           <p14:sldIdLst>
             <p14:sldId id="261"/>
             <p14:sldId id="262"/>
@@ -140,6 +142,8 @@
             <p14:sldId id="265"/>
             <p14:sldId id="266"/>
             <p14:sldId id="267"/>
+            <p14:sldId id="268"/>
+            <p14:sldId id="269"/>
           </p14:sldIdLst>
         </p14:section>
       </p14:sectionLst>
@@ -1673,7 +1677,7 @@
                     </a:solidFill>
                     <a:latin typeface="+mn-lt"/>
                   </a:rPr>
-                  <a:t>simulated decode gain vs Q8_0 (%, Graviton3-calibrated)</a:t>
+                  <a:t>simulated decode gain vs Q8_0 (%)</a:t>
                 </a:r>
               </a:p>
             </c:rich>
@@ -2363,6 +2367,370 @@
 </c:chartSpace>
 </file>
 
+<file path=ppt/charts/chart7.xml><?xml version="1.0" encoding="utf-8"?>
+<c:chartSpace xmlns:c="http://schemas.openxmlformats.org/drawingml/2006/chart" xmlns:a="http://schemas.openxmlformats.org/drawingml/2006/main" xmlns:r="http://schemas.openxmlformats.org/officeDocument/2006/relationships">
+  <c:date1904 val="0"/>
+  <c:roundedCorners val="1"/>
+  <c:chart>
+    <c:title>
+      <c:tx>
+        <c:rich>
+          <a:bodyPr/>
+          <a:lstStyle/>
+          <a:p>
+            <a:pPr>
+              <a:defRPr sz="1400" b="0" i="0" u="none" strike="noStrike">
+                <a:solidFill>
+                  <a:srgbClr val="0B3C4F"/>
+                </a:solidFill>
+                <a:latin typeface="+mn-lt"/>
+              </a:defRPr>
+            </a:pPr>
+            <a:r>
+              <a:rPr sz="1400" b="0" i="0" u="none" strike="noStrike">
+                <a:solidFill>
+                  <a:srgbClr val="0B3C4F"/>
+                </a:solidFill>
+                <a:latin typeface="+mn-lt"/>
+              </a:rPr>
+              <a:t>Seconds per genome and configuration (Phi-3, c7g.2xlarge)</a:t>
+            </a:r>
+          </a:p>
+        </c:rich>
+      </c:tx>
+      <c:layout/>
+      <c:overlay val="0"/>
+    </c:title>
+    <c:autoTitleDeleted val="0"/>
+    <c:plotArea>
+      <c:layout/>
+      <c:barChart>
+        <c:barDir val="col"/>
+        <c:grouping val="stacked"/>
+        <c:varyColors val="0"/>
+        <c:ser>
+          <c:idx val="0"/>
+          <c:order val="0"/>
+          <c:tx>
+            <c:strRef>
+              <c:f>Sheet1!$B$1</c:f>
+              <c:strCache>
+                <c:ptCount val="1"/>
+                <c:pt idx="0">
+                  <c:v>KL-divergence run (accuracy)</c:v>
+                </c:pt>
+              </c:strCache>
+            </c:strRef>
+          </c:tx>
+          <c:spPr>
+            <a:solidFill>
+              <a:srgbClr val="0A7EA4"/>
+            </a:solidFill>
+            <a:effectLst/>
+          </c:spPr>
+          <c:invertIfNegative val="0"/>
+          <c:dLbls>
+            <c:numFmt formatCode="0" sourceLinked="0"/>
+            <c:txPr>
+              <a:bodyPr/>
+              <a:lstStyle/>
+              <a:p>
+                <a:pPr>
+                  <a:defRPr b="0" i="0" strike="noStrike" sz="1100" u="none">
+                    <a:solidFill>
+                      <a:srgbClr val="FFFFFF"/>
+                    </a:solidFill>
+                    <a:latin typeface="+mn-lt"/>
+                  </a:defRPr>
+                </a:pPr>
+              </a:p>
+            </c:txPr>
+            <c:dLblPos val="ctr"/>
+            <c:showLegendKey val="0"/>
+            <c:showVal val="1"/>
+            <c:showCatName val="0"/>
+            <c:showSerName val="0"/>
+            <c:showPercent val="0"/>
+            <c:showBubbleSize val="0"/>
+            <c:showLeaderLines val="0"/>
+          </c:dLbls>
+          <c:cat>
+            <c:multiLvlStrRef>
+              <c:f>Sheet1!$A$2:$A$3</c:f>
+              <c:multiLvlStrCache>
+                <c:ptCount val="2"/>
+                <c:lvl>
+                  <c:pt idx="0">
+                    <c:v>stock</c:v>
+                  </c:pt>
+                  <c:pt idx="1">
+                    <c:v>KleidiAI</c:v>
+                  </c:pt>
+                </c:lvl>
+              </c:multiLvlStrCache>
+            </c:multiLvlStrRef>
+          </c:cat>
+          <c:val>
+            <c:numRef>
+              <c:f>Sheet1!$B$2:$B$3</c:f>
+              <c:numCache>
+                <c:formatCode>General</c:formatCode>
+                <c:ptCount val="2"/>
+                <c:pt idx="0">
+                  <c:v>56</c:v>
+                </c:pt>
+                <c:pt idx="1">
+                  <c:v>63</c:v>
+                </c:pt>
+              </c:numCache>
+            </c:numRef>
+          </c:val>
+        </c:ser>
+        <c:ser>
+          <c:idx val="1"/>
+          <c:order val="1"/>
+          <c:tx>
+            <c:strRef>
+              <c:f>Sheet1!$C$1</c:f>
+              <c:strCache>
+                <c:ptCount val="1"/>
+                <c:pt idx="0">
+                  <c:v>speed and energy run</c:v>
+                </c:pt>
+              </c:strCache>
+            </c:strRef>
+          </c:tx>
+          <c:spPr>
+            <a:solidFill>
+              <a:srgbClr val="F2A541"/>
+            </a:solidFill>
+            <a:effectLst/>
+          </c:spPr>
+          <c:invertIfNegative val="0"/>
+          <c:dLbls>
+            <c:numFmt formatCode="0" sourceLinked="0"/>
+            <c:txPr>
+              <a:bodyPr/>
+              <a:lstStyle/>
+              <a:p>
+                <a:pPr>
+                  <a:defRPr b="0" i="0" strike="noStrike" sz="1100" u="none">
+                    <a:solidFill>
+                      <a:srgbClr val="FFFFFF"/>
+                    </a:solidFill>
+                    <a:latin typeface="+mn-lt"/>
+                  </a:defRPr>
+                </a:pPr>
+              </a:p>
+            </c:txPr>
+            <c:dLblPos val="ctr"/>
+            <c:showLegendKey val="0"/>
+            <c:showVal val="1"/>
+            <c:showCatName val="0"/>
+            <c:showSerName val="0"/>
+            <c:showPercent val="0"/>
+            <c:showBubbleSize val="0"/>
+            <c:showLeaderLines val="0"/>
+          </c:dLbls>
+          <c:cat>
+            <c:multiLvlStrRef>
+              <c:f>Sheet1!$A$2:$A$3</c:f>
+              <c:multiLvlStrCache>
+                <c:ptCount val="2"/>
+                <c:lvl>
+                  <c:pt idx="0">
+                    <c:v>stock</c:v>
+                  </c:pt>
+                  <c:pt idx="1">
+                    <c:v>KleidiAI</c:v>
+                  </c:pt>
+                </c:lvl>
+              </c:multiLvlStrCache>
+            </c:multiLvlStrRef>
+          </c:cat>
+          <c:val>
+            <c:numRef>
+              <c:f>Sheet1!$C$2:$C$3</c:f>
+              <c:numCache>
+                <c:formatCode>General</c:formatCode>
+                <c:ptCount val="2"/>
+                <c:pt idx="0">
+                  <c:v>32</c:v>
+                </c:pt>
+                <c:pt idx="1">
+                  <c:v>50</c:v>
+                </c:pt>
+              </c:numCache>
+            </c:numRef>
+          </c:val>
+        </c:ser>
+        <c:dLbls>
+          <c:numFmt formatCode="0" sourceLinked="0"/>
+          <c:txPr>
+            <a:bodyPr/>
+            <a:lstStyle/>
+            <a:p>
+              <a:pPr>
+                <a:defRPr b="0" i="0" strike="noStrike" sz="1100" u="none">
+                  <a:solidFill>
+                    <a:srgbClr val="FFFFFF"/>
+                  </a:solidFill>
+                  <a:latin typeface="+mn-lt"/>
+                </a:defRPr>
+              </a:pPr>
+            </a:p>
+          </c:txPr>
+          <c:dLblPos val="ctr"/>
+          <c:showLegendKey val="0"/>
+          <c:showVal val="1"/>
+          <c:showCatName val="0"/>
+          <c:showSerName val="0"/>
+          <c:showPercent val="0"/>
+          <c:showBubbleSize val="0"/>
+          <c:showLeaderLines val="0"/>
+        </c:dLbls>
+        <c:gapWidth val="70"/>
+        <c:overlap val="100"/>
+        <c:axId val="2094734554"/>
+        <c:axId val="2094734552"/>
+        <c:axId val="2094734556"/>
+      </c:barChart>
+      <c:catAx>
+        <c:axId val="2094734554"/>
+        <c:scaling>
+          <c:orientation val="minMax"/>
+        </c:scaling>
+        <c:delete val="0"/>
+        <c:axPos val="b"/>
+        <c:numFmt formatCode="General" sourceLinked="1"/>
+        <c:majorTickMark val="out"/>
+        <c:minorTickMark val="none"/>
+        <c:tickLblPos val="low"/>
+        <c:spPr>
+          <a:ln w="12700" cap="flat">
+            <a:solidFill>
+              <a:srgbClr val="888888"/>
+            </a:solidFill>
+            <a:prstDash val="solid"/>
+            <a:round/>
+          </a:ln>
+        </c:spPr>
+        <c:txPr>
+          <a:bodyPr/>
+          <a:lstStyle/>
+          <a:p>
+            <a:pPr>
+              <a:defRPr sz="1200" b="0" i="0" u="none" strike="noStrike">
+                <a:solidFill>
+                  <a:srgbClr val="10212B"/>
+                </a:solidFill>
+                <a:latin typeface="+mn-lt"/>
+              </a:defRPr>
+            </a:pPr>
+            <a:endParaRPr lang="en-US"/>
+          </a:p>
+        </c:txPr>
+        <c:crossAx val="2094734552"/>
+        <c:crosses val="autoZero"/>
+        <c:auto val="1"/>
+        <c:lblAlgn val="ctr"/>
+        <c:noMultiLvlLbl val="1"/>
+      </c:catAx>
+      <c:valAx>
+        <c:axId val="2094734552"/>
+        <c:scaling>
+          <c:orientation val="minMax"/>
+          <c:min val="0"/>
+        </c:scaling>
+        <c:delete val="0"/>
+        <c:axPos val="l"/>
+        <c:majorGridlines>
+          <c:spPr>
+            <a:ln w="9525" cap="flat">
+              <a:solidFill>
+                <a:srgbClr val="D5DEE4"/>
+              </a:solidFill>
+              <a:prstDash val="solid"/>
+              <a:round/>
+            </a:ln>
+          </c:spPr>
+        </c:majorGridlines>
+        <c:numFmt formatCode="General" sourceLinked="0"/>
+        <c:majorTickMark val="out"/>
+        <c:minorTickMark val="none"/>
+        <c:tickLblPos val="nextTo"/>
+        <c:spPr>
+          <a:ln w="12700" cap="flat">
+            <a:solidFill>
+              <a:srgbClr val="888888"/>
+            </a:solidFill>
+            <a:prstDash val="solid"/>
+            <a:round/>
+          </a:ln>
+        </c:spPr>
+        <c:txPr>
+          <a:bodyPr/>
+          <a:lstStyle/>
+          <a:p>
+            <a:pPr>
+              <a:defRPr sz="1100" b="0" i="0" u="none" strike="noStrike">
+                <a:solidFill>
+                  <a:srgbClr val="6C7A89"/>
+                </a:solidFill>
+                <a:latin typeface="+mn-lt"/>
+              </a:defRPr>
+            </a:pPr>
+            <a:endParaRPr lang="en-US"/>
+          </a:p>
+        </c:txPr>
+        <c:crossAx val="2094734554"/>
+        <c:crosses val="autoZero"/>
+        <c:crossBetween val="between"/>
+      </c:valAx>
+      <c:spPr>
+        <a:noFill/>
+        <a:ln>
+          <a:noFill/>
+        </a:ln>
+        <a:effectLst/>
+      </c:spPr>
+    </c:plotArea>
+    <c:legend>
+      <c:legendPos val="b"/>
+      <c:overlay val="0"/>
+      <c:txPr>
+        <a:bodyPr/>
+        <a:lstStyle/>
+        <a:p>
+          <a:pPr>
+            <a:defRPr sz="1200">
+              <a:solidFill>
+                <a:srgbClr val="10212B"/>
+              </a:solidFill>
+              <a:latin typeface="+mn-lt"/>
+              <a:cs typeface="+mn-lt"/>
+            </a:defRPr>
+          </a:pPr>
+          <a:endParaRPr lang="en-US"/>
+        </a:p>
+      </c:txPr>
+    </c:legend>
+    <c:plotVisOnly val="1"/>
+    <c:dispBlanksAs val="span"/>
+  </c:chart>
+  <c:spPr>
+    <a:noFill/>
+    <a:ln>
+      <a:noFill/>
+    </a:ln>
+    <a:effectLst/>
+  </c:spPr>
+  <c:externalData r:id="rId1">
+    <c:autoUpdate val="0"/>
+  </c:externalData>
+</c:chartSpace>
+</file>
+
 <file path=ppt/notesMasters/notesMaster1.xml><?xml version="1.0" encoding="utf-8"?>
 <p:notesMaster xmlns:a="http://schemas.openxmlformats.org/drawingml/2006/main" xmlns:r="http://schemas.openxmlformats.org/officeDocument/2006/relationships" xmlns:p="http://schemas.openxmlformats.org/presentationml/2006/main">
   <p:cSld>
@@ -3022,7 +3390,7 @@
           <a:p>
             <a:r>
               <a:rPr lang="en-US" dirty="0"/>
-              <a:t>Closing slide: four lessons and the concrete next steps. The limits are stated explicitly so the results are not over-read. Tiers T0-T3 are complete; only the M4 block remains.</a:t>
+              <a:t>Nine genomes were measured in two configurations on a c7g.2xlarge with the mock energy meter, so energy is not a measurement. Per-evaluation cost: 88 s stock and 113 s KleidiAI, split between the 2048-token KL-divergence run and the llama-bench speed run. The 8B model is scaled by weight bytes (2.1x), an assumption the optional 8B rehearsal would replace. Full coverage of both models in both configurations does not fit one 24 hour block unless the Mac is about 3x faster than Graviton3, so the default design measures the shipped configuration in full and the baseline for 12 genomes.</a:t>
             </a:r>
             <a:endParaRPr lang="en-US" dirty="0"/>
           </a:p>
@@ -3046,6 +3414,182 @@
             <a:fld id="{F7021451-1387-4CA6-816F-3879F97B5CBC}" type="slidenum">
               <a:rPr lang="en-US"/>
               <a:t>12</a:t>
+            </a:fld>
+            <a:endParaRPr lang="en-US"/>
+          </a:p>
+        </p:txBody>
+      </p:sp>
+    </p:spTree>
+    <p:extLst>
+      <p:ext uri="{BB962C8B-B14F-4D97-AF65-F5344CB8AC3E}">
+        <p14:creationId xmlns:p14="http://schemas.microsoft.com/office/powerpoint/2010/main" val="1024086991"/>
+      </p:ext>
+    </p:extLst>
+  </p:cSld>
+  <p:clrMapOvr>
+    <a:masterClrMapping/>
+  </p:clrMapOvr>
+</p:notes>
+</file>
+
+<file path=ppt/notesSlides/notesSlide13.xml><?xml version="1.0" encoding="utf-8"?>
+<p:notes xmlns:a="http://schemas.openxmlformats.org/drawingml/2006/main" xmlns:r="http://schemas.openxmlformats.org/officeDocument/2006/relationships" xmlns:p="http://schemas.openxmlformats.org/presentationml/2006/main">
+  <p:cSld>
+    <p:spTree>
+      <p:nvGrpSpPr>
+        <p:cNvPr id="1" name=""/>
+        <p:cNvGrpSpPr/>
+        <p:nvPr/>
+      </p:nvGrpSpPr>
+      <p:grpSpPr>
+        <a:xfrm>
+          <a:off x="0" y="0"/>
+          <a:ext cx="0" cy="0"/>
+          <a:chOff x="0" y="0"/>
+          <a:chExt cx="0" cy="0"/>
+        </a:xfrm>
+      </p:grpSpPr>
+      <p:sp>
+        <p:nvSpPr>
+          <p:cNvPr id="2" name="Slide Image Placeholder 1"/>
+          <p:cNvSpPr>
+            <a:spLocks noGrp="1" noRot="1" noChangeAspect="1"/>
+          </p:cNvSpPr>
+          <p:nvPr>
+            <p:ph type="sldImg"/>
+          </p:nvPr>
+        </p:nvSpPr>
+        <p:spPr/>
+      </p:sp>
+      <p:sp>
+        <p:nvSpPr>
+          <p:cNvPr id="3" name="Notes Placeholder 2"/>
+          <p:cNvSpPr>
+            <a:spLocks noGrp="1"/>
+          </p:cNvSpPr>
+          <p:nvPr>
+            <p:ph type="body" idx="1"/>
+          </p:nvPr>
+        </p:nvSpPr>
+        <p:spPr/>
+        <p:txBody>
+          <a:bodyPr/>
+          <a:lstStyle/>
+          <a:p>
+            <a:r>
+              <a:rPr lang="en-US" dirty="0"/>
+              <a:t>All five were found with cheap tiers, each would have cost hours of a 24 hour paid block. The selftest gate worked as designed in the first case: it stopped the queue on a failed check instead of letting the table job fail hours in. The unit tests with synthetic tables had not caught the missing-baseline case; the desktop rehearsal with real binaries did.</a:t>
+            </a:r>
+            <a:endParaRPr lang="en-US" dirty="0"/>
+          </a:p>
+        </p:txBody>
+      </p:sp>
+      <p:sp>
+        <p:nvSpPr>
+          <p:cNvPr id="4" name="Slide Number Placeholder 3"/>
+          <p:cNvSpPr>
+            <a:spLocks noGrp="1"/>
+          </p:cNvSpPr>
+          <p:nvPr>
+            <p:ph type="sldNum" sz="quarter" idx="10"/>
+          </p:nvPr>
+        </p:nvSpPr>
+        <p:spPr/>
+        <p:txBody>
+          <a:bodyPr/>
+          <a:lstStyle/>
+          <a:p>
+            <a:fld id="{F7021451-1387-4CA6-816F-3879F97B5CBC}" type="slidenum">
+              <a:rPr lang="en-US"/>
+              <a:t>13</a:t>
+            </a:fld>
+            <a:endParaRPr lang="en-US"/>
+          </a:p>
+        </p:txBody>
+      </p:sp>
+    </p:spTree>
+    <p:extLst>
+      <p:ext uri="{BB962C8B-B14F-4D97-AF65-F5344CB8AC3E}">
+        <p14:creationId xmlns:p14="http://schemas.microsoft.com/office/powerpoint/2010/main" val="1024086991"/>
+      </p:ext>
+    </p:extLst>
+  </p:cSld>
+  <p:clrMapOvr>
+    <a:masterClrMapping/>
+  </p:clrMapOvr>
+</p:notes>
+</file>
+
+<file path=ppt/notesSlides/notesSlide14.xml><?xml version="1.0" encoding="utf-8"?>
+<p:notes xmlns:a="http://schemas.openxmlformats.org/drawingml/2006/main" xmlns:r="http://schemas.openxmlformats.org/officeDocument/2006/relationships" xmlns:p="http://schemas.openxmlformats.org/presentationml/2006/main">
+  <p:cSld>
+    <p:spTree>
+      <p:nvGrpSpPr>
+        <p:cNvPr id="1" name=""/>
+        <p:cNvGrpSpPr/>
+        <p:nvPr/>
+      </p:nvGrpSpPr>
+      <p:grpSpPr>
+        <a:xfrm>
+          <a:off x="0" y="0"/>
+          <a:ext cx="0" cy="0"/>
+          <a:chOff x="0" y="0"/>
+          <a:chExt cx="0" cy="0"/>
+        </a:xfrm>
+      </p:grpSpPr>
+      <p:sp>
+        <p:nvSpPr>
+          <p:cNvPr id="2" name="Slide Image Placeholder 1"/>
+          <p:cNvSpPr>
+            <a:spLocks noGrp="1" noRot="1" noChangeAspect="1"/>
+          </p:cNvSpPr>
+          <p:nvPr>
+            <p:ph type="sldImg"/>
+          </p:nvPr>
+        </p:nvSpPr>
+        <p:spPr/>
+      </p:sp>
+      <p:sp>
+        <p:nvSpPr>
+          <p:cNvPr id="3" name="Notes Placeholder 2"/>
+          <p:cNvSpPr>
+            <a:spLocks noGrp="1"/>
+          </p:cNvSpPr>
+          <p:nvPr>
+            <p:ph type="body" idx="1"/>
+          </p:nvPr>
+        </p:nvSpPr>
+        <p:spPr/>
+        <p:txBody>
+          <a:bodyPr/>
+          <a:lstStyle/>
+          <a:p>
+            <a:r>
+              <a:rPr lang="en-US" dirty="0"/>
+              <a:t>Closing slide: four lessons and the concrete next steps. The limits are stated explicitly so the results are not over-read. Tiers T0-T3 are complete; only the M4 block remains, and the AWS quota request for it is open.</a:t>
+            </a:r>
+            <a:endParaRPr lang="en-US" dirty="0"/>
+          </a:p>
+        </p:txBody>
+      </p:sp>
+      <p:sp>
+        <p:nvSpPr>
+          <p:cNvPr id="4" name="Slide Number Placeholder 3"/>
+          <p:cNvSpPr>
+            <a:spLocks noGrp="1"/>
+          </p:cNvSpPr>
+          <p:nvPr>
+            <p:ph type="sldNum" sz="quarter" idx="10"/>
+          </p:nvPr>
+        </p:nvSpPr>
+        <p:spPr/>
+        <p:txBody>
+          <a:bodyPr/>
+          <a:lstStyle/>
+          <a:p>
+            <a:fld id="{F7021451-1387-4CA6-816F-3879F97B5CBC}" type="slidenum">
+              <a:rPr lang="en-US"/>
+              <a:t>14</a:t>
             </a:fld>
             <a:endParaRPr lang="en-US"/>
           </a:p>
@@ -3374,7 +3918,7 @@
           <a:p>
             <a:r>
               <a:rPr lang="en-US" dirty="0"/>
-              <a:t>Green badges are complete (T0-T3). The Graviton3 run found the KleidiAI Q8_0 accuracy loss at full scale. The Mac is $40/day with a 24-hour minimum, so every check that does not need M4 hardware was moved to the desktop, the 3080 or emulation.</a:t>
+              <a:t>Green badges are complete (T0-T3). The Graviton3 run found the KleidiAI Q8_0 accuracy loss at full scale. The Mac costs about $30 (1.23 USD/h) with a 24-hour minimum, so every check that does not need M4 hardware was moved to the desktop, the 3080 or emulation.</a:t>
             </a:r>
             <a:endParaRPr lang="en-US" dirty="0"/>
           </a:p>
@@ -4657,7 +5201,7 @@
                 <a:ea typeface="Calibri" pitchFamily="34" charset="-122"/>
                 <a:cs typeface="Calibri" pitchFamily="34" charset="-120"/>
               </a:rPr>
-              <a:t>Branch mac-m4  |  tiers T0-T3 complete (desktop, RTX 3080, aarch64 emulation, AWS Graviton3)  |  Apple M4 run pending</a:t>
+              <a:t>Branch mac-m4  |  tiers T0-T3 complete (desktop, RTX 3080, aarch64 emulation, AWS Graviton3)  |  Apple M4 block pending (quota requested)</a:t>
             </a:r>
             <a:endParaRPr lang="en-US" sz="1400" dirty="0"/>
           </a:p>
@@ -5671,6 +6215,2356 @@
             <a:r>
               <a:rPr lang="en-US" sz="2800" b="1" dirty="0">
                 <a:solidFill>
+                  <a:schemeClr val="tx2"/>
+                </a:solidFill>
+                <a:latin typeface="+mj-lt" pitchFamily="34" charset="0"/>
+                <a:ea typeface="+mj-lt" pitchFamily="34" charset="-122"/>
+                <a:cs typeface="+mj-lt" pitchFamily="34" charset="-120"/>
+              </a:rPr>
+              <a:t>A rehearsal on Graviton3 measured what the Mac day costs</a:t>
+            </a:r>
+            <a:endParaRPr lang="en-US" sz="2800" dirty="0"/>
+          </a:p>
+        </p:txBody>
+      </p:sp>
+      <p:graphicFrame>
+        <p:nvGraphicFramePr>
+          <p:cNvPr id="3" name="Chart 0" descr=""/>
+          <p:cNvGraphicFramePr/>
+          <p:nvPr/>
+        </p:nvGraphicFramePr>
+        <p:xfrm>
+          <a:off x="548640" y="1371600"/>
+          <a:ext cx="4937760" cy="3200400"/>
+        </p:xfrm>
+        <a:graphic xmlns:a="http://schemas.openxmlformats.org/drawingml/2006/main">
+          <a:graphicData uri="http://schemas.openxmlformats.org/drawingml/2006/chart">
+            <c:chart xmlns:c="http://schemas.openxmlformats.org/drawingml/2006/chart" r:id="rId1"/>
+          </a:graphicData>
+        </a:graphic>
+      </p:graphicFrame>
+      <p:sp>
+        <p:nvSpPr>
+          <p:cNvPr id="4" name="stat cost value"/>
+          <p:cNvSpPr txBox="1"/>
+          <p:nvPr/>
+        </p:nvSpPr>
+        <p:spPr>
+          <a:xfrm>
+            <a:off x="548640" y="4663440"/>
+            <a:ext cx="4937760" cy="685800"/>
+          </a:xfrm>
+          <a:prstGeom prst="rect">
+            <a:avLst/>
+          </a:prstGeom>
+          <a:noFill/>
+          <a:ln/>
+        </p:spPr>
+        <p:txBody>
+          <a:bodyPr wrap="square" lIns="0" tIns="0" rIns="0" bIns="0" rtlCol="0" anchor="b"/>
+          <a:lstStyle/>
+          <a:p>
+            <a:pPr indent="0" marL="0">
+              <a:buNone/>
+            </a:pPr>
+            <a:r>
+              <a:rPr lang="en-US" sz="4000" b="1" dirty="0">
+                <a:solidFill>
+                  <a:srgbClr val="0A7EA4"/>
+                </a:solidFill>
+                <a:latin typeface="Cambria" pitchFamily="34" charset="0"/>
+                <a:ea typeface="Cambria" pitchFamily="34" charset="-122"/>
+                <a:cs typeface="Cambria" pitchFamily="34" charset="-120"/>
+              </a:rPr>
+              <a:t>88 s / 113 s</a:t>
+            </a:r>
+            <a:endParaRPr lang="en-US" sz="4000" dirty="0"/>
+          </a:p>
+        </p:txBody>
+      </p:sp>
+      <p:sp>
+        <p:nvSpPr>
+          <p:cNvPr id="5" name="stat cost label"/>
+          <p:cNvSpPr txBox="1"/>
+          <p:nvPr/>
+        </p:nvSpPr>
+        <p:spPr>
+          <a:xfrm>
+            <a:off x="548640" y="5376672"/>
+            <a:ext cx="4937760" cy="640080"/>
+          </a:xfrm>
+          <a:prstGeom prst="rect">
+            <a:avLst/>
+          </a:prstGeom>
+          <a:noFill/>
+          <a:ln/>
+        </p:spPr>
+        <p:txBody>
+          <a:bodyPr wrap="square" lIns="0" tIns="0" rIns="0" bIns="0" rtlCol="0" anchor="t"/>
+          <a:lstStyle/>
+          <a:p>
+            <a:pPr indent="0" marL="0">
+              <a:buNone/>
+            </a:pPr>
+            <a:r>
+              <a:rPr lang="en-US" sz="1400" dirty="0">
+                <a:solidFill>
+                  <a:schemeClr val="tx1"/>
+                </a:solidFill>
+                <a:latin typeface="Calibri" pitchFamily="34" charset="0"/>
+                <a:ea typeface="Calibri" pitchFamily="34" charset="-122"/>
+                <a:cs typeface="Calibri" pitchFamily="34" charset="-120"/>
+              </a:rPr>
+              <a:t>total per genome for stock / KleidiAI; the F16 reference costs 9.3 / 7.4 minutes</a:t>
+            </a:r>
+            <a:endParaRPr lang="en-US" sz="1400" dirty="0"/>
+          </a:p>
+        </p:txBody>
+      </p:sp>
+      <p:sp>
+        <p:nvSpPr>
+          <p:cNvPr id="6" name="projection head"/>
+          <p:cNvSpPr txBox="1"/>
+          <p:nvPr/>
+        </p:nvSpPr>
+        <p:spPr>
+          <a:xfrm>
+            <a:off x="5852160" y="1371600"/>
+            <a:ext cx="5760720" cy="640080"/>
+          </a:xfrm>
+          <a:prstGeom prst="rect">
+            <a:avLst/>
+          </a:prstGeom>
+          <a:noFill/>
+          <a:ln/>
+        </p:spPr>
+        <p:txBody>
+          <a:bodyPr wrap="square" lIns="0" tIns="0" rIns="0" bIns="0" rtlCol="0" anchor="t"/>
+          <a:lstStyle/>
+          <a:p>
+            <a:pPr indent="0" marL="0">
+              <a:buNone/>
+            </a:pPr>
+            <a:r>
+              <a:rPr lang="en-US" sz="1500" b="1" dirty="0">
+                <a:solidFill>
+                  <a:schemeClr val="tx2"/>
+                </a:solidFill>
+                <a:latin typeface="Calibri" pitchFamily="34" charset="0"/>
+                <a:ea typeface="Calibri" pitchFamily="34" charset="-122"/>
+                <a:cs typeface="Calibri" pitchFamily="34" charset="-120"/>
+              </a:rPr>
+              <a:t>Hours to measure both models (256 genomes each) for a Mac that is faster than this machine by:</a:t>
+            </a:r>
+            <a:endParaRPr lang="en-US" sz="1500" dirty="0"/>
+          </a:p>
+        </p:txBody>
+      </p:sp>
+      <p:graphicFrame>
+        <p:nvGraphicFramePr>
+          <p:cNvPr id="13" name="projection table"/>
+          <p:cNvGraphicFramePr>
+            <a:graphicFrameLocks noGrp="1"/>
+          </p:cNvGraphicFramePr>
+          <p:nvPr>
+            <p:extLst>
+              <p:ext uri="{D42A27DB-BD31-4B8C-83A1-F6EECF244321}">
+                <p14:modId xmlns:p14="http://schemas.microsoft.com/office/powerpoint/2010/main" val="1579011935"/>
+              </p:ext>
+            </p:extLst>
+          </p:nvPr>
+        </p:nvGraphicFramePr>
+        <p:xfrm>
+          <a:off x="5852160" y="2057400"/>
+          <a:ext cx="5760720" cy="914400"/>
+        </p:xfrm>
+        <a:graphic>
+          <a:graphicData uri="http://schemas.openxmlformats.org/drawingml/2006/table">
+            <a:tbl>
+              <a:tblPr/>
+              <a:tblGrid>
+                <a:gridCol w="2468880"/>
+                <a:gridCol w="822960"/>
+                <a:gridCol w="822960"/>
+                <a:gridCol w="822960"/>
+                <a:gridCol w="822960"/>
+              </a:tblGrid>
+              <a:tr h="457200">
+                <a:tc>
+                  <a:txBody>
+                    <a:bodyPr/>
+                    <a:lstStyle/>
+                    <a:p>
+                      <a:pPr algn="ctr" indent="0" marL="0">
+                        <a:buNone/>
+                      </a:pPr>
+                      <a:r>
+                        <a:rPr lang="en-US" sz="1300" b="1" dirty="0">
+                          <a:solidFill>
+                            <a:schemeClr val="bg1"/>
+                          </a:solidFill>
+                          <a:latin typeface="Calibri" pitchFamily="34" charset="0"/>
+                          <a:ea typeface="Calibri" pitchFamily="34" charset="-122"/>
+                          <a:cs typeface="Calibri" pitchFamily="34" charset="-120"/>
+                        </a:rPr>
+                        <a:t>design</a:t>
+                      </a:r>
+                      <a:endParaRPr lang="en-US" sz="1300" dirty="0">
+                        <a:latin typeface="Calibri" charset="0"/>
+                        <a:ea typeface="Calibri" charset="0"/>
+                        <a:cs typeface="Calibri" charset="0"/>
+                      </a:endParaRPr>
+                    </a:p>
+                  </a:txBody>
+                  <a:tcPr marL="91440" marR="91440" marT="45720" marB="45720" anchor="ctr">
+                    <a:lnL w="6350" cap="flat" cmpd="sng" algn="ctr">
+                      <a:solidFill>
+                        <a:srgbClr val="D5DEE4"/>
+                      </a:solidFill>
+                      <a:prstDash val="solid"/>
+                      <a:round/>
+                      <a:headEnd type="none" w="med" len="med"/>
+                      <a:tailEnd type="none" w="med" len="med"/>
+                    </a:lnL>
+                    <a:lnR w="6350" cap="flat" cmpd="sng" algn="ctr">
+                      <a:solidFill>
+                        <a:srgbClr val="D5DEE4"/>
+                      </a:solidFill>
+                      <a:prstDash val="solid"/>
+                      <a:round/>
+                      <a:headEnd type="none" w="med" len="med"/>
+                      <a:tailEnd type="none" w="med" len="med"/>
+                    </a:lnR>
+                    <a:lnT w="6350" cap="flat" cmpd="sng" algn="ctr">
+                      <a:solidFill>
+                        <a:srgbClr val="D5DEE4"/>
+                      </a:solidFill>
+                      <a:prstDash val="solid"/>
+                      <a:round/>
+                      <a:headEnd type="none" w="med" len="med"/>
+                      <a:tailEnd type="none" w="med" len="med"/>
+                    </a:lnT>
+                    <a:lnB w="6350" cap="flat" cmpd="sng" algn="ctr">
+                      <a:solidFill>
+                        <a:srgbClr val="D5DEE4"/>
+                      </a:solidFill>
+                      <a:prstDash val="solid"/>
+                      <a:round/>
+                      <a:headEnd type="none" w="med" len="med"/>
+                      <a:tailEnd type="none" w="med" len="med"/>
+                    </a:lnB>
+                    <a:solidFill>
+                      <a:schemeClr val="tx2"/>
+                    </a:solidFill>
+                  </a:tcPr>
+                </a:tc>
+                <a:tc>
+                  <a:txBody>
+                    <a:bodyPr/>
+                    <a:lstStyle/>
+                    <a:p>
+                      <a:pPr algn="ctr" indent="0" marL="0">
+                        <a:buNone/>
+                      </a:pPr>
+                      <a:r>
+                        <a:rPr lang="en-US" sz="1300" b="1" dirty="0">
+                          <a:solidFill>
+                            <a:schemeClr val="bg1"/>
+                          </a:solidFill>
+                          <a:latin typeface="Calibri" pitchFamily="34" charset="0"/>
+                          <a:ea typeface="Calibri" pitchFamily="34" charset="-122"/>
+                          <a:cs typeface="Calibri" pitchFamily="34" charset="-120"/>
+                        </a:rPr>
+                        <a:t>1x</a:t>
+                      </a:r>
+                      <a:endParaRPr lang="en-US" sz="1300" dirty="0">
+                        <a:latin typeface="Calibri" charset="0"/>
+                        <a:ea typeface="Calibri" charset="0"/>
+                        <a:cs typeface="Calibri" charset="0"/>
+                      </a:endParaRPr>
+                    </a:p>
+                  </a:txBody>
+                  <a:tcPr marL="91440" marR="91440" marT="45720" marB="45720" anchor="ctr">
+                    <a:lnL w="6350" cap="flat" cmpd="sng" algn="ctr">
+                      <a:solidFill>
+                        <a:srgbClr val="D5DEE4"/>
+                      </a:solidFill>
+                      <a:prstDash val="solid"/>
+                      <a:round/>
+                      <a:headEnd type="none" w="med" len="med"/>
+                      <a:tailEnd type="none" w="med" len="med"/>
+                    </a:lnL>
+                    <a:lnR w="6350" cap="flat" cmpd="sng" algn="ctr">
+                      <a:solidFill>
+                        <a:srgbClr val="D5DEE4"/>
+                      </a:solidFill>
+                      <a:prstDash val="solid"/>
+                      <a:round/>
+                      <a:headEnd type="none" w="med" len="med"/>
+                      <a:tailEnd type="none" w="med" len="med"/>
+                    </a:lnR>
+                    <a:lnT w="6350" cap="flat" cmpd="sng" algn="ctr">
+                      <a:solidFill>
+                        <a:srgbClr val="D5DEE4"/>
+                      </a:solidFill>
+                      <a:prstDash val="solid"/>
+                      <a:round/>
+                      <a:headEnd type="none" w="med" len="med"/>
+                      <a:tailEnd type="none" w="med" len="med"/>
+                    </a:lnT>
+                    <a:lnB w="6350" cap="flat" cmpd="sng" algn="ctr">
+                      <a:solidFill>
+                        <a:srgbClr val="D5DEE4"/>
+                      </a:solidFill>
+                      <a:prstDash val="solid"/>
+                      <a:round/>
+                      <a:headEnd type="none" w="med" len="med"/>
+                      <a:tailEnd type="none" w="med" len="med"/>
+                    </a:lnB>
+                    <a:solidFill>
+                      <a:schemeClr val="tx2"/>
+                    </a:solidFill>
+                  </a:tcPr>
+                </a:tc>
+                <a:tc>
+                  <a:txBody>
+                    <a:bodyPr/>
+                    <a:lstStyle/>
+                    <a:p>
+                      <a:pPr algn="ctr" indent="0" marL="0">
+                        <a:buNone/>
+                      </a:pPr>
+                      <a:r>
+                        <a:rPr lang="en-US" sz="1300" b="1" dirty="0">
+                          <a:solidFill>
+                            <a:schemeClr val="bg1"/>
+                          </a:solidFill>
+                          <a:latin typeface="Calibri" pitchFamily="34" charset="0"/>
+                          <a:ea typeface="Calibri" pitchFamily="34" charset="-122"/>
+                          <a:cs typeface="Calibri" pitchFamily="34" charset="-120"/>
+                        </a:rPr>
+                        <a:t>1.5x</a:t>
+                      </a:r>
+                      <a:endParaRPr lang="en-US" sz="1300" dirty="0">
+                        <a:latin typeface="Calibri" charset="0"/>
+                        <a:ea typeface="Calibri" charset="0"/>
+                        <a:cs typeface="Calibri" charset="0"/>
+                      </a:endParaRPr>
+                    </a:p>
+                  </a:txBody>
+                  <a:tcPr marL="91440" marR="91440" marT="45720" marB="45720" anchor="ctr">
+                    <a:lnL w="6350" cap="flat" cmpd="sng" algn="ctr">
+                      <a:solidFill>
+                        <a:srgbClr val="D5DEE4"/>
+                      </a:solidFill>
+                      <a:prstDash val="solid"/>
+                      <a:round/>
+                      <a:headEnd type="none" w="med" len="med"/>
+                      <a:tailEnd type="none" w="med" len="med"/>
+                    </a:lnL>
+                    <a:lnR w="6350" cap="flat" cmpd="sng" algn="ctr">
+                      <a:solidFill>
+                        <a:srgbClr val="D5DEE4"/>
+                      </a:solidFill>
+                      <a:prstDash val="solid"/>
+                      <a:round/>
+                      <a:headEnd type="none" w="med" len="med"/>
+                      <a:tailEnd type="none" w="med" len="med"/>
+                    </a:lnR>
+                    <a:lnT w="6350" cap="flat" cmpd="sng" algn="ctr">
+                      <a:solidFill>
+                        <a:srgbClr val="D5DEE4"/>
+                      </a:solidFill>
+                      <a:prstDash val="solid"/>
+                      <a:round/>
+                      <a:headEnd type="none" w="med" len="med"/>
+                      <a:tailEnd type="none" w="med" len="med"/>
+                    </a:lnT>
+                    <a:lnB w="6350" cap="flat" cmpd="sng" algn="ctr">
+                      <a:solidFill>
+                        <a:srgbClr val="D5DEE4"/>
+                      </a:solidFill>
+                      <a:prstDash val="solid"/>
+                      <a:round/>
+                      <a:headEnd type="none" w="med" len="med"/>
+                      <a:tailEnd type="none" w="med" len="med"/>
+                    </a:lnB>
+                    <a:solidFill>
+                      <a:schemeClr val="tx2"/>
+                    </a:solidFill>
+                  </a:tcPr>
+                </a:tc>
+                <a:tc>
+                  <a:txBody>
+                    <a:bodyPr/>
+                    <a:lstStyle/>
+                    <a:p>
+                      <a:pPr algn="ctr" indent="0" marL="0">
+                        <a:buNone/>
+                      </a:pPr>
+                      <a:r>
+                        <a:rPr lang="en-US" sz="1300" b="1" dirty="0">
+                          <a:solidFill>
+                            <a:schemeClr val="bg1"/>
+                          </a:solidFill>
+                          <a:latin typeface="Calibri" pitchFamily="34" charset="0"/>
+                          <a:ea typeface="Calibri" pitchFamily="34" charset="-122"/>
+                          <a:cs typeface="Calibri" pitchFamily="34" charset="-120"/>
+                        </a:rPr>
+                        <a:t>2x</a:t>
+                      </a:r>
+                      <a:endParaRPr lang="en-US" sz="1300" dirty="0">
+                        <a:latin typeface="Calibri" charset="0"/>
+                        <a:ea typeface="Calibri" charset="0"/>
+                        <a:cs typeface="Calibri" charset="0"/>
+                      </a:endParaRPr>
+                    </a:p>
+                  </a:txBody>
+                  <a:tcPr marL="91440" marR="91440" marT="45720" marB="45720" anchor="ctr">
+                    <a:lnL w="6350" cap="flat" cmpd="sng" algn="ctr">
+                      <a:solidFill>
+                        <a:srgbClr val="D5DEE4"/>
+                      </a:solidFill>
+                      <a:prstDash val="solid"/>
+                      <a:round/>
+                      <a:headEnd type="none" w="med" len="med"/>
+                      <a:tailEnd type="none" w="med" len="med"/>
+                    </a:lnL>
+                    <a:lnR w="6350" cap="flat" cmpd="sng" algn="ctr">
+                      <a:solidFill>
+                        <a:srgbClr val="D5DEE4"/>
+                      </a:solidFill>
+                      <a:prstDash val="solid"/>
+                      <a:round/>
+                      <a:headEnd type="none" w="med" len="med"/>
+                      <a:tailEnd type="none" w="med" len="med"/>
+                    </a:lnR>
+                    <a:lnT w="6350" cap="flat" cmpd="sng" algn="ctr">
+                      <a:solidFill>
+                        <a:srgbClr val="D5DEE4"/>
+                      </a:solidFill>
+                      <a:prstDash val="solid"/>
+                      <a:round/>
+                      <a:headEnd type="none" w="med" len="med"/>
+                      <a:tailEnd type="none" w="med" len="med"/>
+                    </a:lnT>
+                    <a:lnB w="6350" cap="flat" cmpd="sng" algn="ctr">
+                      <a:solidFill>
+                        <a:srgbClr val="D5DEE4"/>
+                      </a:solidFill>
+                      <a:prstDash val="solid"/>
+                      <a:round/>
+                      <a:headEnd type="none" w="med" len="med"/>
+                      <a:tailEnd type="none" w="med" len="med"/>
+                    </a:lnB>
+                    <a:solidFill>
+                      <a:schemeClr val="tx2"/>
+                    </a:solidFill>
+                  </a:tcPr>
+                </a:tc>
+                <a:tc>
+                  <a:txBody>
+                    <a:bodyPr/>
+                    <a:lstStyle/>
+                    <a:p>
+                      <a:pPr algn="ctr" indent="0" marL="0">
+                        <a:buNone/>
+                      </a:pPr>
+                      <a:r>
+                        <a:rPr lang="en-US" sz="1300" b="1" dirty="0">
+                          <a:solidFill>
+                            <a:schemeClr val="bg1"/>
+                          </a:solidFill>
+                          <a:latin typeface="Calibri" pitchFamily="34" charset="0"/>
+                          <a:ea typeface="Calibri" pitchFamily="34" charset="-122"/>
+                          <a:cs typeface="Calibri" pitchFamily="34" charset="-120"/>
+                        </a:rPr>
+                        <a:t>3x</a:t>
+                      </a:r>
+                      <a:endParaRPr lang="en-US" sz="1300" dirty="0">
+                        <a:latin typeface="Calibri" charset="0"/>
+                        <a:ea typeface="Calibri" charset="0"/>
+                        <a:cs typeface="Calibri" charset="0"/>
+                      </a:endParaRPr>
+                    </a:p>
+                  </a:txBody>
+                  <a:tcPr marL="91440" marR="91440" marT="45720" marB="45720" anchor="ctr">
+                    <a:lnL w="6350" cap="flat" cmpd="sng" algn="ctr">
+                      <a:solidFill>
+                        <a:srgbClr val="D5DEE4"/>
+                      </a:solidFill>
+                      <a:prstDash val="solid"/>
+                      <a:round/>
+                      <a:headEnd type="none" w="med" len="med"/>
+                      <a:tailEnd type="none" w="med" len="med"/>
+                    </a:lnL>
+                    <a:lnR w="6350" cap="flat" cmpd="sng" algn="ctr">
+                      <a:solidFill>
+                        <a:srgbClr val="D5DEE4"/>
+                      </a:solidFill>
+                      <a:prstDash val="solid"/>
+                      <a:round/>
+                      <a:headEnd type="none" w="med" len="med"/>
+                      <a:tailEnd type="none" w="med" len="med"/>
+                    </a:lnR>
+                    <a:lnT w="6350" cap="flat" cmpd="sng" algn="ctr">
+                      <a:solidFill>
+                        <a:srgbClr val="D5DEE4"/>
+                      </a:solidFill>
+                      <a:prstDash val="solid"/>
+                      <a:round/>
+                      <a:headEnd type="none" w="med" len="med"/>
+                      <a:tailEnd type="none" w="med" len="med"/>
+                    </a:lnT>
+                    <a:lnB w="6350" cap="flat" cmpd="sng" algn="ctr">
+                      <a:solidFill>
+                        <a:srgbClr val="D5DEE4"/>
+                      </a:solidFill>
+                      <a:prstDash val="solid"/>
+                      <a:round/>
+                      <a:headEnd type="none" w="med" len="med"/>
+                      <a:tailEnd type="none" w="med" len="med"/>
+                    </a:lnB>
+                    <a:solidFill>
+                      <a:schemeClr val="tx2"/>
+                    </a:solidFill>
+                  </a:tcPr>
+                </a:tc>
+              </a:tr>
+              <a:tr h="457200">
+                <a:tc>
+                  <a:txBody>
+                    <a:bodyPr/>
+                    <a:lstStyle/>
+                    <a:p>
+                      <a:pPr algn="l" indent="0" marL="0">
+                        <a:buNone/>
+                      </a:pPr>
+                      <a:r>
+                        <a:rPr lang="en-US" sz="1300" dirty="0">
+                          <a:solidFill>
+                            <a:srgbClr val="10212B"/>
+                          </a:solidFill>
+                          <a:latin typeface="Calibri" pitchFamily="34" charset="0"/>
+                          <a:ea typeface="Calibri" pitchFamily="34" charset="-122"/>
+                          <a:cs typeface="Calibri" pitchFamily="34" charset="-120"/>
+                        </a:rPr>
+                        <a:t>both configurations, all genomes</a:t>
+                      </a:r>
+                      <a:endParaRPr lang="en-US" sz="1300" dirty="0">
+                        <a:latin typeface="Calibri" charset="0"/>
+                        <a:ea typeface="Calibri" charset="0"/>
+                        <a:cs typeface="Calibri" charset="0"/>
+                      </a:endParaRPr>
+                    </a:p>
+                  </a:txBody>
+                  <a:tcPr marL="91440" marR="91440" marT="45720" marB="45720" anchor="ctr">
+                    <a:lnL w="6350" cap="flat" cmpd="sng" algn="ctr">
+                      <a:solidFill>
+                        <a:srgbClr val="D5DEE4"/>
+                      </a:solidFill>
+                      <a:prstDash val="solid"/>
+                      <a:round/>
+                      <a:headEnd type="none" w="med" len="med"/>
+                      <a:tailEnd type="none" w="med" len="med"/>
+                    </a:lnL>
+                    <a:lnR w="6350" cap="flat" cmpd="sng" algn="ctr">
+                      <a:solidFill>
+                        <a:srgbClr val="D5DEE4"/>
+                      </a:solidFill>
+                      <a:prstDash val="solid"/>
+                      <a:round/>
+                      <a:headEnd type="none" w="med" len="med"/>
+                      <a:tailEnd type="none" w="med" len="med"/>
+                    </a:lnR>
+                    <a:lnT w="6350" cap="flat" cmpd="sng" algn="ctr">
+                      <a:solidFill>
+                        <a:srgbClr val="D5DEE4"/>
+                      </a:solidFill>
+                      <a:prstDash val="solid"/>
+                      <a:round/>
+                      <a:headEnd type="none" w="med" len="med"/>
+                      <a:tailEnd type="none" w="med" len="med"/>
+                    </a:lnT>
+                    <a:lnB w="6350" cap="flat" cmpd="sng" algn="ctr">
+                      <a:solidFill>
+                        <a:srgbClr val="D5DEE4"/>
+                      </a:solidFill>
+                      <a:prstDash val="solid"/>
+                      <a:round/>
+                      <a:headEnd type="none" w="med" len="med"/>
+                      <a:tailEnd type="none" w="med" len="med"/>
+                    </a:lnB>
+                  </a:tcPr>
+                </a:tc>
+                <a:tc>
+                  <a:txBody>
+                    <a:bodyPr/>
+                    <a:lstStyle/>
+                    <a:p>
+                      <a:pPr algn="ctr" indent="0" marL="0">
+                        <a:buNone/>
+                      </a:pPr>
+                      <a:r>
+                        <a:rPr lang="en-US" sz="1300" b="1" dirty="0">
+                          <a:solidFill>
+                            <a:srgbClr val="D1495B"/>
+                          </a:solidFill>
+                          <a:latin typeface="Calibri" pitchFamily="34" charset="0"/>
+                          <a:ea typeface="Calibri" pitchFamily="34" charset="-122"/>
+                          <a:cs typeface="Calibri" pitchFamily="34" charset="-120"/>
+                        </a:rPr>
+                        <a:t>44 h</a:t>
+                      </a:r>
+                      <a:endParaRPr lang="en-US" sz="1300" dirty="0">
+                        <a:latin typeface="Calibri" charset="0"/>
+                        <a:ea typeface="Calibri" charset="0"/>
+                        <a:cs typeface="Calibri" charset="0"/>
+                      </a:endParaRPr>
+                    </a:p>
+                  </a:txBody>
+                  <a:tcPr marL="91440" marR="91440" marT="45720" marB="45720" anchor="ctr">
+                    <a:lnL w="6350" cap="flat" cmpd="sng" algn="ctr">
+                      <a:solidFill>
+                        <a:srgbClr val="D5DEE4"/>
+                      </a:solidFill>
+                      <a:prstDash val="solid"/>
+                      <a:round/>
+                      <a:headEnd type="none" w="med" len="med"/>
+                      <a:tailEnd type="none" w="med" len="med"/>
+                    </a:lnL>
+                    <a:lnR w="6350" cap="flat" cmpd="sng" algn="ctr">
+                      <a:solidFill>
+                        <a:srgbClr val="D5DEE4"/>
+                      </a:solidFill>
+                      <a:prstDash val="solid"/>
+                      <a:round/>
+                      <a:headEnd type="none" w="med" len="med"/>
+                      <a:tailEnd type="none" w="med" len="med"/>
+                    </a:lnR>
+                    <a:lnT w="6350" cap="flat" cmpd="sng" algn="ctr">
+                      <a:solidFill>
+                        <a:srgbClr val="D5DEE4"/>
+                      </a:solidFill>
+                      <a:prstDash val="solid"/>
+                      <a:round/>
+                      <a:headEnd type="none" w="med" len="med"/>
+                      <a:tailEnd type="none" w="med" len="med"/>
+                    </a:lnT>
+                    <a:lnB w="6350" cap="flat" cmpd="sng" algn="ctr">
+                      <a:solidFill>
+                        <a:srgbClr val="D5DEE4"/>
+                      </a:solidFill>
+                      <a:prstDash val="solid"/>
+                      <a:round/>
+                      <a:headEnd type="none" w="med" len="med"/>
+                      <a:tailEnd type="none" w="med" len="med"/>
+                    </a:lnB>
+                  </a:tcPr>
+                </a:tc>
+                <a:tc>
+                  <a:txBody>
+                    <a:bodyPr/>
+                    <a:lstStyle/>
+                    <a:p>
+                      <a:pPr algn="ctr" indent="0" marL="0">
+                        <a:buNone/>
+                      </a:pPr>
+                      <a:r>
+                        <a:rPr lang="en-US" sz="1300" b="1" dirty="0">
+                          <a:solidFill>
+                            <a:srgbClr val="D1495B"/>
+                          </a:solidFill>
+                          <a:latin typeface="Calibri" pitchFamily="34" charset="0"/>
+                          <a:ea typeface="Calibri" pitchFamily="34" charset="-122"/>
+                          <a:cs typeface="Calibri" pitchFamily="34" charset="-120"/>
+                        </a:rPr>
+                        <a:t>30 h</a:t>
+                      </a:r>
+                      <a:endParaRPr lang="en-US" sz="1300" dirty="0">
+                        <a:latin typeface="Calibri" charset="0"/>
+                        <a:ea typeface="Calibri" charset="0"/>
+                        <a:cs typeface="Calibri" charset="0"/>
+                      </a:endParaRPr>
+                    </a:p>
+                  </a:txBody>
+                  <a:tcPr marL="91440" marR="91440" marT="45720" marB="45720" anchor="ctr">
+                    <a:lnL w="6350" cap="flat" cmpd="sng" algn="ctr">
+                      <a:solidFill>
+                        <a:srgbClr val="D5DEE4"/>
+                      </a:solidFill>
+                      <a:prstDash val="solid"/>
+                      <a:round/>
+                      <a:headEnd type="none" w="med" len="med"/>
+                      <a:tailEnd type="none" w="med" len="med"/>
+                    </a:lnL>
+                    <a:lnR w="6350" cap="flat" cmpd="sng" algn="ctr">
+                      <a:solidFill>
+                        <a:srgbClr val="D5DEE4"/>
+                      </a:solidFill>
+                      <a:prstDash val="solid"/>
+                      <a:round/>
+                      <a:headEnd type="none" w="med" len="med"/>
+                      <a:tailEnd type="none" w="med" len="med"/>
+                    </a:lnR>
+                    <a:lnT w="6350" cap="flat" cmpd="sng" algn="ctr">
+                      <a:solidFill>
+                        <a:srgbClr val="D5DEE4"/>
+                      </a:solidFill>
+                      <a:prstDash val="solid"/>
+                      <a:round/>
+                      <a:headEnd type="none" w="med" len="med"/>
+                      <a:tailEnd type="none" w="med" len="med"/>
+                    </a:lnT>
+                    <a:lnB w="6350" cap="flat" cmpd="sng" algn="ctr">
+                      <a:solidFill>
+                        <a:srgbClr val="D5DEE4"/>
+                      </a:solidFill>
+                      <a:prstDash val="solid"/>
+                      <a:round/>
+                      <a:headEnd type="none" w="med" len="med"/>
+                      <a:tailEnd type="none" w="med" len="med"/>
+                    </a:lnB>
+                  </a:tcPr>
+                </a:tc>
+                <a:tc>
+                  <a:txBody>
+                    <a:bodyPr/>
+                    <a:lstStyle/>
+                    <a:p>
+                      <a:pPr algn="ctr" indent="0" marL="0">
+                        <a:buNone/>
+                      </a:pPr>
+                      <a:r>
+                        <a:rPr lang="en-US" sz="1300" b="1" dirty="0">
+                          <a:solidFill>
+                            <a:srgbClr val="D1495B"/>
+                          </a:solidFill>
+                          <a:latin typeface="Calibri" pitchFamily="34" charset="0"/>
+                          <a:ea typeface="Calibri" pitchFamily="34" charset="-122"/>
+                          <a:cs typeface="Calibri" pitchFamily="34" charset="-120"/>
+                        </a:rPr>
+                        <a:t>22 h</a:t>
+                      </a:r>
+                      <a:endParaRPr lang="en-US" sz="1300" dirty="0">
+                        <a:latin typeface="Calibri" charset="0"/>
+                        <a:ea typeface="Calibri" charset="0"/>
+                        <a:cs typeface="Calibri" charset="0"/>
+                      </a:endParaRPr>
+                    </a:p>
+                  </a:txBody>
+                  <a:tcPr marL="91440" marR="91440" marT="45720" marB="45720" anchor="ctr">
+                    <a:lnL w="6350" cap="flat" cmpd="sng" algn="ctr">
+                      <a:solidFill>
+                        <a:srgbClr val="D5DEE4"/>
+                      </a:solidFill>
+                      <a:prstDash val="solid"/>
+                      <a:round/>
+                      <a:headEnd type="none" w="med" len="med"/>
+                      <a:tailEnd type="none" w="med" len="med"/>
+                    </a:lnL>
+                    <a:lnR w="6350" cap="flat" cmpd="sng" algn="ctr">
+                      <a:solidFill>
+                        <a:srgbClr val="D5DEE4"/>
+                      </a:solidFill>
+                      <a:prstDash val="solid"/>
+                      <a:round/>
+                      <a:headEnd type="none" w="med" len="med"/>
+                      <a:tailEnd type="none" w="med" len="med"/>
+                    </a:lnR>
+                    <a:lnT w="6350" cap="flat" cmpd="sng" algn="ctr">
+                      <a:solidFill>
+                        <a:srgbClr val="D5DEE4"/>
+                      </a:solidFill>
+                      <a:prstDash val="solid"/>
+                      <a:round/>
+                      <a:headEnd type="none" w="med" len="med"/>
+                      <a:tailEnd type="none" w="med" len="med"/>
+                    </a:lnT>
+                    <a:lnB w="6350" cap="flat" cmpd="sng" algn="ctr">
+                      <a:solidFill>
+                        <a:srgbClr val="D5DEE4"/>
+                      </a:solidFill>
+                      <a:prstDash val="solid"/>
+                      <a:round/>
+                      <a:headEnd type="none" w="med" len="med"/>
+                      <a:tailEnd type="none" w="med" len="med"/>
+                    </a:lnB>
+                  </a:tcPr>
+                </a:tc>
+                <a:tc>
+                  <a:txBody>
+                    <a:bodyPr/>
+                    <a:lstStyle/>
+                    <a:p>
+                      <a:pPr algn="ctr" indent="0" marL="0">
+                        <a:buNone/>
+                      </a:pPr>
+                      <a:r>
+                        <a:rPr lang="en-US" sz="1300" b="1" dirty="0">
+                          <a:solidFill>
+                            <a:srgbClr val="2E9E8A"/>
+                          </a:solidFill>
+                          <a:latin typeface="Calibri" pitchFamily="34" charset="0"/>
+                          <a:ea typeface="Calibri" pitchFamily="34" charset="-122"/>
+                          <a:cs typeface="Calibri" pitchFamily="34" charset="-120"/>
+                        </a:rPr>
+                        <a:t>15 h</a:t>
+                      </a:r>
+                      <a:endParaRPr lang="en-US" sz="1300" dirty="0">
+                        <a:latin typeface="Calibri" charset="0"/>
+                        <a:ea typeface="Calibri" charset="0"/>
+                        <a:cs typeface="Calibri" charset="0"/>
+                      </a:endParaRPr>
+                    </a:p>
+                  </a:txBody>
+                  <a:tcPr marL="91440" marR="91440" marT="45720" marB="45720" anchor="ctr">
+                    <a:lnL w="6350" cap="flat" cmpd="sng" algn="ctr">
+                      <a:solidFill>
+                        <a:srgbClr val="D5DEE4"/>
+                      </a:solidFill>
+                      <a:prstDash val="solid"/>
+                      <a:round/>
+                      <a:headEnd type="none" w="med" len="med"/>
+                      <a:tailEnd type="none" w="med" len="med"/>
+                    </a:lnL>
+                    <a:lnR w="6350" cap="flat" cmpd="sng" algn="ctr">
+                      <a:solidFill>
+                        <a:srgbClr val="D5DEE4"/>
+                      </a:solidFill>
+                      <a:prstDash val="solid"/>
+                      <a:round/>
+                      <a:headEnd type="none" w="med" len="med"/>
+                      <a:tailEnd type="none" w="med" len="med"/>
+                    </a:lnR>
+                    <a:lnT w="6350" cap="flat" cmpd="sng" algn="ctr">
+                      <a:solidFill>
+                        <a:srgbClr val="D5DEE4"/>
+                      </a:solidFill>
+                      <a:prstDash val="solid"/>
+                      <a:round/>
+                      <a:headEnd type="none" w="med" len="med"/>
+                      <a:tailEnd type="none" w="med" len="med"/>
+                    </a:lnT>
+                    <a:lnB w="6350" cap="flat" cmpd="sng" algn="ctr">
+                      <a:solidFill>
+                        <a:srgbClr val="D5DEE4"/>
+                      </a:solidFill>
+                      <a:prstDash val="solid"/>
+                      <a:round/>
+                      <a:headEnd type="none" w="med" len="med"/>
+                      <a:tailEnd type="none" w="med" len="med"/>
+                    </a:lnB>
+                  </a:tcPr>
+                </a:tc>
+              </a:tr>
+              <a:tr h="457200">
+                <a:tc>
+                  <a:txBody>
+                    <a:bodyPr/>
+                    <a:lstStyle/>
+                    <a:p>
+                      <a:pPr algn="l" indent="0" marL="0">
+                        <a:buNone/>
+                      </a:pPr>
+                      <a:r>
+                        <a:rPr lang="en-US" sz="1300" b="1" dirty="0">
+                          <a:solidFill>
+                            <a:srgbClr val="10212B"/>
+                          </a:solidFill>
+                          <a:latin typeface="Calibri" pitchFamily="34" charset="0"/>
+                          <a:ea typeface="Calibri" pitchFamily="34" charset="-122"/>
+                          <a:cs typeface="Calibri" pitchFamily="34" charset="-120"/>
+                        </a:rPr>
+                        <a:t>KleidiAI in full + stock for 12 genomes</a:t>
+                      </a:r>
+                      <a:endParaRPr lang="en-US" sz="1300" dirty="0">
+                        <a:latin typeface="Calibri" charset="0"/>
+                        <a:ea typeface="Calibri" charset="0"/>
+                        <a:cs typeface="Calibri" charset="0"/>
+                      </a:endParaRPr>
+                    </a:p>
+                  </a:txBody>
+                  <a:tcPr marL="91440" marR="91440" marT="45720" marB="45720" anchor="ctr">
+                    <a:lnL w="6350" cap="flat" cmpd="sng" algn="ctr">
+                      <a:solidFill>
+                        <a:srgbClr val="D5DEE4"/>
+                      </a:solidFill>
+                      <a:prstDash val="solid"/>
+                      <a:round/>
+                      <a:headEnd type="none" w="med" len="med"/>
+                      <a:tailEnd type="none" w="med" len="med"/>
+                    </a:lnL>
+                    <a:lnR w="6350" cap="flat" cmpd="sng" algn="ctr">
+                      <a:solidFill>
+                        <a:srgbClr val="D5DEE4"/>
+                      </a:solidFill>
+                      <a:prstDash val="solid"/>
+                      <a:round/>
+                      <a:headEnd type="none" w="med" len="med"/>
+                      <a:tailEnd type="none" w="med" len="med"/>
+                    </a:lnR>
+                    <a:lnT w="6350" cap="flat" cmpd="sng" algn="ctr">
+                      <a:solidFill>
+                        <a:srgbClr val="D5DEE4"/>
+                      </a:solidFill>
+                      <a:prstDash val="solid"/>
+                      <a:round/>
+                      <a:headEnd type="none" w="med" len="med"/>
+                      <a:tailEnd type="none" w="med" len="med"/>
+                    </a:lnT>
+                    <a:lnB w="6350" cap="flat" cmpd="sng" algn="ctr">
+                      <a:solidFill>
+                        <a:srgbClr val="D5DEE4"/>
+                      </a:solidFill>
+                      <a:prstDash val="solid"/>
+                      <a:round/>
+                      <a:headEnd type="none" w="med" len="med"/>
+                      <a:tailEnd type="none" w="med" len="med"/>
+                    </a:lnB>
+                  </a:tcPr>
+                </a:tc>
+                <a:tc>
+                  <a:txBody>
+                    <a:bodyPr/>
+                    <a:lstStyle/>
+                    <a:p>
+                      <a:pPr algn="ctr" indent="0" marL="0">
+                        <a:buNone/>
+                      </a:pPr>
+                      <a:r>
+                        <a:rPr lang="en-US" sz="1300" b="1" dirty="0">
+                          <a:solidFill>
+                            <a:srgbClr val="D1495B"/>
+                          </a:solidFill>
+                          <a:latin typeface="Calibri" pitchFamily="34" charset="0"/>
+                          <a:ea typeface="Calibri" pitchFamily="34" charset="-122"/>
+                          <a:cs typeface="Calibri" pitchFamily="34" charset="-120"/>
+                        </a:rPr>
+                        <a:t>25.8 h</a:t>
+                      </a:r>
+                      <a:endParaRPr lang="en-US" sz="1300" dirty="0">
+                        <a:latin typeface="Calibri" charset="0"/>
+                        <a:ea typeface="Calibri" charset="0"/>
+                        <a:cs typeface="Calibri" charset="0"/>
+                      </a:endParaRPr>
+                    </a:p>
+                  </a:txBody>
+                  <a:tcPr marL="91440" marR="91440" marT="45720" marB="45720" anchor="ctr">
+                    <a:lnL w="6350" cap="flat" cmpd="sng" algn="ctr">
+                      <a:solidFill>
+                        <a:srgbClr val="D5DEE4"/>
+                      </a:solidFill>
+                      <a:prstDash val="solid"/>
+                      <a:round/>
+                      <a:headEnd type="none" w="med" len="med"/>
+                      <a:tailEnd type="none" w="med" len="med"/>
+                    </a:lnL>
+                    <a:lnR w="6350" cap="flat" cmpd="sng" algn="ctr">
+                      <a:solidFill>
+                        <a:srgbClr val="D5DEE4"/>
+                      </a:solidFill>
+                      <a:prstDash val="solid"/>
+                      <a:round/>
+                      <a:headEnd type="none" w="med" len="med"/>
+                      <a:tailEnd type="none" w="med" len="med"/>
+                    </a:lnR>
+                    <a:lnT w="6350" cap="flat" cmpd="sng" algn="ctr">
+                      <a:solidFill>
+                        <a:srgbClr val="D5DEE4"/>
+                      </a:solidFill>
+                      <a:prstDash val="solid"/>
+                      <a:round/>
+                      <a:headEnd type="none" w="med" len="med"/>
+                      <a:tailEnd type="none" w="med" len="med"/>
+                    </a:lnT>
+                    <a:lnB w="6350" cap="flat" cmpd="sng" algn="ctr">
+                      <a:solidFill>
+                        <a:srgbClr val="D5DEE4"/>
+                      </a:solidFill>
+                      <a:prstDash val="solid"/>
+                      <a:round/>
+                      <a:headEnd type="none" w="med" len="med"/>
+                      <a:tailEnd type="none" w="med" len="med"/>
+                    </a:lnB>
+                  </a:tcPr>
+                </a:tc>
+                <a:tc>
+                  <a:txBody>
+                    <a:bodyPr/>
+                    <a:lstStyle/>
+                    <a:p>
+                      <a:pPr algn="ctr" indent="0" marL="0">
+                        <a:buNone/>
+                      </a:pPr>
+                      <a:r>
+                        <a:rPr lang="en-US" sz="1300" b="1" dirty="0">
+                          <a:solidFill>
+                            <a:srgbClr val="2E9E8A"/>
+                          </a:solidFill>
+                          <a:latin typeface="Calibri" pitchFamily="34" charset="0"/>
+                          <a:ea typeface="Calibri" pitchFamily="34" charset="-122"/>
+                          <a:cs typeface="Calibri" pitchFamily="34" charset="-120"/>
+                        </a:rPr>
+                        <a:t>17.2 h</a:t>
+                      </a:r>
+                      <a:endParaRPr lang="en-US" sz="1300" dirty="0">
+                        <a:latin typeface="Calibri" charset="0"/>
+                        <a:ea typeface="Calibri" charset="0"/>
+                        <a:cs typeface="Calibri" charset="0"/>
+                      </a:endParaRPr>
+                    </a:p>
+                  </a:txBody>
+                  <a:tcPr marL="91440" marR="91440" marT="45720" marB="45720" anchor="ctr">
+                    <a:lnL w="6350" cap="flat" cmpd="sng" algn="ctr">
+                      <a:solidFill>
+                        <a:srgbClr val="D5DEE4"/>
+                      </a:solidFill>
+                      <a:prstDash val="solid"/>
+                      <a:round/>
+                      <a:headEnd type="none" w="med" len="med"/>
+                      <a:tailEnd type="none" w="med" len="med"/>
+                    </a:lnL>
+                    <a:lnR w="6350" cap="flat" cmpd="sng" algn="ctr">
+                      <a:solidFill>
+                        <a:srgbClr val="D5DEE4"/>
+                      </a:solidFill>
+                      <a:prstDash val="solid"/>
+                      <a:round/>
+                      <a:headEnd type="none" w="med" len="med"/>
+                      <a:tailEnd type="none" w="med" len="med"/>
+                    </a:lnR>
+                    <a:lnT w="6350" cap="flat" cmpd="sng" algn="ctr">
+                      <a:solidFill>
+                        <a:srgbClr val="D5DEE4"/>
+                      </a:solidFill>
+                      <a:prstDash val="solid"/>
+                      <a:round/>
+                      <a:headEnd type="none" w="med" len="med"/>
+                      <a:tailEnd type="none" w="med" len="med"/>
+                    </a:lnT>
+                    <a:lnB w="6350" cap="flat" cmpd="sng" algn="ctr">
+                      <a:solidFill>
+                        <a:srgbClr val="D5DEE4"/>
+                      </a:solidFill>
+                      <a:prstDash val="solid"/>
+                      <a:round/>
+                      <a:headEnd type="none" w="med" len="med"/>
+                      <a:tailEnd type="none" w="med" len="med"/>
+                    </a:lnB>
+                  </a:tcPr>
+                </a:tc>
+                <a:tc>
+                  <a:txBody>
+                    <a:bodyPr/>
+                    <a:lstStyle/>
+                    <a:p>
+                      <a:pPr algn="ctr" indent="0" marL="0">
+                        <a:buNone/>
+                      </a:pPr>
+                      <a:r>
+                        <a:rPr lang="en-US" sz="1300" b="1" dirty="0">
+                          <a:solidFill>
+                            <a:srgbClr val="2E9E8A"/>
+                          </a:solidFill>
+                          <a:latin typeface="Calibri" pitchFamily="34" charset="0"/>
+                          <a:ea typeface="Calibri" pitchFamily="34" charset="-122"/>
+                          <a:cs typeface="Calibri" pitchFamily="34" charset="-120"/>
+                        </a:rPr>
+                        <a:t>12.9 h</a:t>
+                      </a:r>
+                      <a:endParaRPr lang="en-US" sz="1300" dirty="0">
+                        <a:latin typeface="Calibri" charset="0"/>
+                        <a:ea typeface="Calibri" charset="0"/>
+                        <a:cs typeface="Calibri" charset="0"/>
+                      </a:endParaRPr>
+                    </a:p>
+                  </a:txBody>
+                  <a:tcPr marL="91440" marR="91440" marT="45720" marB="45720" anchor="ctr">
+                    <a:lnL w="6350" cap="flat" cmpd="sng" algn="ctr">
+                      <a:solidFill>
+                        <a:srgbClr val="D5DEE4"/>
+                      </a:solidFill>
+                      <a:prstDash val="solid"/>
+                      <a:round/>
+                      <a:headEnd type="none" w="med" len="med"/>
+                      <a:tailEnd type="none" w="med" len="med"/>
+                    </a:lnL>
+                    <a:lnR w="6350" cap="flat" cmpd="sng" algn="ctr">
+                      <a:solidFill>
+                        <a:srgbClr val="D5DEE4"/>
+                      </a:solidFill>
+                      <a:prstDash val="solid"/>
+                      <a:round/>
+                      <a:headEnd type="none" w="med" len="med"/>
+                      <a:tailEnd type="none" w="med" len="med"/>
+                    </a:lnR>
+                    <a:lnT w="6350" cap="flat" cmpd="sng" algn="ctr">
+                      <a:solidFill>
+                        <a:srgbClr val="D5DEE4"/>
+                      </a:solidFill>
+                      <a:prstDash val="solid"/>
+                      <a:round/>
+                      <a:headEnd type="none" w="med" len="med"/>
+                      <a:tailEnd type="none" w="med" len="med"/>
+                    </a:lnT>
+                    <a:lnB w="6350" cap="flat" cmpd="sng" algn="ctr">
+                      <a:solidFill>
+                        <a:srgbClr val="D5DEE4"/>
+                      </a:solidFill>
+                      <a:prstDash val="solid"/>
+                      <a:round/>
+                      <a:headEnd type="none" w="med" len="med"/>
+                      <a:tailEnd type="none" w="med" len="med"/>
+                    </a:lnB>
+                  </a:tcPr>
+                </a:tc>
+                <a:tc>
+                  <a:txBody>
+                    <a:bodyPr/>
+                    <a:lstStyle/>
+                    <a:p>
+                      <a:pPr algn="ctr" indent="0" marL="0">
+                        <a:buNone/>
+                      </a:pPr>
+                      <a:r>
+                        <a:rPr lang="en-US" sz="1300" b="1" dirty="0">
+                          <a:solidFill>
+                            <a:srgbClr val="2E9E8A"/>
+                          </a:solidFill>
+                          <a:latin typeface="Calibri" pitchFamily="34" charset="0"/>
+                          <a:ea typeface="Calibri" pitchFamily="34" charset="-122"/>
+                          <a:cs typeface="Calibri" pitchFamily="34" charset="-120"/>
+                        </a:rPr>
+                        <a:t>8.6 h</a:t>
+                      </a:r>
+                      <a:endParaRPr lang="en-US" sz="1300" dirty="0">
+                        <a:latin typeface="Calibri" charset="0"/>
+                        <a:ea typeface="Calibri" charset="0"/>
+                        <a:cs typeface="Calibri" charset="0"/>
+                      </a:endParaRPr>
+                    </a:p>
+                  </a:txBody>
+                  <a:tcPr marL="91440" marR="91440" marT="45720" marB="45720" anchor="ctr">
+                    <a:lnL w="6350" cap="flat" cmpd="sng" algn="ctr">
+                      <a:solidFill>
+                        <a:srgbClr val="D5DEE4"/>
+                      </a:solidFill>
+                      <a:prstDash val="solid"/>
+                      <a:round/>
+                      <a:headEnd type="none" w="med" len="med"/>
+                      <a:tailEnd type="none" w="med" len="med"/>
+                    </a:lnL>
+                    <a:lnR w="6350" cap="flat" cmpd="sng" algn="ctr">
+                      <a:solidFill>
+                        <a:srgbClr val="D5DEE4"/>
+                      </a:solidFill>
+                      <a:prstDash val="solid"/>
+                      <a:round/>
+                      <a:headEnd type="none" w="med" len="med"/>
+                      <a:tailEnd type="none" w="med" len="med"/>
+                    </a:lnR>
+                    <a:lnT w="6350" cap="flat" cmpd="sng" algn="ctr">
+                      <a:solidFill>
+                        <a:srgbClr val="D5DEE4"/>
+                      </a:solidFill>
+                      <a:prstDash val="solid"/>
+                      <a:round/>
+                      <a:headEnd type="none" w="med" len="med"/>
+                      <a:tailEnd type="none" w="med" len="med"/>
+                    </a:lnT>
+                    <a:lnB w="6350" cap="flat" cmpd="sng" algn="ctr">
+                      <a:solidFill>
+                        <a:srgbClr val="D5DEE4"/>
+                      </a:solidFill>
+                      <a:prstDash val="solid"/>
+                      <a:round/>
+                      <a:headEnd type="none" w="med" len="med"/>
+                      <a:tailEnd type="none" w="med" len="med"/>
+                    </a:lnB>
+                  </a:tcPr>
+                </a:tc>
+              </a:tr>
+            </a:tbl>
+          </a:graphicData>
+        </a:graphic>
+      </p:graphicFrame>
+      <p:sp>
+        <p:nvSpPr>
+          <p:cNvPr id="8" name="projection note"/>
+          <p:cNvSpPr txBox="1"/>
+          <p:nvPr/>
+        </p:nvSpPr>
+        <p:spPr>
+          <a:xfrm>
+            <a:off x="5852160" y="3520440"/>
+            <a:ext cx="5760720" cy="320040"/>
+          </a:xfrm>
+          <a:prstGeom prst="rect">
+            <a:avLst/>
+          </a:prstGeom>
+          <a:noFill/>
+          <a:ln/>
+        </p:spPr>
+        <p:txBody>
+          <a:bodyPr wrap="square" lIns="0" tIns="0" rIns="0" bIns="0" rtlCol="0" anchor="ctr"/>
+          <a:lstStyle/>
+          <a:p>
+            <a:pPr indent="0" marL="0">
+              <a:buNone/>
+            </a:pPr>
+            <a:r>
+              <a:rPr lang="en-US" sz="1200" i="1" dirty="0">
+                <a:solidFill>
+                  <a:schemeClr val="accent5"/>
+                </a:solidFill>
+                <a:latin typeface="Calibri" pitchFamily="34" charset="0"/>
+                <a:ea typeface="Calibri" pitchFamily="34" charset="-122"/>
+                <a:cs typeface="Calibri" pitchFamily="34" charset="-120"/>
+              </a:rPr>
+              <a:t>Green fits the 18-hour queue; red does not.</a:t>
+            </a:r>
+            <a:endParaRPr lang="en-US" sz="1200" dirty="0"/>
+          </a:p>
+        </p:txBody>
+      </p:sp>
+      <p:sp>
+        <p:nvSpPr>
+          <p:cNvPr id="9" name="design card"/>
+          <p:cNvSpPr/>
+          <p:nvPr/>
+        </p:nvSpPr>
+        <p:spPr>
+          <a:xfrm>
+            <a:off x="5852160" y="4023360"/>
+            <a:ext cx="5760720" cy="2057400"/>
+          </a:xfrm>
+          <a:prstGeom prst="roundRect">
+            <a:avLst>
+              <a:gd name="adj" fmla="val 3556"/>
+            </a:avLst>
+          </a:prstGeom>
+          <a:solidFill>
+            <a:schemeClr val="bg2"/>
+          </a:solidFill>
+          <a:ln w="12700">
+            <a:solidFill>
+              <a:schemeClr val="bg2"/>
+            </a:solidFill>
+            <a:prstDash val="solid"/>
+          </a:ln>
+        </p:spPr>
+      </p:sp>
+      <p:sp>
+        <p:nvSpPr>
+          <p:cNvPr id="10" name="design head"/>
+          <p:cNvSpPr txBox="1"/>
+          <p:nvPr/>
+        </p:nvSpPr>
+        <p:spPr>
+          <a:xfrm>
+            <a:off x="6035040" y="4114800"/>
+            <a:ext cx="5394960" cy="365760"/>
+          </a:xfrm>
+          <a:prstGeom prst="rect">
+            <a:avLst/>
+          </a:prstGeom>
+          <a:noFill/>
+          <a:ln/>
+        </p:spPr>
+        <p:txBody>
+          <a:bodyPr wrap="square" lIns="0" tIns="0" rIns="0" bIns="0" rtlCol="0" anchor="ctr"/>
+          <a:lstStyle/>
+          <a:p>
+            <a:pPr indent="0" marL="0">
+              <a:buNone/>
+            </a:pPr>
+            <a:r>
+              <a:rPr lang="en-US" sz="1700" b="1" dirty="0">
+                <a:solidFill>
+                  <a:schemeClr val="tx2"/>
+                </a:solidFill>
+                <a:latin typeface="Calibri" pitchFamily="34" charset="0"/>
+                <a:ea typeface="Calibri" pitchFamily="34" charset="-122"/>
+                <a:cs typeface="Calibri" pitchFamily="34" charset="-120"/>
+              </a:rPr>
+              <a:t>Design change for the Mac day</a:t>
+            </a:r>
+            <a:endParaRPr lang="en-US" sz="1700" dirty="0"/>
+          </a:p>
+        </p:txBody>
+      </p:sp>
+      <p:sp>
+        <p:nvSpPr>
+          <p:cNvPr id="11" name="design bullets"/>
+          <p:cNvSpPr txBox="1"/>
+          <p:nvPr/>
+        </p:nvSpPr>
+        <p:spPr>
+          <a:xfrm>
+            <a:off x="6035040" y="4526280"/>
+            <a:ext cx="5394960" cy="1508760"/>
+          </a:xfrm>
+          <a:prstGeom prst="rect">
+            <a:avLst/>
+          </a:prstGeom>
+          <a:noFill/>
+          <a:ln/>
+        </p:spPr>
+        <p:txBody>
+          <a:bodyPr wrap="square" lIns="0" tIns="0" rIns="0" bIns="0" rtlCol="0" anchor="t"/>
+          <a:lstStyle/>
+          <a:p>
+            <a:pPr marL="203200" indent="-203200">
+              <a:spcAft>
+                <a:spcPts val="500"/>
+              </a:spcAft>
+              <a:buSzPct val="100000"/>
+              <a:buChar char="•"/>
+            </a:pPr>
+            <a:r>
+              <a:rPr lang="en-US" sz="1300" dirty="0">
+                <a:solidFill>
+                  <a:schemeClr val="tx1"/>
+                </a:solidFill>
+                <a:latin typeface="Calibri" pitchFamily="34" charset="0"/>
+                <a:ea typeface="Calibri" pitchFamily="34" charset="-122"/>
+                <a:cs typeface="Calibri" pitchFamily="34" charset="-120"/>
+              </a:rPr>
+              <a:t>Full table in the configuration that ships (KleidiAI); the fair baseline (stock) only for the reference, uniform baselines and greedy chain</a:t>
+            </a:r>
+            <a:endParaRPr lang="en-US" sz="1300" dirty="0"/>
+          </a:p>
+          <a:p>
+            <a:pPr marL="203200" indent="-203200">
+              <a:spcAft>
+                <a:spcPts val="500"/>
+              </a:spcAft>
+              <a:buSzPct val="100000"/>
+              <a:buChar char="•"/>
+            </a:pPr>
+            <a:r>
+              <a:rPr lang="en-US" sz="1300" dirty="0">
+                <a:solidFill>
+                  <a:schemeClr val="tx1"/>
+                </a:solidFill>
+                <a:latin typeface="Calibri" pitchFamily="34" charset="0"/>
+                <a:ea typeface="Calibri" pitchFamily="34" charset="-122"/>
+                <a:cs typeface="Calibri" pitchFamily="34" charset="-120"/>
+              </a:rPr>
+              <a:t>The M4's speedup is unknown: measure decode speed first, then size the queue</a:t>
+            </a:r>
+            <a:endParaRPr lang="en-US" sz="1300" dirty="0"/>
+          </a:p>
+          <a:p>
+            <a:pPr marL="203200" indent="-203200">
+              <a:spcAft>
+                <a:spcPts val="500"/>
+              </a:spcAft>
+              <a:buSzPct val="100000"/>
+              <a:buChar char="•"/>
+            </a:pPr>
+            <a:r>
+              <a:rPr lang="en-US" sz="1300" dirty="0">
+                <a:solidFill>
+                  <a:schemeClr val="tx1"/>
+                </a:solidFill>
+                <a:latin typeface="Calibri" pitchFamily="34" charset="0"/>
+                <a:ea typeface="Calibri" pitchFamily="34" charset="-122"/>
+                <a:cs typeface="Calibri" pitchFamily="34" charset="-120"/>
+              </a:rPr>
+              <a:t>Measured speeds match the calibrated model within 4%</a:t>
+            </a:r>
+            <a:endParaRPr lang="en-US" sz="1300" dirty="0"/>
+          </a:p>
+        </p:txBody>
+      </p:sp>
+      <p:sp>
+        <p:nvSpPr>
+          <p:cNvPr id="25" name="Slide Number Placeholder 0"/>
+          <p:cNvSpPr>
+            <a:spLocks noGrp="1"/>
+          </p:cNvSpPr>
+          <p:nvPr>
+            <p:ph type="sldNum" sz="quarter" idx="4294967295"/>
+          </p:nvPr>
+        </p:nvSpPr>
+        <p:spPr>
+          <a:xfrm>
+            <a:off x="11155680" y="6400800"/>
+            <a:ext cx="548640" cy="274320"/>
+          </a:xfrm>
+          <a:prstGeom prst="rect">
+            <a:avLst/>
+          </a:prstGeom>
+          <a:extLst>
+            <a:ext uri="{C572A759-6A51-4108-AA02-DFA0A04FC94B}">
+              <ma14:wrappingTextBoxFlag xmlns:ma14="http://schemas.microsoft.com/office/mac/drawingml/2011/main" val="0"/>
+            </a:ext>
+          </a:extLst>
+        </p:spPr>
+        <p:txBody>
+          <a:bodyPr/>
+          <a:lstStyle>
+            <a:lvl1pPr>
+              <a:defRPr sz="1100">
+                <a:solidFill>
+                  <a:schemeClr val="accent5"/>
+                </a:solidFill>
+                <a:latin typeface="Calibri"/>
+                <a:ea typeface="Calibri"/>
+                <a:cs typeface="Calibri"/>
+              </a:defRPr>
+            </a:lvl1pPr>
+          </a:lstStyle>
+          <a:p>
+            <a:pPr algn="r"/>
+            <a:fld id="{F7021451-1387-4CA6-816F-3879F97B5CBC}" type="slidenum">
+              <a:rPr b="0" lang="en-US"/>
+              <a:t>12</a:t>
+            </a:fld>
+            <a:endParaRPr lang="en-US"/>
+          </a:p>
+        </p:txBody>
+      </p:sp>
+    </p:spTree>
+  </p:cSld>
+  <p:clrMapOvr>
+    <a:masterClrMapping/>
+  </p:clrMapOvr>
+</p:sld>
+</file>
+
+<file path=ppt/slides/slide13.xml><?xml version="1.0" encoding="utf-8"?>
+<p:sld xmlns:a="http://schemas.openxmlformats.org/drawingml/2006/main" xmlns:r="http://schemas.openxmlformats.org/officeDocument/2006/relationships" xmlns:p="http://schemas.openxmlformats.org/presentationml/2006/main">
+  <p:cSld name="Slide 13">
+    <p:spTree>
+      <p:nvGrpSpPr>
+        <p:cNvPr id="1" name=""/>
+        <p:cNvGrpSpPr/>
+        <p:nvPr/>
+      </p:nvGrpSpPr>
+      <p:grpSpPr>
+        <a:xfrm>
+          <a:off x="0" y="0"/>
+          <a:ext cx="0" cy="0"/>
+          <a:chOff x="0" y="0"/>
+          <a:chExt cx="0" cy="0"/>
+        </a:xfrm>
+      </p:grpSpPr>
+      <p:sp>
+        <p:nvSpPr>
+          <p:cNvPr id="2" name="Text 0"/>
+          <p:cNvSpPr/>
+          <p:nvPr>
+            <p:ph idx="100" type="title" hasCustomPrompt="1"/>
+          </p:nvPr>
+        </p:nvSpPr>
+        <p:spPr>
+          <a:xfrm>
+            <a:off x="548640" y="320040"/>
+            <a:ext cx="11064240" cy="868680"/>
+          </a:xfrm>
+          <a:prstGeom prst="rect">
+            <a:avLst/>
+          </a:prstGeom>
+          <a:noFill/>
+          <a:ln/>
+        </p:spPr>
+        <p:txBody>
+          <a:bodyPr wrap="square" lIns="0" tIns="0" rIns="0" bIns="0" rtlCol="0" anchor="ctr"/>
+          <a:lstStyle/>
+          <a:p>
+            <a:pPr algn="l" indent="0" marL="0">
+              <a:buNone/>
+            </a:pPr>
+            <a:r>
+              <a:rPr lang="en-US" sz="2800" b="1" dirty="0">
+                <a:solidFill>
+                  <a:schemeClr val="tx2"/>
+                </a:solidFill>
+                <a:latin typeface="+mj-lt" pitchFamily="34" charset="0"/>
+                <a:ea typeface="+mj-lt" pitchFamily="34" charset="-122"/>
+                <a:cs typeface="+mj-lt" pitchFamily="34" charset="-120"/>
+              </a:rPr>
+              <a:t>The rehearsal found five problems before the paid block</a:t>
+            </a:r>
+            <a:endParaRPr lang="en-US" sz="2800" dirty="0"/>
+          </a:p>
+        </p:txBody>
+      </p:sp>
+      <p:sp>
+        <p:nvSpPr>
+          <p:cNvPr id="3" name="problem card 1"/>
+          <p:cNvSpPr/>
+          <p:nvPr/>
+        </p:nvSpPr>
+        <p:spPr>
+          <a:xfrm>
+            <a:off x="548640" y="1371600"/>
+            <a:ext cx="11064240" cy="841248"/>
+          </a:xfrm>
+          <a:prstGeom prst="roundRect">
+            <a:avLst>
+              <a:gd name="adj" fmla="val 8696"/>
+            </a:avLst>
+          </a:prstGeom>
+          <a:solidFill>
+            <a:schemeClr val="bg2"/>
+          </a:solidFill>
+          <a:ln w="12700">
+            <a:solidFill>
+              <a:schemeClr val="bg2"/>
+            </a:solidFill>
+            <a:prstDash val="solid"/>
+          </a:ln>
+        </p:spPr>
+      </p:sp>
+      <p:sp>
+        <p:nvSpPr>
+          <p:cNvPr id="4" name="problem 1 circle"/>
+          <p:cNvSpPr/>
+          <p:nvPr/>
+        </p:nvSpPr>
+        <p:spPr>
+          <a:xfrm>
+            <a:off x="731520" y="1490472"/>
+            <a:ext cx="603504" cy="603504"/>
+          </a:xfrm>
+          <a:prstGeom prst="ellipse">
+            <a:avLst/>
+          </a:prstGeom>
+          <a:solidFill>
+            <a:srgbClr val="D1495B"/>
+          </a:solidFill>
+          <a:ln w="12700">
+            <a:solidFill>
+              <a:srgbClr val="D1495B"/>
+            </a:solidFill>
+            <a:prstDash val="solid"/>
+          </a:ln>
+        </p:spPr>
+      </p:sp>
+      <p:pic>
+        <p:nvPicPr>
+          <p:cNvPr id="5" name="problem 1 icon" descr="preencoded.png">    </p:cNvPr>
+          <p:cNvPicPr>
+            <a:picLocks noChangeAspect="1"/>
+          </p:cNvPicPr>
+          <p:nvPr/>
+        </p:nvPicPr>
+        <p:blipFill>
+          <a:blip r:embed="rId1"/>
+          <a:stretch>
+            <a:fillRect/>
+          </a:stretch>
+        </p:blipFill>
+        <p:spPr>
+          <a:xfrm>
+            <a:off x="882396" y="1641348"/>
+            <a:ext cx="301752" cy="301752"/>
+          </a:xfrm>
+          <a:prstGeom prst="rect">
+            <a:avLst/>
+          </a:prstGeom>
+        </p:spPr>
+      </p:pic>
+      <p:sp>
+        <p:nvSpPr>
+          <p:cNvPr id="6" name="problem 1 head"/>
+          <p:cNvSpPr txBox="1"/>
+          <p:nvPr/>
+        </p:nvSpPr>
+        <p:spPr>
+          <a:xfrm>
+            <a:off x="1554480" y="1426464"/>
+            <a:ext cx="3200400" cy="731520"/>
+          </a:xfrm>
+          <a:prstGeom prst="rect">
+            <a:avLst/>
+          </a:prstGeom>
+          <a:noFill/>
+          <a:ln/>
+        </p:spPr>
+        <p:txBody>
+          <a:bodyPr wrap="square" lIns="0" tIns="0" rIns="0" bIns="0" rtlCol="0" anchor="ctr"/>
+          <a:lstStyle/>
+          <a:p>
+            <a:pPr indent="0" marL="0">
+              <a:buNone/>
+            </a:pPr>
+            <a:r>
+              <a:rPr lang="en-US" sz="1600" b="1" dirty="0">
+                <a:solidFill>
+                  <a:schemeClr val="tx2"/>
+                </a:solidFill>
+                <a:latin typeface="Calibri" pitchFamily="34" charset="0"/>
+                <a:ea typeface="Calibri" pitchFamily="34" charset="-122"/>
+                <a:cs typeface="Calibri" pitchFamily="34" charset="-120"/>
+              </a:rPr>
+              <a:t>Scratch disk was RAM-backed</a:t>
+            </a:r>
+            <a:endParaRPr lang="en-US" sz="1600" dirty="0"/>
+          </a:p>
+        </p:txBody>
+      </p:sp>
+      <p:sp>
+        <p:nvSpPr>
+          <p:cNvPr id="7" name="problem 1 body"/>
+          <p:cNvSpPr txBox="1"/>
+          <p:nvPr/>
+        </p:nvSpPr>
+        <p:spPr>
+          <a:xfrm>
+            <a:off x="4846320" y="1426464"/>
+            <a:ext cx="6675120" cy="731520"/>
+          </a:xfrm>
+          <a:prstGeom prst="rect">
+            <a:avLst/>
+          </a:prstGeom>
+          <a:noFill/>
+          <a:ln/>
+        </p:spPr>
+        <p:txBody>
+          <a:bodyPr wrap="square" lIns="0" tIns="0" rIns="0" bIns="0" rtlCol="0" anchor="ctr"/>
+          <a:lstStyle/>
+          <a:p>
+            <a:pPr indent="0" marL="0">
+              <a:buNone/>
+            </a:pPr>
+            <a:r>
+              <a:rPr lang="en-US" sz="1300" dirty="0">
+                <a:solidFill>
+                  <a:schemeClr val="tx1"/>
+                </a:solidFill>
+                <a:latin typeface="Calibri" pitchFamily="34" charset="0"/>
+                <a:ea typeface="Calibri" pitchFamily="34" charset="-122"/>
+                <a:cs typeface="Calibri" pitchFamily="34" charset="-120"/>
+              </a:rPr>
+              <a:t>Ubuntu 26.04 mounts /tmp as an 8 GB tmpfs, and the gate demanded space for every source file. The selftest stopped the queue early. Fix: scratch on disk, real space check.</a:t>
+            </a:r>
+            <a:endParaRPr lang="en-US" sz="1300" dirty="0"/>
+          </a:p>
+        </p:txBody>
+      </p:sp>
+      <p:sp>
+        <p:nvSpPr>
+          <p:cNvPr id="8" name="problem card 2"/>
+          <p:cNvSpPr/>
+          <p:nvPr/>
+        </p:nvSpPr>
+        <p:spPr>
+          <a:xfrm>
+            <a:off x="548640" y="2331720"/>
+            <a:ext cx="11064240" cy="841248"/>
+          </a:xfrm>
+          <a:prstGeom prst="roundRect">
+            <a:avLst>
+              <a:gd name="adj" fmla="val 8696"/>
+            </a:avLst>
+          </a:prstGeom>
+          <a:solidFill>
+            <a:schemeClr val="bg2"/>
+          </a:solidFill>
+          <a:ln w="12700">
+            <a:solidFill>
+              <a:schemeClr val="bg2"/>
+            </a:solidFill>
+            <a:prstDash val="solid"/>
+          </a:ln>
+        </p:spPr>
+      </p:sp>
+      <p:sp>
+        <p:nvSpPr>
+          <p:cNvPr id="9" name="problem 2 circle"/>
+          <p:cNvSpPr/>
+          <p:nvPr/>
+        </p:nvSpPr>
+        <p:spPr>
+          <a:xfrm>
+            <a:off x="731520" y="2450592"/>
+            <a:ext cx="603504" cy="603504"/>
+          </a:xfrm>
+          <a:prstGeom prst="ellipse">
+            <a:avLst/>
+          </a:prstGeom>
+          <a:solidFill>
+            <a:srgbClr val="F2A541"/>
+          </a:solidFill>
+          <a:ln w="12700">
+            <a:solidFill>
+              <a:srgbClr val="F2A541"/>
+            </a:solidFill>
+            <a:prstDash val="solid"/>
+          </a:ln>
+        </p:spPr>
+      </p:sp>
+      <p:pic>
+        <p:nvPicPr>
+          <p:cNvPr id="10" name="problem 2 icon" descr="preencoded.png">    </p:cNvPr>
+          <p:cNvPicPr>
+            <a:picLocks noChangeAspect="1"/>
+          </p:cNvPicPr>
+          <p:nvPr/>
+        </p:nvPicPr>
+        <p:blipFill>
+          <a:blip r:embed="rId2"/>
+          <a:stretch>
+            <a:fillRect/>
+          </a:stretch>
+        </p:blipFill>
+        <p:spPr>
+          <a:xfrm>
+            <a:off x="882396" y="2601468"/>
+            <a:ext cx="301752" cy="301752"/>
+          </a:xfrm>
+          <a:prstGeom prst="rect">
+            <a:avLst/>
+          </a:prstGeom>
+        </p:spPr>
+      </p:pic>
+      <p:sp>
+        <p:nvSpPr>
+          <p:cNvPr id="11" name="problem 2 head"/>
+          <p:cNvSpPr txBox="1"/>
+          <p:nvPr/>
+        </p:nvSpPr>
+        <p:spPr>
+          <a:xfrm>
+            <a:off x="1554480" y="2386584"/>
+            <a:ext cx="3200400" cy="731520"/>
+          </a:xfrm>
+          <a:prstGeom prst="rect">
+            <a:avLst/>
+          </a:prstGeom>
+          <a:noFill/>
+          <a:ln/>
+        </p:spPr>
+        <p:txBody>
+          <a:bodyPr wrap="square" lIns="0" tIns="0" rIns="0" bIns="0" rtlCol="0" anchor="ctr"/>
+          <a:lstStyle/>
+          <a:p>
+            <a:pPr indent="0" marL="0">
+              <a:buNone/>
+            </a:pPr>
+            <a:r>
+              <a:rPr lang="en-US" sz="1600" b="1" dirty="0">
+                <a:solidFill>
+                  <a:schemeClr val="tx2"/>
+                </a:solidFill>
+                <a:latin typeface="Calibri" pitchFamily="34" charset="0"/>
+                <a:ea typeface="Calibri" pitchFamily="34" charset="-122"/>
+                <a:cs typeface="Calibri" pitchFamily="34" charset="-120"/>
+              </a:rPr>
+              <a:t>Idle time ate the budget</a:t>
+            </a:r>
+            <a:endParaRPr lang="en-US" sz="1600" dirty="0"/>
+          </a:p>
+        </p:txBody>
+      </p:sp>
+      <p:sp>
+        <p:nvSpPr>
+          <p:cNvPr id="12" name="problem 2 body"/>
+          <p:cNvSpPr txBox="1"/>
+          <p:nvPr/>
+        </p:nvSpPr>
+        <p:spPr>
+          <a:xfrm>
+            <a:off x="4846320" y="2386584"/>
+            <a:ext cx="6675120" cy="731520"/>
+          </a:xfrm>
+          <a:prstGeom prst="rect">
+            <a:avLst/>
+          </a:prstGeom>
+          <a:noFill/>
+          <a:ln/>
+        </p:spPr>
+        <p:txBody>
+          <a:bodyPr wrap="square" lIns="0" tIns="0" rIns="0" bIns="0" rtlCol="0" anchor="ctr"/>
+          <a:lstStyle/>
+          <a:p>
+            <a:pPr indent="0" marL="0">
+              <a:buNone/>
+            </a:pPr>
+            <a:r>
+              <a:rPr lang="en-US" sz="1300" dirty="0">
+                <a:solidFill>
+                  <a:schemeClr val="tx1"/>
+                </a:solidFill>
+                <a:latin typeface="Calibri" pitchFamily="34" charset="0"/>
+                <a:ea typeface="Calibri" pitchFamily="34" charset="-122"/>
+                <a:cs typeface="Calibri" pitchFamily="34" charset="-120"/>
+              </a:rPr>
+              <a:t>The deadline was fixed at the first start, so two idle hours left the table job 49 minutes. Fix: --restart-clock re-anchors it.</a:t>
+            </a:r>
+            <a:endParaRPr lang="en-US" sz="1300" dirty="0"/>
+          </a:p>
+        </p:txBody>
+      </p:sp>
+      <p:sp>
+        <p:nvSpPr>
+          <p:cNvPr id="13" name="problem card 3"/>
+          <p:cNvSpPr/>
+          <p:nvPr/>
+        </p:nvSpPr>
+        <p:spPr>
+          <a:xfrm>
+            <a:off x="548640" y="3291840"/>
+            <a:ext cx="11064240" cy="841248"/>
+          </a:xfrm>
+          <a:prstGeom prst="roundRect">
+            <a:avLst>
+              <a:gd name="adj" fmla="val 8696"/>
+            </a:avLst>
+          </a:prstGeom>
+          <a:solidFill>
+            <a:schemeClr val="bg2"/>
+          </a:solidFill>
+          <a:ln w="12700">
+            <a:solidFill>
+              <a:schemeClr val="bg2"/>
+            </a:solidFill>
+            <a:prstDash val="solid"/>
+          </a:ln>
+        </p:spPr>
+      </p:sp>
+      <p:sp>
+        <p:nvSpPr>
+          <p:cNvPr id="14" name="problem 3 circle"/>
+          <p:cNvSpPr/>
+          <p:nvPr/>
+        </p:nvSpPr>
+        <p:spPr>
+          <a:xfrm>
+            <a:off x="731520" y="3410712"/>
+            <a:ext cx="603504" cy="603504"/>
+          </a:xfrm>
+          <a:prstGeom prst="ellipse">
+            <a:avLst/>
+          </a:prstGeom>
+          <a:solidFill>
+            <a:srgbClr val="7B6FB5"/>
+          </a:solidFill>
+          <a:ln w="12700">
+            <a:solidFill>
+              <a:srgbClr val="7B6FB5"/>
+            </a:solidFill>
+            <a:prstDash val="solid"/>
+          </a:ln>
+        </p:spPr>
+      </p:sp>
+      <p:pic>
+        <p:nvPicPr>
+          <p:cNvPr id="15" name="problem 3 icon" descr="preencoded.png">    </p:cNvPr>
+          <p:cNvPicPr>
+            <a:picLocks noChangeAspect="1"/>
+          </p:cNvPicPr>
+          <p:nvPr/>
+        </p:nvPicPr>
+        <p:blipFill>
+          <a:blip r:embed="rId3"/>
+          <a:stretch>
+            <a:fillRect/>
+          </a:stretch>
+        </p:blipFill>
+        <p:spPr>
+          <a:xfrm>
+            <a:off x="882396" y="3561588"/>
+            <a:ext cx="301752" cy="301752"/>
+          </a:xfrm>
+          <a:prstGeom prst="rect">
+            <a:avLst/>
+          </a:prstGeom>
+        </p:spPr>
+      </p:pic>
+      <p:sp>
+        <p:nvSpPr>
+          <p:cNvPr id="16" name="problem 3 head"/>
+          <p:cNvSpPr txBox="1"/>
+          <p:nvPr/>
+        </p:nvSpPr>
+        <p:spPr>
+          <a:xfrm>
+            <a:off x="1554480" y="3346704"/>
+            <a:ext cx="3200400" cy="731520"/>
+          </a:xfrm>
+          <a:prstGeom prst="rect">
+            <a:avLst/>
+          </a:prstGeom>
+          <a:noFill/>
+          <a:ln/>
+        </p:spPr>
+        <p:txBody>
+          <a:bodyPr wrap="square" lIns="0" tIns="0" rIns="0" bIns="0" rtlCol="0" anchor="ctr"/>
+          <a:lstStyle/>
+          <a:p>
+            <a:pPr indent="0" marL="0">
+              <a:buNone/>
+            </a:pPr>
+            <a:r>
+              <a:rPr lang="en-US" sz="1600" b="1" dirty="0">
+                <a:solidFill>
+                  <a:schemeClr val="tx2"/>
+                </a:solidFill>
+                <a:latin typeface="Calibri" pitchFamily="34" charset="0"/>
+                <a:ea typeface="Calibri" pitchFamily="34" charset="-122"/>
+                <a:cs typeface="Calibri" pitchFamily="34" charset="-120"/>
+              </a:rPr>
+              <a:t>A job was killed mid-genome</a:t>
+            </a:r>
+            <a:endParaRPr lang="en-US" sz="1600" dirty="0"/>
+          </a:p>
+        </p:txBody>
+      </p:sp>
+      <p:sp>
+        <p:nvSpPr>
+          <p:cNvPr id="17" name="problem 3 body"/>
+          <p:cNvSpPr txBox="1"/>
+          <p:nvPr/>
+        </p:nvSpPr>
+        <p:spPr>
+          <a:xfrm>
+            <a:off x="4846320" y="3346704"/>
+            <a:ext cx="6675120" cy="731520"/>
+          </a:xfrm>
+          <a:prstGeom prst="rect">
+            <a:avLst/>
+          </a:prstGeom>
+          <a:noFill/>
+          <a:ln/>
+        </p:spPr>
+        <p:txBody>
+          <a:bodyPr wrap="square" lIns="0" tIns="0" rIns="0" bIns="0" rtlCol="0" anchor="ctr"/>
+          <a:lstStyle/>
+          <a:p>
+            <a:pPr indent="0" marL="0">
+              <a:buNone/>
+            </a:pPr>
+            <a:r>
+              <a:rPr lang="en-US" sz="1300" dirty="0">
+                <a:solidFill>
+                  <a:schemeClr val="tx1"/>
+                </a:solidFill>
+                <a:latin typeface="Calibri" pitchFamily="34" charset="0"/>
+                <a:ea typeface="Calibri" pitchFamily="34" charset="-122"/>
+                <a:cs typeface="Calibri" pitchFamily="34" charset="-120"/>
+              </a:rPr>
+              <a:t>A hard timeout lost the genome in flight and skipped the analysis. Fix: stop before a genome that would overrun; analysis jobs always run.</a:t>
+            </a:r>
+            <a:endParaRPr lang="en-US" sz="1300" dirty="0"/>
+          </a:p>
+        </p:txBody>
+      </p:sp>
+      <p:sp>
+        <p:nvSpPr>
+          <p:cNvPr id="18" name="problem card 4"/>
+          <p:cNvSpPr/>
+          <p:nvPr/>
+        </p:nvSpPr>
+        <p:spPr>
+          <a:xfrm>
+            <a:off x="548640" y="4251960"/>
+            <a:ext cx="11064240" cy="841248"/>
+          </a:xfrm>
+          <a:prstGeom prst="roundRect">
+            <a:avLst>
+              <a:gd name="adj" fmla="val 8696"/>
+            </a:avLst>
+          </a:prstGeom>
+          <a:solidFill>
+            <a:schemeClr val="bg2"/>
+          </a:solidFill>
+          <a:ln w="12700">
+            <a:solidFill>
+              <a:schemeClr val="bg2"/>
+            </a:solidFill>
+            <a:prstDash val="solid"/>
+          </a:ln>
+        </p:spPr>
+      </p:sp>
+      <p:sp>
+        <p:nvSpPr>
+          <p:cNvPr id="19" name="problem 4 circle"/>
+          <p:cNvSpPr/>
+          <p:nvPr/>
+        </p:nvSpPr>
+        <p:spPr>
+          <a:xfrm>
+            <a:off x="731520" y="4370832"/>
+            <a:ext cx="603504" cy="603504"/>
+          </a:xfrm>
+          <a:prstGeom prst="ellipse">
+            <a:avLst/>
+          </a:prstGeom>
+          <a:solidFill>
+            <a:srgbClr val="0A7EA4"/>
+          </a:solidFill>
+          <a:ln w="12700">
+            <a:solidFill>
+              <a:srgbClr val="0A7EA4"/>
+            </a:solidFill>
+            <a:prstDash val="solid"/>
+          </a:ln>
+        </p:spPr>
+      </p:sp>
+      <p:pic>
+        <p:nvPicPr>
+          <p:cNvPr id="20" name="problem 4 icon" descr="preencoded.png">    </p:cNvPr>
+          <p:cNvPicPr>
+            <a:picLocks noChangeAspect="1"/>
+          </p:cNvPicPr>
+          <p:nvPr/>
+        </p:nvPicPr>
+        <p:blipFill>
+          <a:blip r:embed="rId4"/>
+          <a:stretch>
+            <a:fillRect/>
+          </a:stretch>
+        </p:blipFill>
+        <p:spPr>
+          <a:xfrm>
+            <a:off x="882396" y="4521708"/>
+            <a:ext cx="301752" cy="301752"/>
+          </a:xfrm>
+          <a:prstGeom prst="rect">
+            <a:avLst/>
+          </a:prstGeom>
+        </p:spPr>
+      </p:pic>
+      <p:sp>
+        <p:nvSpPr>
+          <p:cNvPr id="21" name="problem 4 head"/>
+          <p:cNvSpPr txBox="1"/>
+          <p:nvPr/>
+        </p:nvSpPr>
+        <p:spPr>
+          <a:xfrm>
+            <a:off x="1554480" y="4306824"/>
+            <a:ext cx="3200400" cy="731520"/>
+          </a:xfrm>
+          <a:prstGeom prst="rect">
+            <a:avLst/>
+          </a:prstGeom>
+          <a:noFill/>
+          <a:ln/>
+        </p:spPr>
+        <p:txBody>
+          <a:bodyPr wrap="square" lIns="0" tIns="0" rIns="0" bIns="0" rtlCol="0" anchor="ctr"/>
+          <a:lstStyle/>
+          <a:p>
+            <a:pPr indent="0" marL="0">
+              <a:buNone/>
+            </a:pPr>
+            <a:r>
+              <a:rPr lang="en-US" sz="1600" b="1" dirty="0">
+                <a:solidFill>
+                  <a:schemeClr val="tx2"/>
+                </a:solidFill>
+                <a:latin typeface="Calibri" pitchFamily="34" charset="0"/>
+                <a:ea typeface="Calibri" pitchFamily="34" charset="-122"/>
+                <a:cs typeface="Calibri" pitchFamily="34" charset="-120"/>
+              </a:rPr>
+              <a:t>No baseline in a restricted table</a:t>
+            </a:r>
+            <a:endParaRPr lang="en-US" sz="1600" dirty="0"/>
+          </a:p>
+        </p:txBody>
+      </p:sp>
+      <p:sp>
+        <p:nvSpPr>
+          <p:cNvPr id="22" name="problem 4 body"/>
+          <p:cNvSpPr txBox="1"/>
+          <p:nvPr/>
+        </p:nvSpPr>
+        <p:spPr>
+          <a:xfrm>
+            <a:off x="4846320" y="4306824"/>
+            <a:ext cx="6675120" cy="731520"/>
+          </a:xfrm>
+          <a:prstGeom prst="rect">
+            <a:avLst/>
+          </a:prstGeom>
+          <a:noFill/>
+          <a:ln/>
+        </p:spPr>
+        <p:txBody>
+          <a:bodyPr wrap="square" lIns="0" tIns="0" rIns="0" bIns="0" rtlCol="0" anchor="ctr"/>
+          <a:lstStyle/>
+          <a:p>
+            <a:pPr indent="0" marL="0">
+              <a:buNone/>
+            </a:pPr>
+            <a:r>
+              <a:rPr lang="en-US" sz="1300" dirty="0">
+                <a:solidFill>
+                  <a:schemeClr val="tx1"/>
+                </a:solidFill>
+                <a:latin typeface="Calibri" pitchFamily="34" charset="0"/>
+                <a:ea typeface="Calibri" pitchFamily="34" charset="-122"/>
+                <a:cs typeface="Calibri" pitchFamily="34" charset="-120"/>
+              </a:rPr>
+              <a:t>A Q8_0/Q4_0-only table had no F16 reference row (found on the desktop). Fix: always measure the reference first; the analyzer falls back with a warning.</a:t>
+            </a:r>
+            <a:endParaRPr lang="en-US" sz="1300" dirty="0"/>
+          </a:p>
+        </p:txBody>
+      </p:sp>
+      <p:sp>
+        <p:nvSpPr>
+          <p:cNvPr id="23" name="problem card 5"/>
+          <p:cNvSpPr/>
+          <p:nvPr/>
+        </p:nvSpPr>
+        <p:spPr>
+          <a:xfrm>
+            <a:off x="548640" y="5212080"/>
+            <a:ext cx="11064240" cy="841248"/>
+          </a:xfrm>
+          <a:prstGeom prst="roundRect">
+            <a:avLst>
+              <a:gd name="adj" fmla="val 8696"/>
+            </a:avLst>
+          </a:prstGeom>
+          <a:solidFill>
+            <a:schemeClr val="bg2"/>
+          </a:solidFill>
+          <a:ln w="12700">
+            <a:solidFill>
+              <a:schemeClr val="bg2"/>
+            </a:solidFill>
+            <a:prstDash val="solid"/>
+          </a:ln>
+        </p:spPr>
+      </p:sp>
+      <p:sp>
+        <p:nvSpPr>
+          <p:cNvPr id="24" name="problem 5 circle"/>
+          <p:cNvSpPr/>
+          <p:nvPr/>
+        </p:nvSpPr>
+        <p:spPr>
+          <a:xfrm>
+            <a:off x="731520" y="5330952"/>
+            <a:ext cx="603504" cy="603504"/>
+          </a:xfrm>
+          <a:prstGeom prst="ellipse">
+            <a:avLst/>
+          </a:prstGeom>
+          <a:solidFill>
+            <a:srgbClr val="6C7A89"/>
+          </a:solidFill>
+          <a:ln w="12700">
+            <a:solidFill>
+              <a:srgbClr val="6C7A89"/>
+            </a:solidFill>
+            <a:prstDash val="solid"/>
+          </a:ln>
+        </p:spPr>
+      </p:sp>
+      <p:pic>
+        <p:nvPicPr>
+          <p:cNvPr id="25" name="problem 5 icon" descr="preencoded.png">    </p:cNvPr>
+          <p:cNvPicPr>
+            <a:picLocks noChangeAspect="1"/>
+          </p:cNvPicPr>
+          <p:nvPr/>
+        </p:nvPicPr>
+        <p:blipFill>
+          <a:blip r:embed="rId5"/>
+          <a:stretch>
+            <a:fillRect/>
+          </a:stretch>
+        </p:blipFill>
+        <p:spPr>
+          <a:xfrm>
+            <a:off x="882396" y="5481828"/>
+            <a:ext cx="301752" cy="301752"/>
+          </a:xfrm>
+          <a:prstGeom prst="rect">
+            <a:avLst/>
+          </a:prstGeom>
+        </p:spPr>
+      </p:pic>
+      <p:sp>
+        <p:nvSpPr>
+          <p:cNvPr id="26" name="problem 5 head"/>
+          <p:cNvSpPr txBox="1"/>
+          <p:nvPr/>
+        </p:nvSpPr>
+        <p:spPr>
+          <a:xfrm>
+            <a:off x="1554480" y="5266944"/>
+            <a:ext cx="3200400" cy="731520"/>
+          </a:xfrm>
+          <a:prstGeom prst="rect">
+            <a:avLst/>
+          </a:prstGeom>
+          <a:noFill/>
+          <a:ln/>
+        </p:spPr>
+        <p:txBody>
+          <a:bodyPr wrap="square" lIns="0" tIns="0" rIns="0" bIns="0" rtlCol="0" anchor="ctr"/>
+          <a:lstStyle/>
+          <a:p>
+            <a:pPr indent="0" marL="0">
+              <a:buNone/>
+            </a:pPr>
+            <a:r>
+              <a:rPr lang="en-US" sz="1600" b="1" dirty="0">
+                <a:solidFill>
+                  <a:schemeClr val="tx2"/>
+                </a:solidFill>
+                <a:latin typeface="Calibri" pitchFamily="34" charset="0"/>
+                <a:ea typeface="Calibri" pitchFamily="34" charset="-122"/>
+                <a:cs typeface="Calibri" pitchFamily="34" charset="-120"/>
+              </a:rPr>
+              <a:t>A sync overwrote tracked evidence</a:t>
+            </a:r>
+            <a:endParaRPr lang="en-US" sz="1600" dirty="0"/>
+          </a:p>
+        </p:txBody>
+      </p:sp>
+      <p:sp>
+        <p:nvSpPr>
+          <p:cNvPr id="27" name="problem 5 body"/>
+          <p:cNvSpPr txBox="1"/>
+          <p:nvPr/>
+        </p:nvSpPr>
+        <p:spPr>
+          <a:xfrm>
+            <a:off x="4846320" y="5266944"/>
+            <a:ext cx="6675120" cy="731520"/>
+          </a:xfrm>
+          <a:prstGeom prst="rect">
+            <a:avLst/>
+          </a:prstGeom>
+          <a:noFill/>
+          <a:ln/>
+        </p:spPr>
+        <p:txBody>
+          <a:bodyPr wrap="square" lIns="0" tIns="0" rIns="0" bIns="0" rtlCol="0" anchor="ctr"/>
+          <a:lstStyle/>
+          <a:p>
+            <a:pPr indent="0" marL="0">
+              <a:buNone/>
+            </a:pPr>
+            <a:r>
+              <a:rPr lang="en-US" sz="1300" dirty="0">
+                <a:solidFill>
+                  <a:schemeClr val="tx1"/>
+                </a:solidFill>
+                <a:latin typeface="Calibri" pitchFamily="34" charset="0"/>
+                <a:ea typeface="Calibri" pitchFamily="34" charset="-122"/>
+                <a:cs typeface="Calibri" pitchFamily="34" charset="-120"/>
+              </a:rPr>
+              <a:t>Syncing results/ replaced the first Graviton files. Fix: restore from git, sync only rehearsal files; two instances agree within 2-3%.</a:t>
+            </a:r>
+            <a:endParaRPr lang="en-US" sz="1300" dirty="0"/>
+          </a:p>
+        </p:txBody>
+      </p:sp>
+      <p:sp>
+        <p:nvSpPr>
+          <p:cNvPr id="25" name="Slide Number Placeholder 0"/>
+          <p:cNvSpPr>
+            <a:spLocks noGrp="1"/>
+          </p:cNvSpPr>
+          <p:nvPr>
+            <p:ph type="sldNum" sz="quarter" idx="4294967295"/>
+          </p:nvPr>
+        </p:nvSpPr>
+        <p:spPr>
+          <a:xfrm>
+            <a:off x="11155680" y="6400800"/>
+            <a:ext cx="548640" cy="274320"/>
+          </a:xfrm>
+          <a:prstGeom prst="rect">
+            <a:avLst/>
+          </a:prstGeom>
+          <a:extLst>
+            <a:ext uri="{C572A759-6A51-4108-AA02-DFA0A04FC94B}">
+              <ma14:wrappingTextBoxFlag xmlns:ma14="http://schemas.microsoft.com/office/mac/drawingml/2011/main" val="0"/>
+            </a:ext>
+          </a:extLst>
+        </p:spPr>
+        <p:txBody>
+          <a:bodyPr/>
+          <a:lstStyle>
+            <a:lvl1pPr>
+              <a:defRPr sz="1100">
+                <a:solidFill>
+                  <a:schemeClr val="accent5"/>
+                </a:solidFill>
+                <a:latin typeface="Calibri"/>
+                <a:ea typeface="Calibri"/>
+                <a:cs typeface="Calibri"/>
+              </a:defRPr>
+            </a:lvl1pPr>
+          </a:lstStyle>
+          <a:p>
+            <a:pPr algn="r"/>
+            <a:fld id="{F7021451-1387-4CA6-816F-3879F97B5CBC}" type="slidenum">
+              <a:rPr b="0" lang="en-US"/>
+              <a:t>13</a:t>
+            </a:fld>
+            <a:endParaRPr lang="en-US"/>
+          </a:p>
+        </p:txBody>
+      </p:sp>
+    </p:spTree>
+  </p:cSld>
+  <p:clrMapOvr>
+    <a:masterClrMapping/>
+  </p:clrMapOvr>
+</p:sld>
+</file>
+
+<file path=ppt/slides/slide14.xml><?xml version="1.0" encoding="utf-8"?>
+<p:sld xmlns:a="http://schemas.openxmlformats.org/drawingml/2006/main" xmlns:r="http://schemas.openxmlformats.org/officeDocument/2006/relationships" xmlns:p="http://schemas.openxmlformats.org/presentationml/2006/main">
+  <p:cSld name="Slide 14">
+    <p:spTree>
+      <p:nvGrpSpPr>
+        <p:cNvPr id="1" name=""/>
+        <p:cNvGrpSpPr/>
+        <p:nvPr/>
+      </p:nvGrpSpPr>
+      <p:grpSpPr>
+        <a:xfrm>
+          <a:off x="0" y="0"/>
+          <a:ext cx="0" cy="0"/>
+          <a:chOff x="0" y="0"/>
+          <a:chExt cx="0" cy="0"/>
+        </a:xfrm>
+      </p:grpSpPr>
+      <p:sp>
+        <p:nvSpPr>
+          <p:cNvPr id="2" name="Text 0"/>
+          <p:cNvSpPr/>
+          <p:nvPr>
+            <p:ph idx="100" type="title" hasCustomPrompt="1"/>
+          </p:nvPr>
+        </p:nvSpPr>
+        <p:spPr>
+          <a:xfrm>
+            <a:off x="548640" y="320040"/>
+            <a:ext cx="11064240" cy="868680"/>
+          </a:xfrm>
+          <a:prstGeom prst="rect">
+            <a:avLst/>
+          </a:prstGeom>
+          <a:noFill/>
+          <a:ln/>
+        </p:spPr>
+        <p:txBody>
+          <a:bodyPr wrap="square" lIns="0" tIns="0" rIns="0" bIns="0" rtlCol="0" anchor="ctr"/>
+          <a:lstStyle/>
+          <a:p>
+            <a:pPr algn="l" indent="0" marL="0">
+              <a:buNone/>
+            </a:pPr>
+            <a:r>
+              <a:rPr lang="en-US" sz="2800" b="1" dirty="0">
+                <a:solidFill>
                   <a:schemeClr val="bg1"/>
                 </a:solidFill>
                 <a:latin typeface="+mj-lt" pitchFamily="34" charset="0"/>
@@ -6245,7 +9139,7 @@
                 <a:ea typeface="Calibri" pitchFamily="34" charset="-122"/>
                 <a:cs typeface="Calibri" pitchFamily="34" charset="-120"/>
               </a:rPr>
-              <a:t>Emulation and a $2 Graviton run found three issues before the 24-hour Mac block.</a:t>
+              <a:t>A few dollars of rehearsal found five problems and measured the cost of an evaluation before the 24-hour Mac block.</a:t>
             </a:r>
             <a:endParaRPr lang="en-US" sz="1300" dirty="0"/>
           </a:p>
@@ -6354,7 +9248,7 @@
                 <a:ea typeface="Calibri" pitchFamily="34" charset="-122"/>
                 <a:cs typeface="Calibri" pitchFamily="34" charset="-120"/>
               </a:rPr>
-              <a:t>T4, Apple M4: selftest gates (KleidiAI vs stock vs SME), thread scan, Pareto runs on two models; judge KleidiAI SME2 against a stock build</a:t>
+              <a:t>T4, Apple M4 (quota request open): selftest gates, thread scan, then KleidiAI over all 256 genomes of two models and stock for the 12 baseline genomes; judge SME2 against a stock build</a:t>
             </a:r>
             <a:endParaRPr lang="en-US" sz="1400" dirty="0"/>
           </a:p>
@@ -6486,7 +9380,7 @@
             <a:pPr algn="r"/>
             <a:fld id="{F7021451-1387-4CA6-816F-3879F97B5CBC}" type="slidenum">
               <a:rPr b="0" lang="en-US"/>
-              <a:t>12</a:t>
+              <a:t>14</a:t>
             </a:fld>
             <a:endParaRPr lang="en-US"/>
           </a:p>
@@ -10000,7 +12894,7 @@
                 <a:ea typeface="Calibri" pitchFamily="34" charset="-122"/>
                 <a:cs typeface="Calibri" pitchFamily="34" charset="-120"/>
               </a:rPr>
-              <a:t>Native Arm Linux: KleidiAI on/off, roofline, kernels on real hardware</a:t>
+              <a:t>Native Arm Linux: KleidiAI on/off, roofline, kernels, and a dress rehearsal of the Mac workflow</a:t>
             </a:r>
             <a:endParaRPr lang="en-US" sz="1400" dirty="0"/>
           </a:p>
@@ -10039,7 +12933,7 @@
                 <a:ea typeface="Calibri" pitchFamily="34" charset="-122"/>
                 <a:cs typeface="Calibri" pitchFamily="34" charset="-120"/>
               </a:rPr>
-              <a:t>done: about $2</a:t>
+              <a:t>done: a few dollars</a:t>
             </a:r>
             <a:endParaRPr lang="en-US" sz="1400" dirty="0"/>
           </a:p>
@@ -10208,7 +13102,7 @@
                 <a:ea typeface="Calibri" pitchFamily="34" charset="-122"/>
                 <a:cs typeface="Calibri" pitchFamily="34" charset="-120"/>
               </a:rPr>
-              <a:t>The only source of M4 speed and energy; 24-hour minimum</a:t>
+              <a:t>The only source of M4 speed and energy; 24-hour minimum on a Dedicated Host</a:t>
             </a:r>
             <a:endParaRPr lang="en-US" sz="1400" dirty="0"/>
           </a:p>
@@ -10247,7 +13141,7 @@
                 <a:ea typeface="Calibri" pitchFamily="34" charset="-122"/>
                 <a:cs typeface="Calibri" pitchFamily="34" charset="-120"/>
               </a:rPr>
-              <a:t>about $40 per day</a:t>
+              <a:t>about $30 for 24 h</a:t>
             </a:r>
             <a:endParaRPr lang="en-US" sz="1400" dirty="0"/>
           </a:p>
@@ -12989,13 +15883,13 @@
           <a:p>
             <a:pPr marL="203200" indent="-203200">
               <a:spcAft>
-                <a:spcPts val="800"/>
+                <a:spcPts val="700"/>
               </a:spcAft>
               <a:buSzPct val="100000"/>
               <a:buChar char="•"/>
             </a:pPr>
             <a:r>
-              <a:rPr lang="en-US" sz="1400" dirty="0">
+              <a:rPr lang="en-US" sz="1300" dirty="0">
                 <a:solidFill>
                   <a:schemeClr val="tx1"/>
                 </a:solidFill>
@@ -13005,18 +15899,18 @@
               </a:rPr>
               <a:t>With additive objectives the front is the sensitivity ordering: the GA is not needed here; its value must come from interactions, tested on measured Arm data</a:t>
             </a:r>
-            <a:endParaRPr lang="en-US" sz="1400" dirty="0"/>
+            <a:endParaRPr lang="en-US" sz="1300" dirty="0"/>
           </a:p>
           <a:p>
             <a:pPr marL="203200" indent="-203200">
               <a:spcAft>
-                <a:spcPts val="800"/>
+                <a:spcPts val="700"/>
               </a:spcAft>
               <a:buSzPct val="100000"/>
               <a:buChar char="•"/>
             </a:pPr>
             <a:r>
-              <a:rPr lang="en-US" sz="1400" dirty="0">
+              <a:rPr lang="en-US" sz="1300" dirty="0">
                 <a:solidFill>
                   <a:schemeClr val="tx1"/>
                 </a:solidFill>
@@ -13026,18 +15920,18 @@
               </a:rPr>
               <a:t>Scalarized weights collapse: every weighting returns uniform Q4_0; pick points from the front by accuracy budget</a:t>
             </a:r>
-            <a:endParaRPr lang="en-US" sz="1400" dirty="0"/>
+            <a:endParaRPr lang="en-US" sz="1300" dirty="0"/>
           </a:p>
           <a:p>
             <a:pPr marL="203200" indent="-203200">
               <a:spcAft>
-                <a:spcPts val="800"/>
+                <a:spcPts val="700"/>
               </a:spcAft>
               <a:buSzPct val="100000"/>
               <a:buChar char="•"/>
             </a:pPr>
             <a:r>
-              <a:rPr lang="en-US" sz="1400" dirty="0">
+              <a:rPr lang="en-US" sz="1300" dirty="0">
                 <a:solidFill>
                   <a:schemeClr val="tx1"/>
                 </a:solidFill>
@@ -13045,9 +15939,9 @@
                 <a:ea typeface="Calibri" pitchFamily="34" charset="-122"/>
                 <a:cs typeface="Calibri" pitchFamily="34" charset="-120"/>
               </a:rPr>
-              <a:t>Phi-3: Q8_0 is +261% decode vs F16 for 0.07% accuracy; Q4_0 then adds only +41% for 6.8%</a:t>
-            </a:r>
-            <a:endParaRPr lang="en-US" sz="1400" dirty="0"/>
+              <a:t>Phi-3: Q8_0 gives +261% decode for 0.07% accuracy, Q4_0 only +41% more for 6.8% (measured on Graviton3 within 4%)</a:t>
+            </a:r>
+            <a:endParaRPr lang="en-US" sz="1300" dirty="0"/>
           </a:p>
         </p:txBody>
       </p:sp>

</xml_diff>

<commit_message>
Record the Apple M4 results (plan section 24) and update the deck
- results: measured tables (8B: 256 genomes kai + 12 stock; Phi-3: 256 in both), analyses, queue files
- m4_analyze: --alphabet for restricted tables; skip the GA study when genomes are missing; queue passes the alphabet for Phi-3
- plan section 24, README_arm results, results manifest; deck: final 8B result, Phi-3 KleidiAI-vs-stock slide, closing slide
</commit_message>
<xml_diff>
--- a/presentation/Evol_inference_mac-m4.pptx
+++ b/presentation/Evol_inference_mac-m4.pptx
@@ -23,9 +23,10 @@
     <p:sldId id="271" r:id="rId17"/>
     <p:sldId id="272" r:id="rId18"/>
     <p:sldId id="273" r:id="rId19"/>
+    <p:sldId id="274" r:id="rId20"/>
   </p:sldIdLst>
   <p:notesMasterIdLst>
-    <p:notesMasterId r:id="rId20"/>
+    <p:notesMasterId r:id="rId21"/>
   </p:notesMasterIdLst>
   <p:sldSz cx="12192000" cy="6858000"/>
   <p:notesSz cx="6858000" cy="12192000"/>
@@ -124,20 +125,20 @@
   <p:extLst>
     <p:ext uri="{521415D9-36F7-43E2-AB2F-B90AF26B5E84}">
       <p14:sectionLst xmlns:p14="http://schemas.microsoft.com/office/powerpoint/2010/main">
-        <p14:section name="Context" id="{a48d7ece-2a52-3866-a939-a7998fe1c1fd}">
+        <p14:section name="Context" id="{fd2c1f92-bdf7-f37c-96d3-42087962de76}">
           <p14:sldIdLst>
             <p14:sldId id="256"/>
             <p14:sldId id="257"/>
             <p14:sldId id="258"/>
           </p14:sldIdLst>
         </p14:section>
-        <p14:section name="Method" id="{23c42536-6001-d214-5a95-3d787318a32c}">
+        <p14:section name="Method" id="{2b577907-64cf-aec8-b365-273caf47931c}">
           <p14:sldIdLst>
             <p14:sldId id="259"/>
             <p14:sldId id="260"/>
           </p14:sldIdLst>
         </p14:section>
-        <p14:section name="Results" id="{32aa7937-ec48-b2af-d9a7-b91fa5305004}">
+        <p14:section name="Results" id="{37139b1c-2517-582a-8285-c762b286925b}">
           <p14:sldIdLst>
             <p14:sldId id="261"/>
             <p14:sldId id="262"/>
@@ -149,13 +150,14 @@
             <p14:sldId id="268"/>
           </p14:sldIdLst>
         </p14:section>
-        <p14:section name="Apple M4" id="{90981f98-71ce-861a-918f-d93fe892e974}">
+        <p14:section name="Apple M4" id="{c9dc6a60-f753-510f-456e-00ee6a8b4bda}">
           <p14:sldIdLst>
             <p14:sldId id="269"/>
             <p14:sldId id="270"/>
             <p14:sldId id="271"/>
             <p14:sldId id="272"/>
             <p14:sldId id="273"/>
+            <p14:sldId id="274"/>
           </p14:sldIdLst>
         </p14:section>
       </p14:sectionLst>
@@ -438,6 +440,700 @@
         <a:effectLst/>
       </c:spPr>
     </c:plotArea>
+    <c:plotVisOnly val="1"/>
+    <c:dispBlanksAs val="span"/>
+  </c:chart>
+  <c:spPr>
+    <a:noFill/>
+    <a:ln>
+      <a:noFill/>
+    </a:ln>
+    <a:effectLst/>
+  </c:spPr>
+  <c:externalData r:id="rId1">
+    <c:autoUpdate val="0"/>
+  </c:externalData>
+</c:chartSpace>
+</file>
+
+<file path=ppt/charts/chart10.xml><?xml version="1.0" encoding="utf-8"?>
+<c:chartSpace xmlns:c="http://schemas.openxmlformats.org/drawingml/2006/chart" xmlns:a="http://schemas.openxmlformats.org/drawingml/2006/main" xmlns:r="http://schemas.openxmlformats.org/officeDocument/2006/relationships">
+  <c:date1904 val="0"/>
+  <c:roundedCorners val="1"/>
+  <c:chart>
+    <c:title>
+      <c:tx>
+        <c:rich>
+          <a:bodyPr/>
+          <a:lstStyle/>
+          <a:p>
+            <a:pPr>
+              <a:defRPr sz="1400" b="0" i="0" u="none" strike="noStrike">
+                <a:solidFill>
+                  <a:srgbClr val="0B3C4F"/>
+                </a:solidFill>
+                <a:latin typeface="+mn-lt"/>
+              </a:defRPr>
+            </a:pPr>
+            <a:r>
+              <a:rPr sz="1400" b="0" i="0" u="none" strike="noStrike">
+                <a:solidFill>
+                  <a:srgbClr val="0B3C4F"/>
+                </a:solidFill>
+                <a:latin typeface="+mn-lt"/>
+              </a:rPr>
+              <a:t>KleidiAI / stock, median over the genomes with n Q4_0 blocks (n = 256 genomes in all)</a:t>
+            </a:r>
+          </a:p>
+        </c:rich>
+      </c:tx>
+      <c:layout/>
+      <c:overlay val="0"/>
+    </c:title>
+    <c:autoTitleDeleted val="0"/>
+    <c:plotArea>
+      <c:layout/>
+      <c:lineChart>
+        <c:varyColors val="0"/>
+        <c:ser>
+          <c:idx val="0"/>
+          <c:order val="0"/>
+          <c:tx>
+            <c:strRef>
+              <c:f>Sheet1!$B$1</c:f>
+              <c:strCache>
+                <c:ptCount val="1"/>
+                <c:pt idx="0">
+                  <c:v>prefill speed</c:v>
+                </c:pt>
+              </c:strCache>
+            </c:strRef>
+          </c:tx>
+          <c:spPr>
+            <a:solidFill>
+              <a:srgbClr val="2E9E8A"/>
+            </a:solidFill>
+            <a:ln w="25400" cap="flat">
+              <a:solidFill>
+                <a:srgbClr val="2E9E8A"/>
+              </a:solidFill>
+              <a:prstDash val="solid"/>
+              <a:round/>
+            </a:ln>
+            <a:effectLst/>
+          </c:spPr>
+          <c:invertIfNegative val="0"/>
+          <c:dLbls>
+            <c:numFmt formatCode="#,##0" sourceLinked="0"/>
+            <c:txPr>
+              <a:bodyPr/>
+              <a:lstStyle/>
+              <a:p>
+                <a:pPr>
+                  <a:defRPr b="0" i="0" strike="noStrike" sz="1100" u="none">
+                    <a:solidFill>
+                      <a:srgbClr val="000000"/>
+                    </a:solidFill>
+                    <a:latin typeface="+mn-lt"/>
+                  </a:defRPr>
+                </a:pPr>
+              </a:p>
+            </c:txPr>
+            <c:showLegendKey val="0"/>
+            <c:showVal val="0"/>
+            <c:showCatName val="0"/>
+            <c:showSerName val="0"/>
+            <c:showPercent val="0"/>
+            <c:showBubbleSize val="0"/>
+            <c:showLeaderLines val="0"/>
+          </c:dLbls>
+          <c:marker>
+            <c:symbol val="circle"/>
+            <c:size val="7"/>
+            <c:spPr>
+              <a:solidFill>
+                <a:srgbClr val="2E9E8A"/>
+              </a:solidFill>
+              <a:ln w="9525" cap="flat">
+                <a:solidFill>
+                  <a:srgbClr val="2E9E8A"/>
+                </a:solidFill>
+                <a:prstDash val="solid"/>
+                <a:round/>
+              </a:ln>
+              <a:effectLst/>
+            </c:spPr>
+          </c:marker>
+          <c:cat>
+            <c:multiLvlStrRef>
+              <c:f>Sheet1!$A$2:$A$10</c:f>
+              <c:multiLvlStrCache>
+                <c:ptCount val="9"/>
+                <c:lvl>
+                  <c:pt idx="0">
+                    <c:v>0</c:v>
+                  </c:pt>
+                  <c:pt idx="1">
+                    <c:v>1</c:v>
+                  </c:pt>
+                  <c:pt idx="2">
+                    <c:v>2</c:v>
+                  </c:pt>
+                  <c:pt idx="3">
+                    <c:v>3</c:v>
+                  </c:pt>
+                  <c:pt idx="4">
+                    <c:v>4</c:v>
+                  </c:pt>
+                  <c:pt idx="5">
+                    <c:v>5</c:v>
+                  </c:pt>
+                  <c:pt idx="6">
+                    <c:v>6</c:v>
+                  </c:pt>
+                  <c:pt idx="7">
+                    <c:v>7</c:v>
+                  </c:pt>
+                  <c:pt idx="8">
+                    <c:v>8</c:v>
+                  </c:pt>
+                </c:lvl>
+              </c:multiLvlStrCache>
+            </c:multiLvlStrRef>
+          </c:cat>
+          <c:val>
+            <c:numRef>
+              <c:f>Sheet1!$B$2:$B$10</c:f>
+              <c:numCache>
+                <c:formatCode>General</c:formatCode>
+                <c:ptCount val="9"/>
+                <c:pt idx="0">
+                  <c:v>1.783</c:v>
+                </c:pt>
+                <c:pt idx="1">
+                  <c:v>1.672</c:v>
+                </c:pt>
+                <c:pt idx="2">
+                  <c:v>1.565</c:v>
+                </c:pt>
+                <c:pt idx="3">
+                  <c:v>1.472</c:v>
+                </c:pt>
+                <c:pt idx="4">
+                  <c:v>1.396</c:v>
+                </c:pt>
+                <c:pt idx="5">
+                  <c:v>1.322</c:v>
+                </c:pt>
+                <c:pt idx="6">
+                  <c:v>1.255</c:v>
+                </c:pt>
+                <c:pt idx="7">
+                  <c:v>1.198</c:v>
+                </c:pt>
+                <c:pt idx="8">
+                  <c:v>1.142</c:v>
+                </c:pt>
+              </c:numCache>
+            </c:numRef>
+          </c:val>
+          <c:smooth val="0"/>
+        </c:ser>
+        <c:ser>
+          <c:idx val="1"/>
+          <c:order val="1"/>
+          <c:tx>
+            <c:strRef>
+              <c:f>Sheet1!$C$1</c:f>
+              <c:strCache>
+                <c:ptCount val="1"/>
+                <c:pt idx="0">
+                  <c:v>decode speed</c:v>
+                </c:pt>
+              </c:strCache>
+            </c:strRef>
+          </c:tx>
+          <c:spPr>
+            <a:solidFill>
+              <a:srgbClr val="0A7EA4"/>
+            </a:solidFill>
+            <a:ln w="25400" cap="flat">
+              <a:solidFill>
+                <a:srgbClr val="0A7EA4"/>
+              </a:solidFill>
+              <a:prstDash val="solid"/>
+              <a:round/>
+            </a:ln>
+            <a:effectLst/>
+          </c:spPr>
+          <c:invertIfNegative val="0"/>
+          <c:dLbls>
+            <c:numFmt formatCode="#,##0" sourceLinked="0"/>
+            <c:txPr>
+              <a:bodyPr/>
+              <a:lstStyle/>
+              <a:p>
+                <a:pPr>
+                  <a:defRPr b="0" i="0" strike="noStrike" sz="1100" u="none">
+                    <a:solidFill>
+                      <a:srgbClr val="000000"/>
+                    </a:solidFill>
+                    <a:latin typeface="+mn-lt"/>
+                  </a:defRPr>
+                </a:pPr>
+              </a:p>
+            </c:txPr>
+            <c:showLegendKey val="0"/>
+            <c:showVal val="0"/>
+            <c:showCatName val="0"/>
+            <c:showSerName val="0"/>
+            <c:showPercent val="0"/>
+            <c:showBubbleSize val="0"/>
+            <c:showLeaderLines val="0"/>
+          </c:dLbls>
+          <c:marker>
+            <c:symbol val="circle"/>
+            <c:size val="7"/>
+            <c:spPr>
+              <a:solidFill>
+                <a:srgbClr val="0A7EA4"/>
+              </a:solidFill>
+              <a:ln w="9525" cap="flat">
+                <a:solidFill>
+                  <a:srgbClr val="0A7EA4"/>
+                </a:solidFill>
+                <a:prstDash val="solid"/>
+                <a:round/>
+              </a:ln>
+              <a:effectLst/>
+            </c:spPr>
+          </c:marker>
+          <c:cat>
+            <c:multiLvlStrRef>
+              <c:f>Sheet1!$A$2:$A$10</c:f>
+              <c:multiLvlStrCache>
+                <c:ptCount val="9"/>
+                <c:lvl>
+                  <c:pt idx="0">
+                    <c:v>0</c:v>
+                  </c:pt>
+                  <c:pt idx="1">
+                    <c:v>1</c:v>
+                  </c:pt>
+                  <c:pt idx="2">
+                    <c:v>2</c:v>
+                  </c:pt>
+                  <c:pt idx="3">
+                    <c:v>3</c:v>
+                  </c:pt>
+                  <c:pt idx="4">
+                    <c:v>4</c:v>
+                  </c:pt>
+                  <c:pt idx="5">
+                    <c:v>5</c:v>
+                  </c:pt>
+                  <c:pt idx="6">
+                    <c:v>6</c:v>
+                  </c:pt>
+                  <c:pt idx="7">
+                    <c:v>7</c:v>
+                  </c:pt>
+                  <c:pt idx="8">
+                    <c:v>8</c:v>
+                  </c:pt>
+                </c:lvl>
+              </c:multiLvlStrCache>
+            </c:multiLvlStrRef>
+          </c:cat>
+          <c:val>
+            <c:numRef>
+              <c:f>Sheet1!$C$2:$C$10</c:f>
+              <c:numCache>
+                <c:formatCode>General</c:formatCode>
+                <c:ptCount val="9"/>
+                <c:pt idx="0">
+                  <c:v>1.084</c:v>
+                </c:pt>
+                <c:pt idx="1">
+                  <c:v>1.047</c:v>
+                </c:pt>
+                <c:pt idx="2">
+                  <c:v>1.072</c:v>
+                </c:pt>
+                <c:pt idx="3">
+                  <c:v>1.035</c:v>
+                </c:pt>
+                <c:pt idx="4">
+                  <c:v>1.025</c:v>
+                </c:pt>
+                <c:pt idx="5">
+                  <c:v>1.015</c:v>
+                </c:pt>
+                <c:pt idx="6">
+                  <c:v>1.003</c:v>
+                </c:pt>
+                <c:pt idx="7">
+                  <c:v>0.991</c:v>
+                </c:pt>
+                <c:pt idx="8">
+                  <c:v>0.969</c:v>
+                </c:pt>
+              </c:numCache>
+            </c:numRef>
+          </c:val>
+          <c:smooth val="0"/>
+        </c:ser>
+        <c:ser>
+          <c:idx val="2"/>
+          <c:order val="2"/>
+          <c:tx>
+            <c:strRef>
+              <c:f>Sheet1!$D$1</c:f>
+              <c:strCache>
+                <c:ptCount val="1"/>
+                <c:pt idx="0">
+                  <c:v>energy per token</c:v>
+                </c:pt>
+              </c:strCache>
+            </c:strRef>
+          </c:tx>
+          <c:spPr>
+            <a:solidFill>
+              <a:srgbClr val="D1495B"/>
+            </a:solidFill>
+            <a:ln w="25400" cap="flat">
+              <a:solidFill>
+                <a:srgbClr val="D1495B"/>
+              </a:solidFill>
+              <a:prstDash val="solid"/>
+              <a:round/>
+            </a:ln>
+            <a:effectLst/>
+          </c:spPr>
+          <c:invertIfNegative val="0"/>
+          <c:dLbls>
+            <c:numFmt formatCode="#,##0" sourceLinked="0"/>
+            <c:txPr>
+              <a:bodyPr/>
+              <a:lstStyle/>
+              <a:p>
+                <a:pPr>
+                  <a:defRPr b="0" i="0" strike="noStrike" sz="1100" u="none">
+                    <a:solidFill>
+                      <a:srgbClr val="000000"/>
+                    </a:solidFill>
+                    <a:latin typeface="+mn-lt"/>
+                  </a:defRPr>
+                </a:pPr>
+              </a:p>
+            </c:txPr>
+            <c:showLegendKey val="0"/>
+            <c:showVal val="0"/>
+            <c:showCatName val="0"/>
+            <c:showSerName val="0"/>
+            <c:showPercent val="0"/>
+            <c:showBubbleSize val="0"/>
+            <c:showLeaderLines val="0"/>
+          </c:dLbls>
+          <c:marker>
+            <c:symbol val="circle"/>
+            <c:size val="7"/>
+            <c:spPr>
+              <a:solidFill>
+                <a:srgbClr val="D1495B"/>
+              </a:solidFill>
+              <a:ln w="9525" cap="flat">
+                <a:solidFill>
+                  <a:srgbClr val="D1495B"/>
+                </a:solidFill>
+                <a:prstDash val="solid"/>
+                <a:round/>
+              </a:ln>
+              <a:effectLst/>
+            </c:spPr>
+          </c:marker>
+          <c:cat>
+            <c:multiLvlStrRef>
+              <c:f>Sheet1!$A$2:$A$10</c:f>
+              <c:multiLvlStrCache>
+                <c:ptCount val="9"/>
+                <c:lvl>
+                  <c:pt idx="0">
+                    <c:v>0</c:v>
+                  </c:pt>
+                  <c:pt idx="1">
+                    <c:v>1</c:v>
+                  </c:pt>
+                  <c:pt idx="2">
+                    <c:v>2</c:v>
+                  </c:pt>
+                  <c:pt idx="3">
+                    <c:v>3</c:v>
+                  </c:pt>
+                  <c:pt idx="4">
+                    <c:v>4</c:v>
+                  </c:pt>
+                  <c:pt idx="5">
+                    <c:v>5</c:v>
+                  </c:pt>
+                  <c:pt idx="6">
+                    <c:v>6</c:v>
+                  </c:pt>
+                  <c:pt idx="7">
+                    <c:v>7</c:v>
+                  </c:pt>
+                  <c:pt idx="8">
+                    <c:v>8</c:v>
+                  </c:pt>
+                </c:lvl>
+              </c:multiLvlStrCache>
+            </c:multiLvlStrRef>
+          </c:cat>
+          <c:val>
+            <c:numRef>
+              <c:f>Sheet1!$D$2:$D$10</c:f>
+              <c:numCache>
+                <c:formatCode>General</c:formatCode>
+                <c:ptCount val="9"/>
+                <c:pt idx="0">
+                  <c:v>1.194</c:v>
+                </c:pt>
+                <c:pt idx="1">
+                  <c:v>1.172</c:v>
+                </c:pt>
+                <c:pt idx="2">
+                  <c:v>1.143</c:v>
+                </c:pt>
+                <c:pt idx="3">
+                  <c:v>1.14</c:v>
+                </c:pt>
+                <c:pt idx="4">
+                  <c:v>1.121</c:v>
+                </c:pt>
+                <c:pt idx="5">
+                  <c:v>1.102</c:v>
+                </c:pt>
+                <c:pt idx="6">
+                  <c:v>1.08</c:v>
+                </c:pt>
+                <c:pt idx="7">
+                  <c:v>1.059</c:v>
+                </c:pt>
+                <c:pt idx="8">
+                  <c:v>1.061</c:v>
+                </c:pt>
+              </c:numCache>
+            </c:numRef>
+          </c:val>
+          <c:smooth val="0"/>
+        </c:ser>
+        <c:dLbls>
+          <c:numFmt formatCode="#,##0" sourceLinked="0"/>
+          <c:txPr>
+            <a:bodyPr/>
+            <a:lstStyle/>
+            <a:p>
+              <a:pPr>
+                <a:defRPr b="0" i="0" strike="noStrike" sz="1100" u="none">
+                  <a:solidFill>
+                    <a:srgbClr val="000000"/>
+                  </a:solidFill>
+                  <a:latin typeface="+mn-lt"/>
+                </a:defRPr>
+              </a:pPr>
+            </a:p>
+          </c:txPr>
+          <c:showLegendKey val="0"/>
+          <c:showVal val="0"/>
+          <c:showCatName val="0"/>
+          <c:showSerName val="0"/>
+          <c:showPercent val="0"/>
+          <c:showBubbleSize val="0"/>
+          <c:showLeaderLines val="0"/>
+        </c:dLbls>
+        <c:marker val="1"/>
+        <c:axId val="2094734554"/>
+        <c:axId val="2094734552"/>
+        <c:axId val="2094734556"/>
+      </c:lineChart>
+      <c:catAx>
+        <c:axId val="2094734554"/>
+        <c:scaling>
+          <c:orientation val="minMax"/>
+        </c:scaling>
+        <c:delete val="0"/>
+        <c:axPos val="b"/>
+        <c:title>
+          <c:tx>
+            <c:rich>
+              <a:bodyPr/>
+              <a:lstStyle/>
+              <a:p>
+                <a:pPr>
+                  <a:defRPr sz="1200" b="0" i="0" u="none" strike="noStrike">
+                    <a:solidFill>
+                      <a:srgbClr val="6C7A89"/>
+                    </a:solidFill>
+                    <a:latin typeface="+mn-lt"/>
+                  </a:defRPr>
+                </a:pPr>
+                <a:r>
+                  <a:rPr sz="1200" b="0" i="0" u="none" strike="noStrike">
+                    <a:solidFill>
+                      <a:srgbClr val="6C7A89"/>
+                    </a:solidFill>
+                    <a:latin typeface="+mn-lt"/>
+                  </a:rPr>
+                  <a:t>number of blocks (of 8) at Q4_0; the rest are Q8_0</a:t>
+                </a:r>
+              </a:p>
+            </c:rich>
+          </c:tx>
+          <c:layout/>
+          <c:overlay val="0"/>
+        </c:title>
+        <c:numFmt formatCode="General" sourceLinked="1"/>
+        <c:majorTickMark val="out"/>
+        <c:minorTickMark val="none"/>
+        <c:tickLblPos val="low"/>
+        <c:spPr>
+          <a:ln w="12700" cap="flat">
+            <a:solidFill>
+              <a:srgbClr val="888888"/>
+            </a:solidFill>
+            <a:prstDash val="solid"/>
+            <a:round/>
+          </a:ln>
+        </c:spPr>
+        <c:txPr>
+          <a:bodyPr/>
+          <a:lstStyle/>
+          <a:p>
+            <a:pPr>
+              <a:defRPr sz="1200" b="0" i="0" u="none" strike="noStrike">
+                <a:solidFill>
+                  <a:srgbClr val="10212B"/>
+                </a:solidFill>
+                <a:latin typeface="+mn-lt"/>
+              </a:defRPr>
+            </a:pPr>
+            <a:endParaRPr lang="en-US"/>
+          </a:p>
+        </c:txPr>
+        <c:crossAx val="2094734552"/>
+        <c:crosses val="autoZero"/>
+        <c:auto val="1"/>
+        <c:lblAlgn val="ctr"/>
+        <c:noMultiLvlLbl val="1"/>
+      </c:catAx>
+      <c:valAx>
+        <c:axId val="2094734552"/>
+        <c:scaling>
+          <c:orientation val="minMax"/>
+          <c:min val="0.8"/>
+        </c:scaling>
+        <c:delete val="0"/>
+        <c:axPos val="l"/>
+        <c:majorGridlines>
+          <c:spPr>
+            <a:ln w="9525" cap="flat">
+              <a:solidFill>
+                <a:srgbClr val="D5DEE4"/>
+              </a:solidFill>
+              <a:prstDash val="solid"/>
+              <a:round/>
+            </a:ln>
+          </c:spPr>
+        </c:majorGridlines>
+        <c:title>
+          <c:tx>
+            <c:rich>
+              <a:bodyPr/>
+              <a:lstStyle/>
+              <a:p>
+                <a:pPr>
+                  <a:defRPr sz="1200" b="0" i="0" u="none" strike="noStrike">
+                    <a:solidFill>
+                      <a:srgbClr val="6C7A89"/>
+                    </a:solidFill>
+                    <a:latin typeface="+mn-lt"/>
+                  </a:defRPr>
+                </a:pPr>
+                <a:r>
+                  <a:rPr sz="1200" b="0" i="0" u="none" strike="noStrike">
+                    <a:solidFill>
+                      <a:srgbClr val="6C7A89"/>
+                    </a:solidFill>
+                    <a:latin typeface="+mn-lt"/>
+                  </a:rPr>
+                  <a:t>ratio (1.0 = same as stock)</a:t>
+                </a:r>
+              </a:p>
+            </c:rich>
+          </c:tx>
+          <c:layout/>
+          <c:overlay val="0"/>
+        </c:title>
+        <c:numFmt formatCode="General" sourceLinked="0"/>
+        <c:majorTickMark val="out"/>
+        <c:minorTickMark val="none"/>
+        <c:tickLblPos val="nextTo"/>
+        <c:spPr>
+          <a:ln w="12700" cap="flat">
+            <a:solidFill>
+              <a:srgbClr val="888888"/>
+            </a:solidFill>
+            <a:prstDash val="solid"/>
+            <a:round/>
+          </a:ln>
+        </c:spPr>
+        <c:txPr>
+          <a:bodyPr/>
+          <a:lstStyle/>
+          <a:p>
+            <a:pPr>
+              <a:defRPr sz="1100" b="0" i="0" u="none" strike="noStrike">
+                <a:solidFill>
+                  <a:srgbClr val="6C7A89"/>
+                </a:solidFill>
+                <a:latin typeface="+mn-lt"/>
+              </a:defRPr>
+            </a:pPr>
+            <a:endParaRPr lang="en-US"/>
+          </a:p>
+        </c:txPr>
+        <c:crossAx val="2094734554"/>
+        <c:crosses val="autoZero"/>
+        <c:crossBetween val="between"/>
+      </c:valAx>
+      <c:spPr>
+        <a:noFill/>
+        <a:ln>
+          <a:noFill/>
+        </a:ln>
+        <a:effectLst/>
+      </c:spPr>
+    </c:plotArea>
+    <c:legend>
+      <c:legendPos val="b"/>
+      <c:overlay val="0"/>
+      <c:txPr>
+        <a:bodyPr/>
+        <a:lstStyle/>
+        <a:p>
+          <a:pPr>
+            <a:defRPr sz="1200">
+              <a:solidFill>
+                <a:srgbClr val="10212B"/>
+              </a:solidFill>
+              <a:latin typeface="+mn-lt"/>
+              <a:cs typeface="+mn-lt"/>
+            </a:defRPr>
+          </a:pPr>
+          <a:endParaRPr lang="en-US"/>
+        </a:p>
+      </c:txPr>
+    </c:legend>
     <c:plotVisOnly val="1"/>
     <c:dispBlanksAs val="span"/>
   </c:chart>
@@ -3535,7 +4231,7 @@
                 </a:solidFill>
                 <a:latin typeface="+mn-lt"/>
               </a:rPr>
-              <a:t>KleidiAI configuration, 8 threads</a:t>
+              <a:t>KleidiAI configuration, 8 threads, every genome measured</a:t>
             </a:r>
           </a:p>
         </c:rich>
@@ -3591,10 +4287,10 @@
           </c:marker>
           <c:xVal>
             <c:numRef>
-              <c:f>Sheet1!$A$2:$A$76</c:f>
+              <c:f>Sheet1!$A$2:$A$257</c:f>
               <c:numCache>
                 <c:formatCode>General</c:formatCode>
-                <c:ptCount val="75"/>
+                <c:ptCount val="256"/>
                 <c:pt idx="0">
                   <c:v>0.8037125677301304</c:v>
                 </c:pt>
@@ -3602,222 +4298,765 @@
                   <c:v>1.0274423112758946</c:v>
                 </c:pt>
                 <c:pt idx="2">
+                  <c:v>1.0418902685307208</c:v>
+                </c:pt>
+                <c:pt idx="3">
+                  <c:v>1.0637176741036702</c:v>
+                </c:pt>
+                <c:pt idx="4">
                   <c:v>1.119722485595509</c:v>
                 </c:pt>
-                <c:pt idx="3">
+                <c:pt idx="5">
+                  <c:v>1.12356510805931</c:v>
+                </c:pt>
+                <c:pt idx="6">
                   <c:v>1.2789089764170702</c:v>
                 </c:pt>
-                <c:pt idx="4">
+                <c:pt idx="7">
+                  <c:v>1.2938993642069185</c:v>
+                </c:pt>
+                <c:pt idx="8">
+                  <c:v>1.300888884398721</c:v>
+                </c:pt>
+                <c:pt idx="9">
+                  <c:v>1.3788192283276324</c:v>
+                </c:pt>
+                <c:pt idx="10">
+                  <c:v>1.3978802380213429</c:v>
+                </c:pt>
+                <c:pt idx="11">
+                  <c:v>1.399198419032599</c:v>
+                </c:pt>
+                <c:pt idx="12">
+                  <c:v>1.419277448077838</c:v>
+                </c:pt>
+                <c:pt idx="13">
+                  <c:v>1.4236385707715682</c:v>
+                </c:pt>
+                <c:pt idx="14">
+                  <c:v>1.4239428421436884</c:v>
+                </c:pt>
+                <c:pt idx="15">
+                  <c:v>1.4476788217700598</c:v>
+                </c:pt>
+                <c:pt idx="16">
+                  <c:v>1.4480846132969294</c:v>
+                </c:pt>
+                <c:pt idx="17">
+                  <c:v>1.451432455328261</c:v>
+                </c:pt>
+                <c:pt idx="18">
                   <c:v>1.4855258640051439</c:v>
                 </c:pt>
-                <c:pt idx="5">
+                <c:pt idx="19">
                   <c:v>1.5047084410898748</c:v>
                 </c:pt>
-                <c:pt idx="6">
+                <c:pt idx="20">
+                  <c:v>1.527854153125352</c:v>
+                </c:pt>
+                <c:pt idx="21">
+                  <c:v>1.5698953866796206</c:v>
+                </c:pt>
+                <c:pt idx="22">
                   <c:v>1.5702000968228491</c:v>
                 </c:pt>
-                <c:pt idx="7">
+                <c:pt idx="23">
+                  <c:v>1.6096169808414107</c:v>
+                </c:pt>
+                <c:pt idx="24">
+                  <c:v>1.6366487340220948</c:v>
+                </c:pt>
+                <c:pt idx="25">
                   <c:v>1.6759897290737014</c:v>
                 </c:pt>
-                <c:pt idx="8">
+                <c:pt idx="26">
+                  <c:v>1.6794467714938754</c:v>
+                </c:pt>
+                <c:pt idx="27">
+                  <c:v>1.680768612893857</c:v>
+                </c:pt>
+                <c:pt idx="28">
+                  <c:v>1.699276196920474</c:v>
+                </c:pt>
+                <c:pt idx="29">
+                  <c:v>1.7011068003673913</c:v>
+                </c:pt>
+                <c:pt idx="30">
                   <c:v>1.7044629922686738</c:v>
                 </c:pt>
-                <c:pt idx="9">
+                <c:pt idx="31">
                   <c:v>1.714837376578493</c:v>
                 </c:pt>
-                <c:pt idx="10">
+                <c:pt idx="32">
+                  <c:v>1.7361997353967373</c:v>
+                </c:pt>
+                <c:pt idx="33">
+                  <c:v>1.73670841766711</c:v>
+                </c:pt>
+                <c:pt idx="34">
+                  <c:v>1.7375223145900343</c:v>
+                </c:pt>
+                <c:pt idx="35">
+                  <c:v>1.7505455509156498</c:v>
+                </c:pt>
+                <c:pt idx="36">
                   <c:v>1.7741544160059242</c:v>
                 </c:pt>
-                <c:pt idx="11">
+                <c:pt idx="37">
+                  <c:v>1.7799557081428885</c:v>
+                </c:pt>
+                <c:pt idx="38">
+                  <c:v>1.7811770749395883</c:v>
+                </c:pt>
+                <c:pt idx="39">
+                  <c:v>1.798277749104571</c:v>
+                </c:pt>
+                <c:pt idx="40">
+                  <c:v>1.8121232563516054</c:v>
+                </c:pt>
+                <c:pt idx="41">
+                  <c:v>1.8160940065877318</c:v>
+                </c:pt>
+                <c:pt idx="42">
+                  <c:v>1.8172139897816963</c:v>
+                </c:pt>
+                <c:pt idx="43">
+                  <c:v>1.8294327885737482</c:v>
+                </c:pt>
+                <c:pt idx="44">
                   <c:v>1.8660979837167746</c:v>
                 </c:pt>
-                <c:pt idx="12">
+                <c:pt idx="45">
+                  <c:v>1.8697652292541944</c:v>
+                </c:pt>
+                <c:pt idx="46">
+                  <c:v>1.870682061267015</c:v>
+                </c:pt>
+                <c:pt idx="47">
                   <c:v>1.881990334573369</c:v>
                 </c:pt>
-                <c:pt idx="13">
+                <c:pt idx="48">
                   <c:v>1.9391621663504388</c:v>
                 </c:pt>
-                <c:pt idx="14">
+                <c:pt idx="49">
                   <c:v>1.9435456445676902</c:v>
                 </c:pt>
-                <c:pt idx="15">
+                <c:pt idx="50">
+                  <c:v>1.948948795669092</c:v>
+                </c:pt>
+                <c:pt idx="51">
+                  <c:v>1.9494585416874433</c:v>
+                </c:pt>
+                <c:pt idx="52">
+                  <c:v>1.9527209765594522</c:v>
+                </c:pt>
+                <c:pt idx="53">
                   <c:v>1.9532307414387606</c:v>
                 </c:pt>
-                <c:pt idx="16">
+                <c:pt idx="54">
+                  <c:v>1.9689327479964103</c:v>
+                </c:pt>
+                <c:pt idx="55">
+                  <c:v>1.9789261930765134</c:v>
+                </c:pt>
+                <c:pt idx="56">
                   <c:v>1.9909604163725225</c:v>
                 </c:pt>
-                <c:pt idx="17">
+                <c:pt idx="57">
+                  <c:v>2.0341117184856206</c:v>
+                </c:pt>
+                <c:pt idx="58">
+                  <c:v>2.0438054195423883</c:v>
+                </c:pt>
+                <c:pt idx="59">
+                  <c:v>2.044213595580424</c:v>
+                </c:pt>
+                <c:pt idx="60">
                   <c:v>2.0469688265429387</c:v>
                 </c:pt>
-                <c:pt idx="18">
+                <c:pt idx="61">
+                  <c:v>2.049520032653551</c:v>
+                </c:pt>
+                <c:pt idx="62">
                   <c:v>2.071973396840243</c:v>
                 </c:pt>
-                <c:pt idx="19">
+                <c:pt idx="63">
                   <c:v>2.0779958209304006</c:v>
                 </c:pt>
-                <c:pt idx="20">
+                <c:pt idx="64">
                   <c:v>2.086366559783337</c:v>
                 </c:pt>
-                <c:pt idx="21">
+                <c:pt idx="65">
+                  <c:v>2.1088280310977314</c:v>
+                </c:pt>
+                <c:pt idx="66">
+                  <c:v>2.119754260239892</c:v>
+                </c:pt>
+                <c:pt idx="67">
                   <c:v>2.1212860680423384</c:v>
                 </c:pt>
-                <c:pt idx="22">
+                <c:pt idx="68">
+                  <c:v>2.1266986396358156</c:v>
+                </c:pt>
+                <c:pt idx="69">
                   <c:v>2.1443680868635795</c:v>
                 </c:pt>
-                <c:pt idx="23">
+                <c:pt idx="70">
+                  <c:v>2.1531528802597677</c:v>
+                </c:pt>
+                <c:pt idx="71">
+                  <c:v>2.162551402650137</c:v>
+                </c:pt>
+                <c:pt idx="72">
+                  <c:v>2.164799003504525</c:v>
+                </c:pt>
+                <c:pt idx="73">
                   <c:v>2.175935573527954</c:v>
                 </c:pt>
-                <c:pt idx="24">
+                <c:pt idx="74">
                   <c:v>2.177059515000912</c:v>
                 </c:pt>
-                <c:pt idx="25">
+                <c:pt idx="75">
+                  <c:v>2.1813510416219817</c:v>
+                </c:pt>
+                <c:pt idx="76">
+                  <c:v>2.1829859563179177</c:v>
+                </c:pt>
+                <c:pt idx="77">
+                  <c:v>2.1880952333465986</c:v>
+                </c:pt>
+                <c:pt idx="78">
                   <c:v>2.1904455865659367</c:v>
                 </c:pt>
-                <c:pt idx="26">
+                <c:pt idx="79">
+                  <c:v>2.1920806467757625</c:v>
+                </c:pt>
+                <c:pt idx="80">
+                  <c:v>2.1923872234775654</c:v>
+                </c:pt>
+                <c:pt idx="81">
+                  <c:v>2.2018915574340214</c:v>
+                </c:pt>
+                <c:pt idx="82">
+                  <c:v>2.222231757636761</c:v>
+                </c:pt>
+                <c:pt idx="83">
+                  <c:v>2.2370550559047686</c:v>
+                </c:pt>
+                <c:pt idx="84">
                   <c:v>2.2417580686058036</c:v>
                 </c:pt>
-                <c:pt idx="27">
+                <c:pt idx="85">
                   <c:v>2.252800774772612</c:v>
                 </c:pt>
-                <c:pt idx="28">
+                <c:pt idx="86">
                   <c:v>2.2767307298494632</c:v>
                 </c:pt>
-                <c:pt idx="29">
+                <c:pt idx="87">
                   <c:v>2.2767307298494632</c:v>
                 </c:pt>
-                <c:pt idx="30">
+                <c:pt idx="88">
+                  <c:v>2.2775489469681665</c:v>
+                </c:pt>
+                <c:pt idx="89">
+                  <c:v>2.2801059176538407</c:v>
+                </c:pt>
+                <c:pt idx="90">
+                  <c:v>2.2854246214466523</c:v>
+                </c:pt>
+                <c:pt idx="91">
                   <c:v>2.302098504544503</c:v>
                 </c:pt>
-                <c:pt idx="31">
+                <c:pt idx="92">
+                  <c:v>2.3047583936840255</c:v>
+                </c:pt>
+                <c:pt idx="93">
+                  <c:v>2.319491339639379</c:v>
+                </c:pt>
+                <c:pt idx="94">
                   <c:v>2.3201052584291615</c:v>
                 </c:pt>
-                <c:pt idx="32">
+                <c:pt idx="95">
+                  <c:v>2.3207191809024863</c:v>
+                </c:pt>
+                <c:pt idx="96">
+                  <c:v>2.3363754486110944</c:v>
+                </c:pt>
+                <c:pt idx="97">
                   <c:v>2.3373988174824056</c:v>
                 </c:pt>
-                <c:pt idx="33">
+                <c:pt idx="98">
+                  <c:v>2.3620651027654205</c:v>
+                </c:pt>
+                <c:pt idx="99">
+                  <c:v>2.363907636520013</c:v>
+                </c:pt>
+                <c:pt idx="100">
+                  <c:v>2.366876232885917</c:v>
+                </c:pt>
+                <c:pt idx="101">
+                  <c:v>2.3773181867922766</c:v>
+                </c:pt>
+                <c:pt idx="102">
                   <c:v>2.3809014556356534</c:v>
                 </c:pt>
-                <c:pt idx="34">
+                <c:pt idx="103">
                   <c:v>2.3877612058322395</c:v>
                 </c:pt>
-                <c:pt idx="35">
+                <c:pt idx="104">
+                  <c:v>2.39144723158371</c:v>
+                </c:pt>
+                <c:pt idx="105">
+                  <c:v>2.3943142322440325</c:v>
+                </c:pt>
+                <c:pt idx="106">
                   <c:v>2.4024037025982325</c:v>
                 </c:pt>
-                <c:pt idx="36">
+                <c:pt idx="107">
                   <c:v>2.4049637946918168</c:v>
                 </c:pt>
-                <c:pt idx="37">
+                <c:pt idx="108">
+                  <c:v>2.4254468356865955</c:v>
+                </c:pt>
+                <c:pt idx="109">
+                  <c:v>2.426880801980036</c:v>
+                </c:pt>
+                <c:pt idx="110">
                   <c:v>2.4270856559464926</c:v>
                 </c:pt>
-                <c:pt idx="38">
+                <c:pt idx="111">
+                  <c:v>2.427802648055555</c:v>
+                </c:pt>
+                <c:pt idx="112">
+                  <c:v>2.4288269312034316</c:v>
+                </c:pt>
+                <c:pt idx="113">
+                  <c:v>2.431490115324886</c:v>
+                </c:pt>
+                <c:pt idx="114">
                   <c:v>2.449929443035348</c:v>
                 </c:pt>
-                <c:pt idx="39">
+                <c:pt idx="115">
+                  <c:v>2.4656054814264916</c:v>
+                </c:pt>
+                <c:pt idx="116">
+                  <c:v>2.4657079470832066</c:v>
+                </c:pt>
+                <c:pt idx="117">
                   <c:v>2.4714461873974747</c:v>
                 </c:pt>
-                <c:pt idx="40">
+                <c:pt idx="118">
                   <c:v>2.479029354989093</c:v>
                 </c:pt>
-                <c:pt idx="41">
+                <c:pt idx="119">
+                  <c:v>2.49163505083414</c:v>
+                </c:pt>
+                <c:pt idx="120">
+                  <c:v>2.5155183841012674</c:v>
+                </c:pt>
+                <c:pt idx="121">
+                  <c:v>2.5183888588024894</c:v>
+                </c:pt>
+                <c:pt idx="122">
                   <c:v>2.524232573511731</c:v>
                 </c:pt>
-                <c:pt idx="42">
+                <c:pt idx="123">
+                  <c:v>2.52730834662529</c:v>
+                </c:pt>
+                <c:pt idx="124">
                   <c:v>2.5771487287135963</c:v>
                 </c:pt>
-                <c:pt idx="43">
+                <c:pt idx="125">
+                  <c:v>2.5796106098255445</c:v>
+                </c:pt>
+                <c:pt idx="126">
                   <c:v>2.585662985394843</c:v>
                 </c:pt>
-                <c:pt idx="44">
+                <c:pt idx="127">
+                  <c:v>2.5877147191718075</c:v>
+                </c:pt>
+                <c:pt idx="128">
                   <c:v>2.5978714056767105</c:v>
                 </c:pt>
-                <c:pt idx="45">
+                <c:pt idx="129">
+                  <c:v>2.6139805360210433</c:v>
+                </c:pt>
+                <c:pt idx="130">
+                  <c:v>2.6236267035541827</c:v>
+                </c:pt>
+                <c:pt idx="131">
+                  <c:v>2.624037198882001</c:v>
+                </c:pt>
+                <c:pt idx="132">
+                  <c:v>2.6267054585363825</c:v>
+                </c:pt>
+                <c:pt idx="133">
+                  <c:v>2.6270133391145922</c:v>
+                </c:pt>
+                <c:pt idx="134">
+                  <c:v>2.6326579800744376</c:v>
+                </c:pt>
+                <c:pt idx="135">
+                  <c:v>2.6339922133006732</c:v>
+                </c:pt>
+                <c:pt idx="136">
+                  <c:v>2.6377897412664053</c:v>
+                </c:pt>
+                <c:pt idx="137">
+                  <c:v>2.63871348553093</c:v>
+                </c:pt>
+                <c:pt idx="138">
                   <c:v>2.6539051392814317</c:v>
                 </c:pt>
-                <c:pt idx="46">
+                <c:pt idx="139">
                   <c:v>2.6642737073043765</c:v>
                 </c:pt>
-                <c:pt idx="47">
+                <c:pt idx="140">
                   <c:v>2.6658136829597723</c:v>
                 </c:pt>
-                <c:pt idx="48">
+                <c:pt idx="141">
+                  <c:v>2.6662243470358282</c:v>
+                </c:pt>
+                <c:pt idx="142">
+                  <c:v>2.6670456801159315</c:v>
+                </c:pt>
+                <c:pt idx="143">
+                  <c:v>2.6992881942693003</c:v>
+                </c:pt>
+                <c:pt idx="144">
+                  <c:v>2.700520593122002</c:v>
+                </c:pt>
+                <c:pt idx="145">
+                  <c:v>2.7023692191302517</c:v>
+                </c:pt>
+                <c:pt idx="146">
+                  <c:v>2.710174895802875</c:v>
+                </c:pt>
+                <c:pt idx="147">
                   <c:v>2.7158241107741343</c:v>
                 </c:pt>
-                <c:pt idx="49">
+                <c:pt idx="148">
+                  <c:v>2.723014470121532</c:v>
+                </c:pt>
+                <c:pt idx="149">
+                  <c:v>2.7316435657539495</c:v>
+                </c:pt>
+                <c:pt idx="150">
+                  <c:v>2.7321572252559267</c:v>
+                </c:pt>
+                <c:pt idx="151">
+                  <c:v>2.732876352873448</c:v>
+                </c:pt>
+                <c:pt idx="152">
+                  <c:v>2.7379103871475685</c:v>
+                </c:pt>
+                <c:pt idx="153">
+                  <c:v>2.7473627097033715</c:v>
+                </c:pt>
+                <c:pt idx="154">
                   <c:v>2.7505479273179922</c:v>
                 </c:pt>
-                <c:pt idx="50">
+                <c:pt idx="155">
+                  <c:v>2.7603096930476134</c:v>
+                </c:pt>
+                <c:pt idx="156">
                   <c:v>2.7755193443686155</c:v>
                 </c:pt>
-                <c:pt idx="51">
+                <c:pt idx="157">
+                  <c:v>2.7875447836063882</c:v>
+                </c:pt>
+                <c:pt idx="158">
                   <c:v>2.7947401635765923</c:v>
                 </c:pt>
-                <c:pt idx="52">
+                <c:pt idx="159">
+                  <c:v>2.8117026950739588</c:v>
+                </c:pt>
+                <c:pt idx="160">
+                  <c:v>2.826508646264947</c:v>
+                </c:pt>
+                <c:pt idx="161">
                   <c:v>2.827022780093502</c:v>
                 </c:pt>
-                <c:pt idx="53">
+                <c:pt idx="162">
+                  <c:v>2.844710549116214</c:v>
+                </c:pt>
+                <c:pt idx="163">
+                  <c:v>2.84563615567639</c:v>
+                </c:pt>
+                <c:pt idx="164">
+                  <c:v>2.8524241916653814</c:v>
+                </c:pt>
+                <c:pt idx="165">
+                  <c:v>2.862092773955638</c:v>
+                </c:pt>
+                <c:pt idx="166">
+                  <c:v>2.8655901445649112</c:v>
+                </c:pt>
+                <c:pt idx="167">
                   <c:v>2.8899721785860866</c:v>
                 </c:pt>
-                <c:pt idx="54">
+                <c:pt idx="168">
+                  <c:v>2.8940878597863096</c:v>
+                </c:pt>
+                <c:pt idx="169">
                   <c:v>2.913125026924024</c:v>
                 </c:pt>
-                <c:pt idx="55">
+                <c:pt idx="170">
+                  <c:v>2.915080394875491</c:v>
+                </c:pt>
+                <c:pt idx="171">
+                  <c:v>2.925475342931394</c:v>
+                </c:pt>
+                <c:pt idx="172">
                   <c:v>2.926298750027767</c:v>
                 </c:pt>
-                <c:pt idx="56">
+                <c:pt idx="173">
                   <c:v>2.9269163096729445</c:v>
                 </c:pt>
-                <c:pt idx="57">
+                <c:pt idx="174">
+                  <c:v>2.9417388528190314</c:v>
+                </c:pt>
+                <c:pt idx="175">
+                  <c:v>2.9426653326378727</c:v>
+                </c:pt>
+                <c:pt idx="176">
+                  <c:v>2.94657722824605</c:v>
+                </c:pt>
+                <c:pt idx="177">
+                  <c:v>2.9615055642223442</c:v>
+                </c:pt>
+                <c:pt idx="178">
+                  <c:v>2.9735527651208793</c:v>
+                </c:pt>
+                <c:pt idx="179">
+                  <c:v>2.973655738725123</c:v>
+                </c:pt>
+                <c:pt idx="180">
+                  <c:v>2.981482033956717</c:v>
+                </c:pt>
+                <c:pt idx="181">
+                  <c:v>2.983026767772712</c:v>
+                </c:pt>
+                <c:pt idx="182">
+                  <c:v>3.0030074130255713</c:v>
+                </c:pt>
+                <c:pt idx="183">
+                  <c:v>3.0097028261059755</c:v>
+                </c:pt>
+                <c:pt idx="184">
+                  <c:v>3.0263917497301396</c:v>
+                </c:pt>
+                <c:pt idx="185">
+                  <c:v>3.0268038561213517</c:v>
+                </c:pt>
+                <c:pt idx="186">
+                  <c:v>3.0350463301243913</c:v>
+                </c:pt>
+                <c:pt idx="187">
+                  <c:v>3.0416407841098003</c:v>
+                </c:pt>
+                <c:pt idx="188">
+                  <c:v>3.0459686239067363</c:v>
+                </c:pt>
+                <c:pt idx="189">
+                  <c:v>3.0548309582832944</c:v>
+                </c:pt>
+                <c:pt idx="190">
+                  <c:v>3.055346233726275</c:v>
+                </c:pt>
+                <c:pt idx="191">
+                  <c:v>3.0580257075613737</c:v>
+                </c:pt>
+                <c:pt idx="192">
+                  <c:v>3.0666829453197098</c:v>
+                </c:pt>
+                <c:pt idx="193">
                   <c:v>3.082350271814027</c:v>
                 </c:pt>
-                <c:pt idx="58">
+                <c:pt idx="194">
+                  <c:v>3.0977106863270043</c:v>
+                </c:pt>
+                <c:pt idx="195">
+                  <c:v>3.0993602628945682</c:v>
+                </c:pt>
+                <c:pt idx="196">
+                  <c:v>3.100803664042018</c:v>
+                </c:pt>
+                <c:pt idx="197">
+                  <c:v>3.114104525601813</c:v>
+                </c:pt>
+                <c:pt idx="198">
+                  <c:v>3.117197995139387</c:v>
+                </c:pt>
+                <c:pt idx="199">
+                  <c:v>3.122044617339892</c:v>
+                </c:pt>
+                <c:pt idx="200">
+                  <c:v>3.130604102256851</c:v>
+                </c:pt>
+                <c:pt idx="201">
+                  <c:v>3.1394737155975516</c:v>
+                </c:pt>
+                <c:pt idx="202">
+                  <c:v>3.1746502733968063</c:v>
+                </c:pt>
+                <c:pt idx="203">
+                  <c:v>3.2018919768156184</c:v>
+                </c:pt>
+                <c:pt idx="204">
+                  <c:v>3.218095945834243</c:v>
+                </c:pt>
+                <c:pt idx="205">
                   <c:v>3.235644513731062</c:v>
                 </c:pt>
-                <c:pt idx="59">
+                <c:pt idx="206">
+                  <c:v>3.243903695655015</c:v>
+                </c:pt>
+                <c:pt idx="207">
+                  <c:v>3.259494702204435</c:v>
+                </c:pt>
+                <c:pt idx="208">
+                  <c:v>3.2661035213453316</c:v>
+                </c:pt>
+                <c:pt idx="209">
                   <c:v>3.2828339852467803</c:v>
                 </c:pt>
-                <c:pt idx="60">
+                <c:pt idx="210">
+                  <c:v>3.2872752425944896</c:v>
+                </c:pt>
+                <c:pt idx="211">
+                  <c:v>3.300600160539524</c:v>
+                </c:pt>
+                <c:pt idx="212">
+                  <c:v>3.3021496811633133</c:v>
+                </c:pt>
+                <c:pt idx="213">
+                  <c:v>3.3103108733509634</c:v>
+                </c:pt>
+                <c:pt idx="214">
+                  <c:v>3.321675632597332</c:v>
+                </c:pt>
+                <c:pt idx="215">
+                  <c:v>3.3342816459756897</c:v>
+                </c:pt>
+                <c:pt idx="216">
                   <c:v>3.3400685277790387</c:v>
                 </c:pt>
-                <c:pt idx="61">
+                <c:pt idx="217">
+                  <c:v>3.345752387852796</c:v>
+                </c:pt>
+                <c:pt idx="218">
                   <c:v>3.3495762514321736</c:v>
                 </c:pt>
-                <c:pt idx="62">
+                <c:pt idx="219">
+                  <c:v>3.3515399120356726</c:v>
+                </c:pt>
+                <c:pt idx="220">
+                  <c:v>3.35350360994906</c:v>
+                </c:pt>
+                <c:pt idx="221">
+                  <c:v>3.3630125696866298</c:v>
+                </c:pt>
+                <c:pt idx="222">
+                  <c:v>3.3648731206577853</c:v>
+                </c:pt>
+                <c:pt idx="223">
+                  <c:v>3.4073648149554048</c:v>
+                </c:pt>
+                <c:pt idx="224">
+                  <c:v>3.4177060684909666</c:v>
+                </c:pt>
+                <c:pt idx="225">
+                  <c:v>3.4195676039539658</c:v>
+                </c:pt>
+                <c:pt idx="226">
+                  <c:v>3.419981283051743</c:v>
+                </c:pt>
+                <c:pt idx="227">
                   <c:v>3.4220497033615294</c:v>
                 </c:pt>
-                <c:pt idx="63">
+                <c:pt idx="228">
+                  <c:v>3.4534947858817278</c:v>
+                </c:pt>
+                <c:pt idx="229">
+                  <c:v>3.4625990940065687</c:v>
+                </c:pt>
+                <c:pt idx="230">
                   <c:v>3.4855703407194794</c:v>
                 </c:pt>
-                <c:pt idx="64">
+                <c:pt idx="231">
+                  <c:v>3.4867086882541365</c:v>
+                </c:pt>
+                <c:pt idx="232">
+                  <c:v>3.566009875586551</c:v>
+                </c:pt>
+                <c:pt idx="233">
+                  <c:v>3.5687026268489186</c:v>
+                </c:pt>
+                <c:pt idx="234">
                   <c:v>3.572638312326304</c:v>
                 </c:pt>
-                <c:pt idx="65">
+                <c:pt idx="235">
+                  <c:v>3.584342681740016</c:v>
+                </c:pt>
+                <c:pt idx="236">
                   <c:v>3.584964189660611</c:v>
                 </c:pt>
-                <c:pt idx="66">
+                <c:pt idx="237">
                   <c:v>3.5891076710972802</c:v>
                 </c:pt>
-                <c:pt idx="67">
+                <c:pt idx="238">
+                  <c:v>3.6379096327701532</c:v>
+                </c:pt>
+                <c:pt idx="239">
                   <c:v>3.641433381601056</c:v>
                 </c:pt>
-                <c:pt idx="68">
+                <c:pt idx="240">
                   <c:v>3.67004236507249</c:v>
                 </c:pt>
-                <c:pt idx="69">
+                <c:pt idx="241">
+                  <c:v>3.6866308988982244</c:v>
+                </c:pt>
+                <c:pt idx="242">
                   <c:v>3.689015718834221</c:v>
                 </c:pt>
-                <c:pt idx="70">
+                <c:pt idx="243">
+                  <c:v>3.692748590591388</c:v>
+                </c:pt>
+                <c:pt idx="244">
                   <c:v>3.7084073778372417</c:v>
                 </c:pt>
-                <c:pt idx="71">
+                <c:pt idx="245">
                   <c:v>3.7540491175298785</c:v>
                 </c:pt>
-                <c:pt idx="72">
+                <c:pt idx="246">
+                  <c:v>3.7693020838157176</c:v>
+                </c:pt>
+                <c:pt idx="247">
+                  <c:v>3.78341566860112</c:v>
+                </c:pt>
+                <c:pt idx="248">
+                  <c:v>3.8034478008637462</c:v>
+                </c:pt>
+                <c:pt idx="249">
+                  <c:v>3.8826800547967943</c:v>
+                </c:pt>
+                <c:pt idx="250">
+                  <c:v>3.9015884231760944</c:v>
+                </c:pt>
+                <c:pt idx="251">
                   <c:v>3.95875001480559</c:v>
                 </c:pt>
-                <c:pt idx="73">
+                <c:pt idx="252">
+                  <c:v>4.036228140584952</c:v>
+                </c:pt>
+                <c:pt idx="253">
                   <c:v>4.049233481919434</c:v>
                 </c:pt>
-                <c:pt idx="74">
+                <c:pt idx="254">
+                  <c:v>4.051418538765561</c:v>
+                </c:pt>
+                <c:pt idx="255">
                   <c:v>4.339518826123245</c:v>
                 </c:pt>
               </c:numCache>
@@ -3825,10 +5064,10 @@
           </c:xVal>
           <c:yVal>
             <c:numRef>
-              <c:f>Sheet1!$B$2:$B$76</c:f>
+              <c:f>Sheet1!$B$2:$B$257</c:f>
               <c:numCache>
                 <c:formatCode>General</c:formatCode>
-                <c:ptCount val="75"/>
+                <c:ptCount val="256"/>
                 <c:pt idx="0">
                   <c:v/>
                 </c:pt>
@@ -3839,219 +5078,762 @@
                   <c:v/>
                 </c:pt>
                 <c:pt idx="3">
+                  <c:v>14.8218</c:v>
+                </c:pt>
+                <c:pt idx="4">
                   <c:v/>
                 </c:pt>
-                <c:pt idx="4">
-                  <c:v>14.9009</c:v>
-                </c:pt>
                 <c:pt idx="5">
-                  <c:v>15.795</c:v>
+                  <c:v>14.8287</c:v>
                 </c:pt>
                 <c:pt idx="6">
                   <c:v/>
                 </c:pt>
                 <c:pt idx="7">
+                  <c:v>14.8376</c:v>
+                </c:pt>
+                <c:pt idx="8">
+                  <c:v>15.7362</c:v>
+                </c:pt>
+                <c:pt idx="9">
+                  <c:v>15.6464</c:v>
+                </c:pt>
+                <c:pt idx="10">
+                  <c:v>15.7079</c:v>
+                </c:pt>
+                <c:pt idx="11">
+                  <c:v>15.767</c:v>
+                </c:pt>
+                <c:pt idx="12">
+                  <c:v>15.5765</c:v>
+                </c:pt>
+                <c:pt idx="13">
+                  <c:v>15.7178</c:v>
+                </c:pt>
+                <c:pt idx="14">
+                  <c:v>15.7899</c:v>
+                </c:pt>
+                <c:pt idx="15">
+                  <c:v>15.675</c:v>
+                </c:pt>
+                <c:pt idx="16">
+                  <c:v>15.7319</c:v>
+                </c:pt>
+                <c:pt idx="17">
+                  <c:v>15.6487</c:v>
+                </c:pt>
+                <c:pt idx="18">
+                  <c:v>14.9009</c:v>
+                </c:pt>
+                <c:pt idx="19">
+                  <c:v>15.795</c:v>
+                </c:pt>
+                <c:pt idx="20">
+                  <c:v>15.6824</c:v>
+                </c:pt>
+                <c:pt idx="21">
+                  <c:v>15.6911</c:v>
+                </c:pt>
+                <c:pt idx="22">
                   <c:v/>
                 </c:pt>
-                <c:pt idx="8">
+                <c:pt idx="23">
+                  <c:v>15.7266</c:v>
+                </c:pt>
+                <c:pt idx="24">
+                  <c:v>16.5802</c:v>
+                </c:pt>
+                <c:pt idx="25">
+                  <c:v/>
+                </c:pt>
+                <c:pt idx="26">
+                  <c:v>16.5959</c:v>
+                </c:pt>
+                <c:pt idx="27">
+                  <c:v>16.5712</c:v>
+                </c:pt>
+                <c:pt idx="28">
+                  <c:v>15.7121</c:v>
+                </c:pt>
+                <c:pt idx="29">
+                  <c:v>16.5725</c:v>
+                </c:pt>
+                <c:pt idx="30">
                   <c:v>15.8205</c:v>
                 </c:pt>
-                <c:pt idx="9">
+                <c:pt idx="31">
                   <c:v>16.6568</c:v>
                 </c:pt>
-                <c:pt idx="10">
+                <c:pt idx="32">
+                  <c:v>16.5464</c:v>
+                </c:pt>
+                <c:pt idx="33">
+                  <c:v>16.5165</c:v>
+                </c:pt>
+                <c:pt idx="34">
+                  <c:v>16.5645</c:v>
+                </c:pt>
+                <c:pt idx="35">
+                  <c:v>15.7436</c:v>
+                </c:pt>
+                <c:pt idx="36">
                   <c:v>14.9473</c:v>
                 </c:pt>
-                <c:pt idx="11">
+                <c:pt idx="37">
+                  <c:v>16.5637</c:v>
+                </c:pt>
+                <c:pt idx="38">
+                  <c:v>16.6121</c:v>
+                </c:pt>
+                <c:pt idx="39">
+                  <c:v>16.6477</c:v>
+                </c:pt>
+                <c:pt idx="40">
+                  <c:v>15.7139</c:v>
+                </c:pt>
+                <c:pt idx="41">
+                  <c:v>15.7239</c:v>
+                </c:pt>
+                <c:pt idx="42">
+                  <c:v>16.6099</c:v>
+                </c:pt>
+                <c:pt idx="43">
+                  <c:v>16.5894</c:v>
+                </c:pt>
+                <c:pt idx="44">
                   <c:v>16.6288</c:v>
                 </c:pt>
-                <c:pt idx="12">
+                <c:pt idx="45">
+                  <c:v>16.5462</c:v>
+                </c:pt>
+                <c:pt idx="46">
+                  <c:v>15.7301</c:v>
+                </c:pt>
+                <c:pt idx="47">
                   <c:v>16.6349</c:v>
                 </c:pt>
-                <c:pt idx="13">
+                <c:pt idx="48">
                   <c:v>15.821</c:v>
                 </c:pt>
-                <c:pt idx="14">
+                <c:pt idx="49">
                   <c:v/>
                 </c:pt>
-                <c:pt idx="15">
+                <c:pt idx="50">
+                  <c:v>15.6557</c:v>
+                </c:pt>
+                <c:pt idx="51">
+                  <c:v>16.5851</c:v>
+                </c:pt>
+                <c:pt idx="52">
+                  <c:v>17.525</c:v>
+                </c:pt>
+                <c:pt idx="53">
                   <c:v>15.7935</c:v>
                 </c:pt>
-                <c:pt idx="16">
+                <c:pt idx="54">
+                  <c:v>16.5956</c:v>
+                </c:pt>
+                <c:pt idx="55">
+                  <c:v>16.5523</c:v>
+                </c:pt>
+                <c:pt idx="56">
                   <c:v>17.5984</c:v>
                 </c:pt>
-                <c:pt idx="17">
+                <c:pt idx="57">
+                  <c:v>16.635</c:v>
+                </c:pt>
+                <c:pt idx="58">
+                  <c:v>15.6591</c:v>
+                </c:pt>
+                <c:pt idx="59">
+                  <c:v>16.6281</c:v>
+                </c:pt>
+                <c:pt idx="60">
                   <c:v>17.6122</c:v>
                 </c:pt>
-                <c:pt idx="18">
+                <c:pt idx="61">
+                  <c:v>16.5176</c:v>
+                </c:pt>
+                <c:pt idx="62">
                   <c:v>15.8273</c:v>
                 </c:pt>
-                <c:pt idx="19">
+                <c:pt idx="63">
                   <c:v>16.6403</c:v>
                 </c:pt>
-                <c:pt idx="20">
+                <c:pt idx="64">
                   <c:v>16.6505</c:v>
                 </c:pt>
-                <c:pt idx="21">
+                <c:pt idx="65">
+                  <c:v>16.6184</c:v>
+                </c:pt>
+                <c:pt idx="66">
+                  <c:v>17.479</c:v>
+                </c:pt>
+                <c:pt idx="67">
                   <c:v>16.6546</c:v>
                 </c:pt>
-                <c:pt idx="22">
+                <c:pt idx="68">
+                  <c:v>17.5355</c:v>
+                </c:pt>
+                <c:pt idx="69">
                   <c:v>17.5935</c:v>
                 </c:pt>
-                <c:pt idx="23">
+                <c:pt idx="70">
+                  <c:v>17.5631</c:v>
+                </c:pt>
+                <c:pt idx="71">
+                  <c:v>16.5537</c:v>
+                </c:pt>
+                <c:pt idx="72">
+                  <c:v>16.4732</c:v>
+                </c:pt>
+                <c:pt idx="73">
                   <c:v>17.5928</c:v>
                 </c:pt>
-                <c:pt idx="24">
+                <c:pt idx="74">
                   <c:v>16.6836</c:v>
                 </c:pt>
-                <c:pt idx="25">
+                <c:pt idx="75">
+                  <c:v>16.5206</c:v>
+                </c:pt>
+                <c:pt idx="76">
+                  <c:v>16.5842</c:v>
+                </c:pt>
+                <c:pt idx="77">
+                  <c:v>16.5691</c:v>
+                </c:pt>
+                <c:pt idx="78">
                   <c:v>16.6726</c:v>
                 </c:pt>
-                <c:pt idx="26">
+                <c:pt idx="79">
+                  <c:v>17.5446</c:v>
+                </c:pt>
+                <c:pt idx="80">
+                  <c:v>17.5794</c:v>
+                </c:pt>
+                <c:pt idx="81">
+                  <c:v>15.6796</c:v>
+                </c:pt>
+                <c:pt idx="82">
+                  <c:v>17.4753</c:v>
+                </c:pt>
+                <c:pt idx="83">
+                  <c:v>16.5491</c:v>
+                </c:pt>
+                <c:pt idx="84">
                   <c:v>17.5648</c:v>
                 </c:pt>
-                <c:pt idx="27">
+                <c:pt idx="85">
                   <c:v/>
                 </c:pt>
-                <c:pt idx="28">
+                <c:pt idx="86">
                   <c:v>16.6661</c:v>
                 </c:pt>
-                <c:pt idx="29">
+                <c:pt idx="87">
                   <c:v>16.6393</c:v>
                 </c:pt>
-                <c:pt idx="30">
+                <c:pt idx="88">
+                  <c:v>16.4959</c:v>
+                </c:pt>
+                <c:pt idx="89">
+                  <c:v>17.4479</c:v>
+                </c:pt>
+                <c:pt idx="90">
+                  <c:v>17.5224</c:v>
+                </c:pt>
+                <c:pt idx="91">
                   <c:v/>
                 </c:pt>
-                <c:pt idx="31">
+                <c:pt idx="92">
+                  <c:v>17.4969</c:v>
+                </c:pt>
+                <c:pt idx="93">
+                  <c:v>17.4598</c:v>
+                </c:pt>
+                <c:pt idx="94">
                   <c:v>16.6401</c:v>
                 </c:pt>
-                <c:pt idx="32">
+                <c:pt idx="95">
+                  <c:v>16.6016</c:v>
+                </c:pt>
+                <c:pt idx="96">
+                  <c:v>16.5872</c:v>
+                </c:pt>
+                <c:pt idx="97">
                   <c:v>16.6595</c:v>
                 </c:pt>
-                <c:pt idx="33">
+                <c:pt idx="98">
+                  <c:v>15.6887</c:v>
+                </c:pt>
+                <c:pt idx="99">
+                  <c:v>17.5463</c:v>
+                </c:pt>
+                <c:pt idx="100">
+                  <c:v>17.4757</c:v>
+                </c:pt>
+                <c:pt idx="101">
+                  <c:v>17.5586</c:v>
+                </c:pt>
+                <c:pt idx="102">
                   <c:v/>
                 </c:pt>
-                <c:pt idx="34">
+                <c:pt idx="103">
                   <c:v>17.6002</c:v>
                 </c:pt>
-                <c:pt idx="35">
+                <c:pt idx="104">
+                  <c:v>16.4893</c:v>
+                </c:pt>
+                <c:pt idx="105">
+                  <c:v>17.4917</c:v>
+                </c:pt>
+                <c:pt idx="106">
                   <c:v>16.6521</c:v>
                 </c:pt>
-                <c:pt idx="36">
+                <c:pt idx="107">
                   <c:v>16.6602</c:v>
                 </c:pt>
-                <c:pt idx="37">
+                <c:pt idx="108">
+                  <c:v>17.5534</c:v>
+                </c:pt>
+                <c:pt idx="109">
+                  <c:v>17.496</c:v>
+                </c:pt>
+                <c:pt idx="110">
                   <c:v>17.5692</c:v>
                 </c:pt>
-                <c:pt idx="38">
+                <c:pt idx="111">
+                  <c:v>16.576</c:v>
+                </c:pt>
+                <c:pt idx="112">
+                  <c:v>17.575</c:v>
+                </c:pt>
+                <c:pt idx="113">
+                  <c:v>16.5514</c:v>
+                </c:pt>
+                <c:pt idx="114">
                   <c:v/>
                 </c:pt>
-                <c:pt idx="39">
+                <c:pt idx="115">
+                  <c:v>18.5351</c:v>
+                </c:pt>
+                <c:pt idx="116">
+                  <c:v>17.569</c:v>
+                </c:pt>
+                <c:pt idx="117">
                   <c:v>17.5766</c:v>
                 </c:pt>
-                <c:pt idx="40">
+                <c:pt idx="118">
                   <c:v>18.6454</c:v>
                 </c:pt>
-                <c:pt idx="41">
+                <c:pt idx="119">
+                  <c:v>16.6307</c:v>
+                </c:pt>
+                <c:pt idx="120">
+                  <c:v>17.5231</c:v>
+                </c:pt>
+                <c:pt idx="121">
+                  <c:v>17.508</c:v>
+                </c:pt>
+                <c:pt idx="122">
                   <c:v>17.5635</c:v>
                 </c:pt>
-                <c:pt idx="42">
+                <c:pt idx="123">
+                  <c:v>17.478</c:v>
+                </c:pt>
+                <c:pt idx="124">
                   <c:v>17.5888</c:v>
                 </c:pt>
-                <c:pt idx="43">
+                <c:pt idx="125">
+                  <c:v>17.5426</c:v>
+                </c:pt>
+                <c:pt idx="126">
                   <c:v>16.6145</c:v>
                 </c:pt>
-                <c:pt idx="44">
+                <c:pt idx="127">
+                  <c:v>18.4561</c:v>
+                </c:pt>
+                <c:pt idx="128">
                   <c:v>17.5845</c:v>
                 </c:pt>
-                <c:pt idx="45">
+                <c:pt idx="129">
+                  <c:v>18.4954</c:v>
+                </c:pt>
+                <c:pt idx="130">
+                  <c:v>17.4246</c:v>
+                </c:pt>
+                <c:pt idx="131">
+                  <c:v>18.4827</c:v>
+                </c:pt>
+                <c:pt idx="132">
+                  <c:v>17.5337</c:v>
+                </c:pt>
+                <c:pt idx="133">
+                  <c:v>17.5128</c:v>
+                </c:pt>
+                <c:pt idx="134">
+                  <c:v>17.461</c:v>
+                </c:pt>
+                <c:pt idx="135">
+                  <c:v>18.485</c:v>
+                </c:pt>
+                <c:pt idx="136">
+                  <c:v>17.4716</c:v>
+                </c:pt>
+                <c:pt idx="137">
+                  <c:v>17.4736</c:v>
+                </c:pt>
+                <c:pt idx="138">
                   <c:v>17.5943</c:v>
                 </c:pt>
-                <c:pt idx="46">
+                <c:pt idx="139">
                   <c:v>16.6424</c:v>
                 </c:pt>
-                <c:pt idx="47">
+                <c:pt idx="140">
                   <c:v>17.5791</c:v>
                 </c:pt>
-                <c:pt idx="48">
+                <c:pt idx="141">
+                  <c:v>17.4801</c:v>
+                </c:pt>
+                <c:pt idx="142">
+                  <c:v>18.5323</c:v>
+                </c:pt>
+                <c:pt idx="143">
+                  <c:v>17.4335</c:v>
+                </c:pt>
+                <c:pt idx="144">
+                  <c:v>18.5227</c:v>
+                </c:pt>
+                <c:pt idx="145">
+                  <c:v>18.6328</c:v>
+                </c:pt>
+                <c:pt idx="146">
+                  <c:v>16.5071</c:v>
+                </c:pt>
+                <c:pt idx="147">
                   <c:v>17.5625</c:v>
                 </c:pt>
-                <c:pt idx="49">
+                <c:pt idx="148">
+                  <c:v>17.5159</c:v>
+                </c:pt>
+                <c:pt idx="149">
+                  <c:v>16.5303</c:v>
+                </c:pt>
+                <c:pt idx="150">
+                  <c:v>17.4449</c:v>
+                </c:pt>
+                <c:pt idx="151">
+                  <c:v>18.449</c:v>
+                </c:pt>
+                <c:pt idx="152">
+                  <c:v>18.4652</c:v>
+                </c:pt>
+                <c:pt idx="153">
+                  <c:v>18.6257</c:v>
+                </c:pt>
+                <c:pt idx="154">
                   <c:v>17.5905</c:v>
                 </c:pt>
-                <c:pt idx="50">
+                <c:pt idx="155">
+                  <c:v/>
+                </c:pt>
+                <c:pt idx="156">
                   <c:v>17.5947</c:v>
                 </c:pt>
-                <c:pt idx="51">
+                <c:pt idx="157">
+                  <c:v>18.4681</c:v>
+                </c:pt>
+                <c:pt idx="158">
                   <c:v>17.5782</c:v>
                 </c:pt>
-                <c:pt idx="52">
+                <c:pt idx="159">
+                  <c:v>17.5072</c:v>
+                </c:pt>
+                <c:pt idx="160">
+                  <c:v>18.5192</c:v>
+                </c:pt>
+                <c:pt idx="161">
                   <c:v>18.6865</c:v>
                 </c:pt>
-                <c:pt idx="53">
+                <c:pt idx="162">
+                  <c:v>16.545</c:v>
+                </c:pt>
+                <c:pt idx="163">
+                  <c:v>17.5439</c:v>
+                </c:pt>
+                <c:pt idx="164">
+                  <c:v>18.5531</c:v>
+                </c:pt>
+                <c:pt idx="165">
+                  <c:v>16.5711</c:v>
+                </c:pt>
+                <c:pt idx="166">
+                  <c:v>18.6049</c:v>
+                </c:pt>
+                <c:pt idx="167">
                   <c:v/>
                 </c:pt>
-                <c:pt idx="54">
+                <c:pt idx="168">
+                  <c:v>18.5895</c:v>
+                </c:pt>
+                <c:pt idx="169">
                   <c:v>16.6244</c:v>
                 </c:pt>
-                <c:pt idx="55">
+                <c:pt idx="170">
+                  <c:v>17.3902</c:v>
+                </c:pt>
+                <c:pt idx="171">
+                  <c:v>17.5368</c:v>
+                </c:pt>
+                <c:pt idx="172">
                   <c:v>17.5647</c:v>
                 </c:pt>
-                <c:pt idx="56">
+                <c:pt idx="173">
                   <c:v>18.7251</c:v>
                 </c:pt>
-                <c:pt idx="57">
+                <c:pt idx="174">
+                  <c:v>18.5936</c:v>
+                </c:pt>
+                <c:pt idx="175">
+                  <c:v>18.484</c:v>
+                </c:pt>
+                <c:pt idx="176">
+                  <c:v>18.5711</c:v>
+                </c:pt>
+                <c:pt idx="177">
+                  <c:v>18.6257</c:v>
+                </c:pt>
+                <c:pt idx="178">
+                  <c:v>17.4488</c:v>
+                </c:pt>
+                <c:pt idx="179">
+                  <c:v>18.535</c:v>
+                </c:pt>
+                <c:pt idx="180">
+                  <c:v>18.4831</c:v>
+                </c:pt>
+                <c:pt idx="181">
+                  <c:v>17.4401</c:v>
+                </c:pt>
+                <c:pt idx="182">
+                  <c:v>18.5021</c:v>
+                </c:pt>
+                <c:pt idx="183">
+                  <c:v>18.5784</c:v>
+                </c:pt>
+                <c:pt idx="184">
+                  <c:v>18.5958</c:v>
+                </c:pt>
+                <c:pt idx="185">
+                  <c:v>17.5172</c:v>
+                </c:pt>
+                <c:pt idx="186">
+                  <c:v>19.6481</c:v>
+                </c:pt>
+                <c:pt idx="187">
+                  <c:v>17.5098</c:v>
+                </c:pt>
+                <c:pt idx="188">
+                  <c:v>18.5785</c:v>
+                </c:pt>
+                <c:pt idx="189">
+                  <c:v>18.5991</c:v>
+                </c:pt>
+                <c:pt idx="190">
+                  <c:v>19.8096</c:v>
+                </c:pt>
+                <c:pt idx="191">
+                  <c:v>17.487</c:v>
+                </c:pt>
+                <c:pt idx="192">
+                  <c:v>18.5695</c:v>
+                </c:pt>
+                <c:pt idx="193">
                   <c:v/>
                 </c:pt>
-                <c:pt idx="58">
+                <c:pt idx="194">
+                  <c:v>17.57</c:v>
+                </c:pt>
+                <c:pt idx="195">
+                  <c:v>17.5056</c:v>
+                </c:pt>
+                <c:pt idx="196">
+                  <c:v>18.4689</c:v>
+                </c:pt>
+                <c:pt idx="197">
+                  <c:v>17.5304</c:v>
+                </c:pt>
+                <c:pt idx="198">
+                  <c:v>19.7989</c:v>
+                </c:pt>
+                <c:pt idx="199">
+                  <c:v>17.51</c:v>
+                </c:pt>
+                <c:pt idx="200">
+                  <c:v>18.5172</c:v>
+                </c:pt>
+                <c:pt idx="201">
+                  <c:v>18.5548</c:v>
+                </c:pt>
+                <c:pt idx="202">
+                  <c:v>17.4545</c:v>
+                </c:pt>
+                <c:pt idx="203">
+                  <c:v>19.7435</c:v>
+                </c:pt>
+                <c:pt idx="204">
+                  <c:v>18.5767</c:v>
+                </c:pt>
+                <c:pt idx="205">
                   <c:v/>
                 </c:pt>
-                <c:pt idx="59">
+                <c:pt idx="206">
+                  <c:v>19.8033</c:v>
+                </c:pt>
+                <c:pt idx="207">
+                  <c:v>17.6146</c:v>
+                </c:pt>
+                <c:pt idx="208">
+                  <c:v>17.5649</c:v>
+                </c:pt>
+                <c:pt idx="209">
                   <c:v>18.8435</c:v>
                 </c:pt>
-                <c:pt idx="60">
+                <c:pt idx="210">
+                  <c:v>18.5221</c:v>
+                </c:pt>
+                <c:pt idx="211">
+                  <c:v>18.7372</c:v>
+                </c:pt>
+                <c:pt idx="212">
+                  <c:v>18.5423</c:v>
+                </c:pt>
+                <c:pt idx="213">
+                  <c:v>19.831</c:v>
+                </c:pt>
+                <c:pt idx="214">
+                  <c:v>18.6339</c:v>
+                </c:pt>
+                <c:pt idx="215">
+                  <c:v>18.5519</c:v>
+                </c:pt>
+                <c:pt idx="216">
                   <c:v>18.637</c:v>
                 </c:pt>
-                <c:pt idx="61">
+                <c:pt idx="217">
+                  <c:v>18.5897</c:v>
+                </c:pt>
+                <c:pt idx="218">
                   <c:v>19.8896</c:v>
                 </c:pt>
-                <c:pt idx="62">
+                <c:pt idx="219">
+                  <c:v>18.6074</c:v>
+                </c:pt>
+                <c:pt idx="220">
+                  <c:v/>
+                </c:pt>
+                <c:pt idx="221">
+                  <c:v>18.6281</c:v>
+                </c:pt>
+                <c:pt idx="222">
+                  <c:v>19.7046</c:v>
+                </c:pt>
+                <c:pt idx="223">
+                  <c:v>18.5337</c:v>
+                </c:pt>
+                <c:pt idx="224">
+                  <c:v>18.4454</c:v>
+                </c:pt>
+                <c:pt idx="225">
+                  <c:v>19.78</c:v>
+                </c:pt>
+                <c:pt idx="226">
+                  <c:v>18.5465</c:v>
+                </c:pt>
+                <c:pt idx="227">
                   <c:v>18.6955</c:v>
                 </c:pt>
-                <c:pt idx="63">
+                <c:pt idx="228">
+                  <c:v>19.678</c:v>
+                </c:pt>
+                <c:pt idx="229">
+                  <c:v>18.5838</c:v>
+                </c:pt>
+                <c:pt idx="230">
                   <c:v/>
                 </c:pt>
-                <c:pt idx="64">
+                <c:pt idx="231">
+                  <c:v>18.5063</c:v>
+                </c:pt>
+                <c:pt idx="232">
+                  <c:v>18.512</c:v>
+                </c:pt>
+                <c:pt idx="233">
+                  <c:v>19.8502</c:v>
+                </c:pt>
+                <c:pt idx="234">
                   <c:v>18.6995</c:v>
                 </c:pt>
-                <c:pt idx="65">
+                <c:pt idx="235">
+                  <c:v>19.6411</c:v>
+                </c:pt>
+                <c:pt idx="236">
                   <c:v>19.8354</c:v>
                 </c:pt>
-                <c:pt idx="66">
+                <c:pt idx="237">
                   <c:v>19.836</c:v>
                 </c:pt>
-                <c:pt idx="67">
+                <c:pt idx="238">
+                  <c:v>19.7072</c:v>
+                </c:pt>
+                <c:pt idx="239">
                   <c:v>19.8339</c:v>
                 </c:pt>
-                <c:pt idx="68">
+                <c:pt idx="240">
                   <c:v>19.9123</c:v>
                 </c:pt>
-                <c:pt idx="69">
+                <c:pt idx="241">
+                  <c:v>20.0913</c:v>
+                </c:pt>
+                <c:pt idx="242">
                   <c:v/>
                 </c:pt>
-                <c:pt idx="70">
+                <c:pt idx="243">
+                  <c:v>19.665</c:v>
+                </c:pt>
+                <c:pt idx="244">
                   <c:v>19.8041</c:v>
                 </c:pt>
-                <c:pt idx="71">
+                <c:pt idx="245">
                   <c:v>20.0808</c:v>
                 </c:pt>
-                <c:pt idx="72">
+                <c:pt idx="246">
+                  <c:v>19.7399</c:v>
+                </c:pt>
+                <c:pt idx="247">
+                  <c:v>19.8387</c:v>
+                </c:pt>
+                <c:pt idx="248">
+                  <c:v>19.8067</c:v>
+                </c:pt>
+                <c:pt idx="249">
+                  <c:v>21.4046</c:v>
+                </c:pt>
+                <c:pt idx="250">
+                  <c:v>21.0921</c:v>
+                </c:pt>
+                <c:pt idx="251">
                   <c:v>21.4639</c:v>
                 </c:pt>
-                <c:pt idx="73">
+                <c:pt idx="252">
+                  <c:v>21.3788</c:v>
+                </c:pt>
+                <c:pt idx="253">
                   <c:v>21.2468</c:v>
                 </c:pt>
-                <c:pt idx="74">
+                <c:pt idx="254">
+                  <c:v>21.0196</c:v>
+                </c:pt>
+                <c:pt idx="255">
                   <c:v/>
                 </c:pt>
               </c:numCache>
@@ -4068,7 +5850,7 @@
               <c:strCache>
                 <c:ptCount val="1"/>
                 <c:pt idx="0">
-                  <c:v>Pareto front (accuracy vs decode)</c:v>
+                  <c:v>front for accuracy and decode</c:v>
                 </c:pt>
               </c:strCache>
             </c:strRef>
@@ -4101,10 +5883,10 @@
           </c:marker>
           <c:xVal>
             <c:numRef>
-              <c:f>Sheet1!$A$2:$A$76</c:f>
+              <c:f>Sheet1!$A$2:$A$257</c:f>
               <c:numCache>
                 <c:formatCode>General</c:formatCode>
-                <c:ptCount val="75"/>
+                <c:ptCount val="256"/>
                 <c:pt idx="0">
                   <c:v>0.8037125677301304</c:v>
                 </c:pt>
@@ -4112,222 +5894,765 @@
                   <c:v>1.0274423112758946</c:v>
                 </c:pt>
                 <c:pt idx="2">
+                  <c:v>1.0418902685307208</c:v>
+                </c:pt>
+                <c:pt idx="3">
+                  <c:v>1.0637176741036702</c:v>
+                </c:pt>
+                <c:pt idx="4">
                   <c:v>1.119722485595509</c:v>
                 </c:pt>
-                <c:pt idx="3">
+                <c:pt idx="5">
+                  <c:v>1.12356510805931</c:v>
+                </c:pt>
+                <c:pt idx="6">
                   <c:v>1.2789089764170702</c:v>
                 </c:pt>
-                <c:pt idx="4">
+                <c:pt idx="7">
+                  <c:v>1.2938993642069185</c:v>
+                </c:pt>
+                <c:pt idx="8">
+                  <c:v>1.300888884398721</c:v>
+                </c:pt>
+                <c:pt idx="9">
+                  <c:v>1.3788192283276324</c:v>
+                </c:pt>
+                <c:pt idx="10">
+                  <c:v>1.3978802380213429</c:v>
+                </c:pt>
+                <c:pt idx="11">
+                  <c:v>1.399198419032599</c:v>
+                </c:pt>
+                <c:pt idx="12">
+                  <c:v>1.419277448077838</c:v>
+                </c:pt>
+                <c:pt idx="13">
+                  <c:v>1.4236385707715682</c:v>
+                </c:pt>
+                <c:pt idx="14">
+                  <c:v>1.4239428421436884</c:v>
+                </c:pt>
+                <c:pt idx="15">
+                  <c:v>1.4476788217700598</c:v>
+                </c:pt>
+                <c:pt idx="16">
+                  <c:v>1.4480846132969294</c:v>
+                </c:pt>
+                <c:pt idx="17">
+                  <c:v>1.451432455328261</c:v>
+                </c:pt>
+                <c:pt idx="18">
                   <c:v>1.4855258640051439</c:v>
                 </c:pt>
-                <c:pt idx="5">
+                <c:pt idx="19">
                   <c:v>1.5047084410898748</c:v>
                 </c:pt>
-                <c:pt idx="6">
+                <c:pt idx="20">
+                  <c:v>1.527854153125352</c:v>
+                </c:pt>
+                <c:pt idx="21">
+                  <c:v>1.5698953866796206</c:v>
+                </c:pt>
+                <c:pt idx="22">
                   <c:v>1.5702000968228491</c:v>
                 </c:pt>
-                <c:pt idx="7">
+                <c:pt idx="23">
+                  <c:v>1.6096169808414107</c:v>
+                </c:pt>
+                <c:pt idx="24">
+                  <c:v>1.6366487340220948</c:v>
+                </c:pt>
+                <c:pt idx="25">
                   <c:v>1.6759897290737014</c:v>
                 </c:pt>
-                <c:pt idx="8">
+                <c:pt idx="26">
+                  <c:v>1.6794467714938754</c:v>
+                </c:pt>
+                <c:pt idx="27">
+                  <c:v>1.680768612893857</c:v>
+                </c:pt>
+                <c:pt idx="28">
+                  <c:v>1.699276196920474</c:v>
+                </c:pt>
+                <c:pt idx="29">
+                  <c:v>1.7011068003673913</c:v>
+                </c:pt>
+                <c:pt idx="30">
                   <c:v>1.7044629922686738</c:v>
                 </c:pt>
-                <c:pt idx="9">
+                <c:pt idx="31">
                   <c:v>1.714837376578493</c:v>
                 </c:pt>
-                <c:pt idx="10">
+                <c:pt idx="32">
+                  <c:v>1.7361997353967373</c:v>
+                </c:pt>
+                <c:pt idx="33">
+                  <c:v>1.73670841766711</c:v>
+                </c:pt>
+                <c:pt idx="34">
+                  <c:v>1.7375223145900343</c:v>
+                </c:pt>
+                <c:pt idx="35">
+                  <c:v>1.7505455509156498</c:v>
+                </c:pt>
+                <c:pt idx="36">
                   <c:v>1.7741544160059242</c:v>
                 </c:pt>
-                <c:pt idx="11">
+                <c:pt idx="37">
+                  <c:v>1.7799557081428885</c:v>
+                </c:pt>
+                <c:pt idx="38">
+                  <c:v>1.7811770749395883</c:v>
+                </c:pt>
+                <c:pt idx="39">
+                  <c:v>1.798277749104571</c:v>
+                </c:pt>
+                <c:pt idx="40">
+                  <c:v>1.8121232563516054</c:v>
+                </c:pt>
+                <c:pt idx="41">
+                  <c:v>1.8160940065877318</c:v>
+                </c:pt>
+                <c:pt idx="42">
+                  <c:v>1.8172139897816963</c:v>
+                </c:pt>
+                <c:pt idx="43">
+                  <c:v>1.8294327885737482</c:v>
+                </c:pt>
+                <c:pt idx="44">
                   <c:v>1.8660979837167746</c:v>
                 </c:pt>
-                <c:pt idx="12">
+                <c:pt idx="45">
+                  <c:v>1.8697652292541944</c:v>
+                </c:pt>
+                <c:pt idx="46">
+                  <c:v>1.870682061267015</c:v>
+                </c:pt>
+                <c:pt idx="47">
                   <c:v>1.881990334573369</c:v>
                 </c:pt>
-                <c:pt idx="13">
+                <c:pt idx="48">
                   <c:v>1.9391621663504388</c:v>
                 </c:pt>
-                <c:pt idx="14">
+                <c:pt idx="49">
                   <c:v>1.9435456445676902</c:v>
                 </c:pt>
-                <c:pt idx="15">
+                <c:pt idx="50">
+                  <c:v>1.948948795669092</c:v>
+                </c:pt>
+                <c:pt idx="51">
+                  <c:v>1.9494585416874433</c:v>
+                </c:pt>
+                <c:pt idx="52">
+                  <c:v>1.9527209765594522</c:v>
+                </c:pt>
+                <c:pt idx="53">
                   <c:v>1.9532307414387606</c:v>
                 </c:pt>
-                <c:pt idx="16">
+                <c:pt idx="54">
+                  <c:v>1.9689327479964103</c:v>
+                </c:pt>
+                <c:pt idx="55">
+                  <c:v>1.9789261930765134</c:v>
+                </c:pt>
+                <c:pt idx="56">
                   <c:v>1.9909604163725225</c:v>
                 </c:pt>
-                <c:pt idx="17">
+                <c:pt idx="57">
+                  <c:v>2.0341117184856206</c:v>
+                </c:pt>
+                <c:pt idx="58">
+                  <c:v>2.0438054195423883</c:v>
+                </c:pt>
+                <c:pt idx="59">
+                  <c:v>2.044213595580424</c:v>
+                </c:pt>
+                <c:pt idx="60">
                   <c:v>2.0469688265429387</c:v>
                 </c:pt>
-                <c:pt idx="18">
+                <c:pt idx="61">
+                  <c:v>2.049520032653551</c:v>
+                </c:pt>
+                <c:pt idx="62">
                   <c:v>2.071973396840243</c:v>
                 </c:pt>
-                <c:pt idx="19">
+                <c:pt idx="63">
                   <c:v>2.0779958209304006</c:v>
                 </c:pt>
-                <c:pt idx="20">
+                <c:pt idx="64">
                   <c:v>2.086366559783337</c:v>
                 </c:pt>
-                <c:pt idx="21">
+                <c:pt idx="65">
+                  <c:v>2.1088280310977314</c:v>
+                </c:pt>
+                <c:pt idx="66">
+                  <c:v>2.119754260239892</c:v>
+                </c:pt>
+                <c:pt idx="67">
                   <c:v>2.1212860680423384</c:v>
                 </c:pt>
-                <c:pt idx="22">
+                <c:pt idx="68">
+                  <c:v>2.1266986396358156</c:v>
+                </c:pt>
+                <c:pt idx="69">
                   <c:v>2.1443680868635795</c:v>
                 </c:pt>
-                <c:pt idx="23">
+                <c:pt idx="70">
+                  <c:v>2.1531528802597677</c:v>
+                </c:pt>
+                <c:pt idx="71">
+                  <c:v>2.162551402650137</c:v>
+                </c:pt>
+                <c:pt idx="72">
+                  <c:v>2.164799003504525</c:v>
+                </c:pt>
+                <c:pt idx="73">
                   <c:v>2.175935573527954</c:v>
                 </c:pt>
-                <c:pt idx="24">
+                <c:pt idx="74">
                   <c:v>2.177059515000912</c:v>
                 </c:pt>
-                <c:pt idx="25">
+                <c:pt idx="75">
+                  <c:v>2.1813510416219817</c:v>
+                </c:pt>
+                <c:pt idx="76">
+                  <c:v>2.1829859563179177</c:v>
+                </c:pt>
+                <c:pt idx="77">
+                  <c:v>2.1880952333465986</c:v>
+                </c:pt>
+                <c:pt idx="78">
                   <c:v>2.1904455865659367</c:v>
                 </c:pt>
-                <c:pt idx="26">
+                <c:pt idx="79">
+                  <c:v>2.1920806467757625</c:v>
+                </c:pt>
+                <c:pt idx="80">
+                  <c:v>2.1923872234775654</c:v>
+                </c:pt>
+                <c:pt idx="81">
+                  <c:v>2.2018915574340214</c:v>
+                </c:pt>
+                <c:pt idx="82">
+                  <c:v>2.222231757636761</c:v>
+                </c:pt>
+                <c:pt idx="83">
+                  <c:v>2.2370550559047686</c:v>
+                </c:pt>
+                <c:pt idx="84">
                   <c:v>2.2417580686058036</c:v>
                 </c:pt>
-                <c:pt idx="27">
+                <c:pt idx="85">
                   <c:v>2.252800774772612</c:v>
                 </c:pt>
-                <c:pt idx="28">
+                <c:pt idx="86">
                   <c:v>2.2767307298494632</c:v>
                 </c:pt>
-                <c:pt idx="29">
+                <c:pt idx="87">
                   <c:v>2.2767307298494632</c:v>
                 </c:pt>
-                <c:pt idx="30">
+                <c:pt idx="88">
+                  <c:v>2.2775489469681665</c:v>
+                </c:pt>
+                <c:pt idx="89">
+                  <c:v>2.2801059176538407</c:v>
+                </c:pt>
+                <c:pt idx="90">
+                  <c:v>2.2854246214466523</c:v>
+                </c:pt>
+                <c:pt idx="91">
                   <c:v>2.302098504544503</c:v>
                 </c:pt>
-                <c:pt idx="31">
+                <c:pt idx="92">
+                  <c:v>2.3047583936840255</c:v>
+                </c:pt>
+                <c:pt idx="93">
+                  <c:v>2.319491339639379</c:v>
+                </c:pt>
+                <c:pt idx="94">
                   <c:v>2.3201052584291615</c:v>
                 </c:pt>
-                <c:pt idx="32">
+                <c:pt idx="95">
+                  <c:v>2.3207191809024863</c:v>
+                </c:pt>
+                <c:pt idx="96">
+                  <c:v>2.3363754486110944</c:v>
+                </c:pt>
+                <c:pt idx="97">
                   <c:v>2.3373988174824056</c:v>
                 </c:pt>
-                <c:pt idx="33">
+                <c:pt idx="98">
+                  <c:v>2.3620651027654205</c:v>
+                </c:pt>
+                <c:pt idx="99">
+                  <c:v>2.363907636520013</c:v>
+                </c:pt>
+                <c:pt idx="100">
+                  <c:v>2.366876232885917</c:v>
+                </c:pt>
+                <c:pt idx="101">
+                  <c:v>2.3773181867922766</c:v>
+                </c:pt>
+                <c:pt idx="102">
                   <c:v>2.3809014556356534</c:v>
                 </c:pt>
-                <c:pt idx="34">
+                <c:pt idx="103">
                   <c:v>2.3877612058322395</c:v>
                 </c:pt>
-                <c:pt idx="35">
+                <c:pt idx="104">
+                  <c:v>2.39144723158371</c:v>
+                </c:pt>
+                <c:pt idx="105">
+                  <c:v>2.3943142322440325</c:v>
+                </c:pt>
+                <c:pt idx="106">
                   <c:v>2.4024037025982325</c:v>
                 </c:pt>
-                <c:pt idx="36">
+                <c:pt idx="107">
                   <c:v>2.4049637946918168</c:v>
                 </c:pt>
-                <c:pt idx="37">
+                <c:pt idx="108">
+                  <c:v>2.4254468356865955</c:v>
+                </c:pt>
+                <c:pt idx="109">
+                  <c:v>2.426880801980036</c:v>
+                </c:pt>
+                <c:pt idx="110">
                   <c:v>2.4270856559464926</c:v>
                 </c:pt>
-                <c:pt idx="38">
+                <c:pt idx="111">
+                  <c:v>2.427802648055555</c:v>
+                </c:pt>
+                <c:pt idx="112">
+                  <c:v>2.4288269312034316</c:v>
+                </c:pt>
+                <c:pt idx="113">
+                  <c:v>2.431490115324886</c:v>
+                </c:pt>
+                <c:pt idx="114">
                   <c:v>2.449929443035348</c:v>
                 </c:pt>
-                <c:pt idx="39">
+                <c:pt idx="115">
+                  <c:v>2.4656054814264916</c:v>
+                </c:pt>
+                <c:pt idx="116">
+                  <c:v>2.4657079470832066</c:v>
+                </c:pt>
+                <c:pt idx="117">
                   <c:v>2.4714461873974747</c:v>
                 </c:pt>
-                <c:pt idx="40">
+                <c:pt idx="118">
                   <c:v>2.479029354989093</c:v>
                 </c:pt>
-                <c:pt idx="41">
+                <c:pt idx="119">
+                  <c:v>2.49163505083414</c:v>
+                </c:pt>
+                <c:pt idx="120">
+                  <c:v>2.5155183841012674</c:v>
+                </c:pt>
+                <c:pt idx="121">
+                  <c:v>2.5183888588024894</c:v>
+                </c:pt>
+                <c:pt idx="122">
                   <c:v>2.524232573511731</c:v>
                 </c:pt>
-                <c:pt idx="42">
+                <c:pt idx="123">
+                  <c:v>2.52730834662529</c:v>
+                </c:pt>
+                <c:pt idx="124">
                   <c:v>2.5771487287135963</c:v>
                 </c:pt>
-                <c:pt idx="43">
+                <c:pt idx="125">
+                  <c:v>2.5796106098255445</c:v>
+                </c:pt>
+                <c:pt idx="126">
                   <c:v>2.585662985394843</c:v>
                 </c:pt>
-                <c:pt idx="44">
+                <c:pt idx="127">
+                  <c:v>2.5877147191718075</c:v>
+                </c:pt>
+                <c:pt idx="128">
                   <c:v>2.5978714056767105</c:v>
                 </c:pt>
-                <c:pt idx="45">
+                <c:pt idx="129">
+                  <c:v>2.6139805360210433</c:v>
+                </c:pt>
+                <c:pt idx="130">
+                  <c:v>2.6236267035541827</c:v>
+                </c:pt>
+                <c:pt idx="131">
+                  <c:v>2.624037198882001</c:v>
+                </c:pt>
+                <c:pt idx="132">
+                  <c:v>2.6267054585363825</c:v>
+                </c:pt>
+                <c:pt idx="133">
+                  <c:v>2.6270133391145922</c:v>
+                </c:pt>
+                <c:pt idx="134">
+                  <c:v>2.6326579800744376</c:v>
+                </c:pt>
+                <c:pt idx="135">
+                  <c:v>2.6339922133006732</c:v>
+                </c:pt>
+                <c:pt idx="136">
+                  <c:v>2.6377897412664053</c:v>
+                </c:pt>
+                <c:pt idx="137">
+                  <c:v>2.63871348553093</c:v>
+                </c:pt>
+                <c:pt idx="138">
                   <c:v>2.6539051392814317</c:v>
                 </c:pt>
-                <c:pt idx="46">
+                <c:pt idx="139">
                   <c:v>2.6642737073043765</c:v>
                 </c:pt>
-                <c:pt idx="47">
+                <c:pt idx="140">
                   <c:v>2.6658136829597723</c:v>
                 </c:pt>
-                <c:pt idx="48">
+                <c:pt idx="141">
+                  <c:v>2.6662243470358282</c:v>
+                </c:pt>
+                <c:pt idx="142">
+                  <c:v>2.6670456801159315</c:v>
+                </c:pt>
+                <c:pt idx="143">
+                  <c:v>2.6992881942693003</c:v>
+                </c:pt>
+                <c:pt idx="144">
+                  <c:v>2.700520593122002</c:v>
+                </c:pt>
+                <c:pt idx="145">
+                  <c:v>2.7023692191302517</c:v>
+                </c:pt>
+                <c:pt idx="146">
+                  <c:v>2.710174895802875</c:v>
+                </c:pt>
+                <c:pt idx="147">
                   <c:v>2.7158241107741343</c:v>
                 </c:pt>
-                <c:pt idx="49">
+                <c:pt idx="148">
+                  <c:v>2.723014470121532</c:v>
+                </c:pt>
+                <c:pt idx="149">
+                  <c:v>2.7316435657539495</c:v>
+                </c:pt>
+                <c:pt idx="150">
+                  <c:v>2.7321572252559267</c:v>
+                </c:pt>
+                <c:pt idx="151">
+                  <c:v>2.732876352873448</c:v>
+                </c:pt>
+                <c:pt idx="152">
+                  <c:v>2.7379103871475685</c:v>
+                </c:pt>
+                <c:pt idx="153">
+                  <c:v>2.7473627097033715</c:v>
+                </c:pt>
+                <c:pt idx="154">
                   <c:v>2.7505479273179922</c:v>
                 </c:pt>
-                <c:pt idx="50">
+                <c:pt idx="155">
+                  <c:v>2.7603096930476134</c:v>
+                </c:pt>
+                <c:pt idx="156">
                   <c:v>2.7755193443686155</c:v>
                 </c:pt>
-                <c:pt idx="51">
+                <c:pt idx="157">
+                  <c:v>2.7875447836063882</c:v>
+                </c:pt>
+                <c:pt idx="158">
                   <c:v>2.7947401635765923</c:v>
                 </c:pt>
-                <c:pt idx="52">
+                <c:pt idx="159">
+                  <c:v>2.8117026950739588</c:v>
+                </c:pt>
+                <c:pt idx="160">
+                  <c:v>2.826508646264947</c:v>
+                </c:pt>
+                <c:pt idx="161">
                   <c:v>2.827022780093502</c:v>
                 </c:pt>
-                <c:pt idx="53">
+                <c:pt idx="162">
+                  <c:v>2.844710549116214</c:v>
+                </c:pt>
+                <c:pt idx="163">
+                  <c:v>2.84563615567639</c:v>
+                </c:pt>
+                <c:pt idx="164">
+                  <c:v>2.8524241916653814</c:v>
+                </c:pt>
+                <c:pt idx="165">
+                  <c:v>2.862092773955638</c:v>
+                </c:pt>
+                <c:pt idx="166">
+                  <c:v>2.8655901445649112</c:v>
+                </c:pt>
+                <c:pt idx="167">
                   <c:v>2.8899721785860866</c:v>
                 </c:pt>
-                <c:pt idx="54">
+                <c:pt idx="168">
+                  <c:v>2.8940878597863096</c:v>
+                </c:pt>
+                <c:pt idx="169">
                   <c:v>2.913125026924024</c:v>
                 </c:pt>
-                <c:pt idx="55">
+                <c:pt idx="170">
+                  <c:v>2.915080394875491</c:v>
+                </c:pt>
+                <c:pt idx="171">
+                  <c:v>2.925475342931394</c:v>
+                </c:pt>
+                <c:pt idx="172">
                   <c:v>2.926298750027767</c:v>
                 </c:pt>
-                <c:pt idx="56">
+                <c:pt idx="173">
                   <c:v>2.9269163096729445</c:v>
                 </c:pt>
-                <c:pt idx="57">
+                <c:pt idx="174">
+                  <c:v>2.9417388528190314</c:v>
+                </c:pt>
+                <c:pt idx="175">
+                  <c:v>2.9426653326378727</c:v>
+                </c:pt>
+                <c:pt idx="176">
+                  <c:v>2.94657722824605</c:v>
+                </c:pt>
+                <c:pt idx="177">
+                  <c:v>2.9615055642223442</c:v>
+                </c:pt>
+                <c:pt idx="178">
+                  <c:v>2.9735527651208793</c:v>
+                </c:pt>
+                <c:pt idx="179">
+                  <c:v>2.973655738725123</c:v>
+                </c:pt>
+                <c:pt idx="180">
+                  <c:v>2.981482033956717</c:v>
+                </c:pt>
+                <c:pt idx="181">
+                  <c:v>2.983026767772712</c:v>
+                </c:pt>
+                <c:pt idx="182">
+                  <c:v>3.0030074130255713</c:v>
+                </c:pt>
+                <c:pt idx="183">
+                  <c:v>3.0097028261059755</c:v>
+                </c:pt>
+                <c:pt idx="184">
+                  <c:v>3.0263917497301396</c:v>
+                </c:pt>
+                <c:pt idx="185">
+                  <c:v>3.0268038561213517</c:v>
+                </c:pt>
+                <c:pt idx="186">
+                  <c:v>3.0350463301243913</c:v>
+                </c:pt>
+                <c:pt idx="187">
+                  <c:v>3.0416407841098003</c:v>
+                </c:pt>
+                <c:pt idx="188">
+                  <c:v>3.0459686239067363</c:v>
+                </c:pt>
+                <c:pt idx="189">
+                  <c:v>3.0548309582832944</c:v>
+                </c:pt>
+                <c:pt idx="190">
+                  <c:v>3.055346233726275</c:v>
+                </c:pt>
+                <c:pt idx="191">
+                  <c:v>3.0580257075613737</c:v>
+                </c:pt>
+                <c:pt idx="192">
+                  <c:v>3.0666829453197098</c:v>
+                </c:pt>
+                <c:pt idx="193">
                   <c:v>3.082350271814027</c:v>
                 </c:pt>
-                <c:pt idx="58">
+                <c:pt idx="194">
+                  <c:v>3.0977106863270043</c:v>
+                </c:pt>
+                <c:pt idx="195">
+                  <c:v>3.0993602628945682</c:v>
+                </c:pt>
+                <c:pt idx="196">
+                  <c:v>3.100803664042018</c:v>
+                </c:pt>
+                <c:pt idx="197">
+                  <c:v>3.114104525601813</c:v>
+                </c:pt>
+                <c:pt idx="198">
+                  <c:v>3.117197995139387</c:v>
+                </c:pt>
+                <c:pt idx="199">
+                  <c:v>3.122044617339892</c:v>
+                </c:pt>
+                <c:pt idx="200">
+                  <c:v>3.130604102256851</c:v>
+                </c:pt>
+                <c:pt idx="201">
+                  <c:v>3.1394737155975516</c:v>
+                </c:pt>
+                <c:pt idx="202">
+                  <c:v>3.1746502733968063</c:v>
+                </c:pt>
+                <c:pt idx="203">
+                  <c:v>3.2018919768156184</c:v>
+                </c:pt>
+                <c:pt idx="204">
+                  <c:v>3.218095945834243</c:v>
+                </c:pt>
+                <c:pt idx="205">
                   <c:v>3.235644513731062</c:v>
                 </c:pt>
-                <c:pt idx="59">
+                <c:pt idx="206">
+                  <c:v>3.243903695655015</c:v>
+                </c:pt>
+                <c:pt idx="207">
+                  <c:v>3.259494702204435</c:v>
+                </c:pt>
+                <c:pt idx="208">
+                  <c:v>3.2661035213453316</c:v>
+                </c:pt>
+                <c:pt idx="209">
                   <c:v>3.2828339852467803</c:v>
                 </c:pt>
-                <c:pt idx="60">
+                <c:pt idx="210">
+                  <c:v>3.2872752425944896</c:v>
+                </c:pt>
+                <c:pt idx="211">
+                  <c:v>3.300600160539524</c:v>
+                </c:pt>
+                <c:pt idx="212">
+                  <c:v>3.3021496811633133</c:v>
+                </c:pt>
+                <c:pt idx="213">
+                  <c:v>3.3103108733509634</c:v>
+                </c:pt>
+                <c:pt idx="214">
+                  <c:v>3.321675632597332</c:v>
+                </c:pt>
+                <c:pt idx="215">
+                  <c:v>3.3342816459756897</c:v>
+                </c:pt>
+                <c:pt idx="216">
                   <c:v>3.3400685277790387</c:v>
                 </c:pt>
-                <c:pt idx="61">
+                <c:pt idx="217">
+                  <c:v>3.345752387852796</c:v>
+                </c:pt>
+                <c:pt idx="218">
                   <c:v>3.3495762514321736</c:v>
                 </c:pt>
-                <c:pt idx="62">
+                <c:pt idx="219">
+                  <c:v>3.3515399120356726</c:v>
+                </c:pt>
+                <c:pt idx="220">
+                  <c:v>3.35350360994906</c:v>
+                </c:pt>
+                <c:pt idx="221">
+                  <c:v>3.3630125696866298</c:v>
+                </c:pt>
+                <c:pt idx="222">
+                  <c:v>3.3648731206577853</c:v>
+                </c:pt>
+                <c:pt idx="223">
+                  <c:v>3.4073648149554048</c:v>
+                </c:pt>
+                <c:pt idx="224">
+                  <c:v>3.4177060684909666</c:v>
+                </c:pt>
+                <c:pt idx="225">
+                  <c:v>3.4195676039539658</c:v>
+                </c:pt>
+                <c:pt idx="226">
+                  <c:v>3.419981283051743</c:v>
+                </c:pt>
+                <c:pt idx="227">
                   <c:v>3.4220497033615294</c:v>
                 </c:pt>
-                <c:pt idx="63">
+                <c:pt idx="228">
+                  <c:v>3.4534947858817278</c:v>
+                </c:pt>
+                <c:pt idx="229">
+                  <c:v>3.4625990940065687</c:v>
+                </c:pt>
+                <c:pt idx="230">
                   <c:v>3.4855703407194794</c:v>
                 </c:pt>
-                <c:pt idx="64">
+                <c:pt idx="231">
+                  <c:v>3.4867086882541365</c:v>
+                </c:pt>
+                <c:pt idx="232">
+                  <c:v>3.566009875586551</c:v>
+                </c:pt>
+                <c:pt idx="233">
+                  <c:v>3.5687026268489186</c:v>
+                </c:pt>
+                <c:pt idx="234">
                   <c:v>3.572638312326304</c:v>
                 </c:pt>
-                <c:pt idx="65">
+                <c:pt idx="235">
+                  <c:v>3.584342681740016</c:v>
+                </c:pt>
+                <c:pt idx="236">
                   <c:v>3.584964189660611</c:v>
                 </c:pt>
-                <c:pt idx="66">
+                <c:pt idx="237">
                   <c:v>3.5891076710972802</c:v>
                 </c:pt>
-                <c:pt idx="67">
+                <c:pt idx="238">
+                  <c:v>3.6379096327701532</c:v>
+                </c:pt>
+                <c:pt idx="239">
                   <c:v>3.641433381601056</c:v>
                 </c:pt>
-                <c:pt idx="68">
+                <c:pt idx="240">
                   <c:v>3.67004236507249</c:v>
                 </c:pt>
-                <c:pt idx="69">
+                <c:pt idx="241">
+                  <c:v>3.6866308988982244</c:v>
+                </c:pt>
+                <c:pt idx="242">
                   <c:v>3.689015718834221</c:v>
                 </c:pt>
-                <c:pt idx="70">
+                <c:pt idx="243">
+                  <c:v>3.692748590591388</c:v>
+                </c:pt>
+                <c:pt idx="244">
                   <c:v>3.7084073778372417</c:v>
                 </c:pt>
-                <c:pt idx="71">
+                <c:pt idx="245">
                   <c:v>3.7540491175298785</c:v>
                 </c:pt>
-                <c:pt idx="72">
+                <c:pt idx="246">
+                  <c:v>3.7693020838157176</c:v>
+                </c:pt>
+                <c:pt idx="247">
+                  <c:v>3.78341566860112</c:v>
+                </c:pt>
+                <c:pt idx="248">
+                  <c:v>3.8034478008637462</c:v>
+                </c:pt>
+                <c:pt idx="249">
+                  <c:v>3.8826800547967943</c:v>
+                </c:pt>
+                <c:pt idx="250">
+                  <c:v>3.9015884231760944</c:v>
+                </c:pt>
+                <c:pt idx="251">
                   <c:v>3.95875001480559</c:v>
                 </c:pt>
-                <c:pt idx="73">
+                <c:pt idx="252">
+                  <c:v>4.036228140584952</c:v>
+                </c:pt>
+                <c:pt idx="253">
                   <c:v>4.049233481919434</c:v>
                 </c:pt>
-                <c:pt idx="74">
+                <c:pt idx="254">
+                  <c:v>4.051418538765561</c:v>
+                </c:pt>
+                <c:pt idx="255">
                   <c:v>4.339518826123245</c:v>
                 </c:pt>
               </c:numCache>
@@ -4335,10 +6660,10 @@
           </c:xVal>
           <c:yVal>
             <c:numRef>
-              <c:f>Sheet1!$C$2:$C$76</c:f>
+              <c:f>Sheet1!$C$2:$C$257</c:f>
               <c:numCache>
                 <c:formatCode>General</c:formatCode>
-                <c:ptCount val="75"/>
+                <c:ptCount val="256"/>
                 <c:pt idx="0">
                   <c:v>14.2796</c:v>
                 </c:pt>
@@ -4346,22 +6671,22 @@
                   <c:v>14.874</c:v>
                 </c:pt>
                 <c:pt idx="2">
+                  <c:v>14.908</c:v>
+                </c:pt>
+                <c:pt idx="3">
+                  <c:v/>
+                </c:pt>
+                <c:pt idx="4">
                   <c:v>14.9224</c:v>
-                </c:pt>
-                <c:pt idx="3">
-                  <c:v>15.804</c:v>
-                </c:pt>
-                <c:pt idx="4">
-                  <c:v/>
                 </c:pt>
                 <c:pt idx="5">
                   <c:v/>
                 </c:pt>
                 <c:pt idx="6">
-                  <c:v>16.6394</c:v>
+                  <c:v>15.804</c:v>
                 </c:pt>
                 <c:pt idx="7">
-                  <c:v>16.6604</c:v>
+                  <c:v/>
                 </c:pt>
                 <c:pt idx="8">
                   <c:v/>
@@ -4382,7 +6707,7 @@
                   <c:v/>
                 </c:pt>
                 <c:pt idx="14">
-                  <c:v>17.6205</c:v>
+                  <c:v/>
                 </c:pt>
                 <c:pt idx="15">
                   <c:v/>
@@ -4406,7 +6731,7 @@
                   <c:v/>
                 </c:pt>
                 <c:pt idx="22">
-                  <c:v/>
+                  <c:v>16.6394</c:v>
                 </c:pt>
                 <c:pt idx="23">
                   <c:v/>
@@ -4415,13 +6740,13 @@
                   <c:v/>
                 </c:pt>
                 <c:pt idx="25">
-                  <c:v/>
+                  <c:v>16.6604</c:v>
                 </c:pt>
                 <c:pt idx="26">
                   <c:v/>
                 </c:pt>
                 <c:pt idx="27">
-                  <c:v>17.6208</c:v>
+                  <c:v/>
                 </c:pt>
                 <c:pt idx="28">
                   <c:v/>
@@ -4430,7 +6755,7 @@
                   <c:v/>
                 </c:pt>
                 <c:pt idx="30">
-                  <c:v>17.623</c:v>
+                  <c:v/>
                 </c:pt>
                 <c:pt idx="31">
                   <c:v/>
@@ -4439,7 +6764,7 @@
                   <c:v/>
                 </c:pt>
                 <c:pt idx="33">
-                  <c:v>18.6558</c:v>
+                  <c:v/>
                 </c:pt>
                 <c:pt idx="34">
                   <c:v/>
@@ -4454,7 +6779,7 @@
                   <c:v/>
                 </c:pt>
                 <c:pt idx="38">
-                  <c:v>18.7382</c:v>
+                  <c:v/>
                 </c:pt>
                 <c:pt idx="39">
                   <c:v/>
@@ -4487,7 +6812,7 @@
                   <c:v/>
                 </c:pt>
                 <c:pt idx="49">
-                  <c:v/>
+                  <c:v>17.6205</c:v>
                 </c:pt>
                 <c:pt idx="50">
                   <c:v/>
@@ -4499,7 +6824,7 @@
                   <c:v/>
                 </c:pt>
                 <c:pt idx="53">
-                  <c:v>19.8334</c:v>
+                  <c:v/>
                 </c:pt>
                 <c:pt idx="54">
                   <c:v/>
@@ -4511,10 +6836,10 @@
                   <c:v/>
                 </c:pt>
                 <c:pt idx="57">
-                  <c:v>19.8776</c:v>
+                  <c:v/>
                 </c:pt>
                 <c:pt idx="58">
-                  <c:v>19.8929</c:v>
+                  <c:v/>
                 </c:pt>
                 <c:pt idx="59">
                   <c:v/>
@@ -4529,7 +6854,7 @@
                   <c:v/>
                 </c:pt>
                 <c:pt idx="63">
-                  <c:v>21.2999</c:v>
+                  <c:v/>
                 </c:pt>
                 <c:pt idx="64">
                   <c:v/>
@@ -4547,7 +6872,7 @@
                   <c:v/>
                 </c:pt>
                 <c:pt idx="69">
-                  <c:v>21.4846</c:v>
+                  <c:v/>
                 </c:pt>
                 <c:pt idx="70">
                   <c:v/>
@@ -4562,6 +6887,549 @@
                   <c:v/>
                 </c:pt>
                 <c:pt idx="74">
+                  <c:v/>
+                </c:pt>
+                <c:pt idx="75">
+                  <c:v/>
+                </c:pt>
+                <c:pt idx="76">
+                  <c:v/>
+                </c:pt>
+                <c:pt idx="77">
+                  <c:v/>
+                </c:pt>
+                <c:pt idx="78">
+                  <c:v/>
+                </c:pt>
+                <c:pt idx="79">
+                  <c:v/>
+                </c:pt>
+                <c:pt idx="80">
+                  <c:v/>
+                </c:pt>
+                <c:pt idx="81">
+                  <c:v/>
+                </c:pt>
+                <c:pt idx="82">
+                  <c:v/>
+                </c:pt>
+                <c:pt idx="83">
+                  <c:v/>
+                </c:pt>
+                <c:pt idx="84">
+                  <c:v/>
+                </c:pt>
+                <c:pt idx="85">
+                  <c:v>17.6208</c:v>
+                </c:pt>
+                <c:pt idx="86">
+                  <c:v/>
+                </c:pt>
+                <c:pt idx="87">
+                  <c:v/>
+                </c:pt>
+                <c:pt idx="88">
+                  <c:v/>
+                </c:pt>
+                <c:pt idx="89">
+                  <c:v/>
+                </c:pt>
+                <c:pt idx="90">
+                  <c:v/>
+                </c:pt>
+                <c:pt idx="91">
+                  <c:v>17.623</c:v>
+                </c:pt>
+                <c:pt idx="92">
+                  <c:v/>
+                </c:pt>
+                <c:pt idx="93">
+                  <c:v/>
+                </c:pt>
+                <c:pt idx="94">
+                  <c:v/>
+                </c:pt>
+                <c:pt idx="95">
+                  <c:v/>
+                </c:pt>
+                <c:pt idx="96">
+                  <c:v/>
+                </c:pt>
+                <c:pt idx="97">
+                  <c:v/>
+                </c:pt>
+                <c:pt idx="98">
+                  <c:v/>
+                </c:pt>
+                <c:pt idx="99">
+                  <c:v/>
+                </c:pt>
+                <c:pt idx="100">
+                  <c:v/>
+                </c:pt>
+                <c:pt idx="101">
+                  <c:v/>
+                </c:pt>
+                <c:pt idx="102">
+                  <c:v>18.6558</c:v>
+                </c:pt>
+                <c:pt idx="103">
+                  <c:v/>
+                </c:pt>
+                <c:pt idx="104">
+                  <c:v/>
+                </c:pt>
+                <c:pt idx="105">
+                  <c:v/>
+                </c:pt>
+                <c:pt idx="106">
+                  <c:v/>
+                </c:pt>
+                <c:pt idx="107">
+                  <c:v/>
+                </c:pt>
+                <c:pt idx="108">
+                  <c:v/>
+                </c:pt>
+                <c:pt idx="109">
+                  <c:v/>
+                </c:pt>
+                <c:pt idx="110">
+                  <c:v/>
+                </c:pt>
+                <c:pt idx="111">
+                  <c:v/>
+                </c:pt>
+                <c:pt idx="112">
+                  <c:v/>
+                </c:pt>
+                <c:pt idx="113">
+                  <c:v/>
+                </c:pt>
+                <c:pt idx="114">
+                  <c:v>18.7382</c:v>
+                </c:pt>
+                <c:pt idx="115">
+                  <c:v/>
+                </c:pt>
+                <c:pt idx="116">
+                  <c:v/>
+                </c:pt>
+                <c:pt idx="117">
+                  <c:v/>
+                </c:pt>
+                <c:pt idx="118">
+                  <c:v/>
+                </c:pt>
+                <c:pt idx="119">
+                  <c:v/>
+                </c:pt>
+                <c:pt idx="120">
+                  <c:v/>
+                </c:pt>
+                <c:pt idx="121">
+                  <c:v/>
+                </c:pt>
+                <c:pt idx="122">
+                  <c:v/>
+                </c:pt>
+                <c:pt idx="123">
+                  <c:v/>
+                </c:pt>
+                <c:pt idx="124">
+                  <c:v/>
+                </c:pt>
+                <c:pt idx="125">
+                  <c:v/>
+                </c:pt>
+                <c:pt idx="126">
+                  <c:v/>
+                </c:pt>
+                <c:pt idx="127">
+                  <c:v/>
+                </c:pt>
+                <c:pt idx="128">
+                  <c:v/>
+                </c:pt>
+                <c:pt idx="129">
+                  <c:v/>
+                </c:pt>
+                <c:pt idx="130">
+                  <c:v/>
+                </c:pt>
+                <c:pt idx="131">
+                  <c:v/>
+                </c:pt>
+                <c:pt idx="132">
+                  <c:v/>
+                </c:pt>
+                <c:pt idx="133">
+                  <c:v/>
+                </c:pt>
+                <c:pt idx="134">
+                  <c:v/>
+                </c:pt>
+                <c:pt idx="135">
+                  <c:v/>
+                </c:pt>
+                <c:pt idx="136">
+                  <c:v/>
+                </c:pt>
+                <c:pt idx="137">
+                  <c:v/>
+                </c:pt>
+                <c:pt idx="138">
+                  <c:v/>
+                </c:pt>
+                <c:pt idx="139">
+                  <c:v/>
+                </c:pt>
+                <c:pt idx="140">
+                  <c:v/>
+                </c:pt>
+                <c:pt idx="141">
+                  <c:v/>
+                </c:pt>
+                <c:pt idx="142">
+                  <c:v/>
+                </c:pt>
+                <c:pt idx="143">
+                  <c:v/>
+                </c:pt>
+                <c:pt idx="144">
+                  <c:v/>
+                </c:pt>
+                <c:pt idx="145">
+                  <c:v/>
+                </c:pt>
+                <c:pt idx="146">
+                  <c:v/>
+                </c:pt>
+                <c:pt idx="147">
+                  <c:v/>
+                </c:pt>
+                <c:pt idx="148">
+                  <c:v/>
+                </c:pt>
+                <c:pt idx="149">
+                  <c:v/>
+                </c:pt>
+                <c:pt idx="150">
+                  <c:v/>
+                </c:pt>
+                <c:pt idx="151">
+                  <c:v/>
+                </c:pt>
+                <c:pt idx="152">
+                  <c:v/>
+                </c:pt>
+                <c:pt idx="153">
+                  <c:v/>
+                </c:pt>
+                <c:pt idx="154">
+                  <c:v/>
+                </c:pt>
+                <c:pt idx="155">
+                  <c:v>18.813</c:v>
+                </c:pt>
+                <c:pt idx="156">
+                  <c:v/>
+                </c:pt>
+                <c:pt idx="157">
+                  <c:v/>
+                </c:pt>
+                <c:pt idx="158">
+                  <c:v/>
+                </c:pt>
+                <c:pt idx="159">
+                  <c:v/>
+                </c:pt>
+                <c:pt idx="160">
+                  <c:v/>
+                </c:pt>
+                <c:pt idx="161">
+                  <c:v/>
+                </c:pt>
+                <c:pt idx="162">
+                  <c:v/>
+                </c:pt>
+                <c:pt idx="163">
+                  <c:v/>
+                </c:pt>
+                <c:pt idx="164">
+                  <c:v/>
+                </c:pt>
+                <c:pt idx="165">
+                  <c:v/>
+                </c:pt>
+                <c:pt idx="166">
+                  <c:v/>
+                </c:pt>
+                <c:pt idx="167">
+                  <c:v>19.8334</c:v>
+                </c:pt>
+                <c:pt idx="168">
+                  <c:v/>
+                </c:pt>
+                <c:pt idx="169">
+                  <c:v/>
+                </c:pt>
+                <c:pt idx="170">
+                  <c:v/>
+                </c:pt>
+                <c:pt idx="171">
+                  <c:v/>
+                </c:pt>
+                <c:pt idx="172">
+                  <c:v/>
+                </c:pt>
+                <c:pt idx="173">
+                  <c:v/>
+                </c:pt>
+                <c:pt idx="174">
+                  <c:v/>
+                </c:pt>
+                <c:pt idx="175">
+                  <c:v/>
+                </c:pt>
+                <c:pt idx="176">
+                  <c:v/>
+                </c:pt>
+                <c:pt idx="177">
+                  <c:v/>
+                </c:pt>
+                <c:pt idx="178">
+                  <c:v/>
+                </c:pt>
+                <c:pt idx="179">
+                  <c:v/>
+                </c:pt>
+                <c:pt idx="180">
+                  <c:v/>
+                </c:pt>
+                <c:pt idx="181">
+                  <c:v/>
+                </c:pt>
+                <c:pt idx="182">
+                  <c:v/>
+                </c:pt>
+                <c:pt idx="183">
+                  <c:v/>
+                </c:pt>
+                <c:pt idx="184">
+                  <c:v/>
+                </c:pt>
+                <c:pt idx="185">
+                  <c:v/>
+                </c:pt>
+                <c:pt idx="186">
+                  <c:v/>
+                </c:pt>
+                <c:pt idx="187">
+                  <c:v/>
+                </c:pt>
+                <c:pt idx="188">
+                  <c:v/>
+                </c:pt>
+                <c:pt idx="189">
+                  <c:v/>
+                </c:pt>
+                <c:pt idx="190">
+                  <c:v/>
+                </c:pt>
+                <c:pt idx="191">
+                  <c:v/>
+                </c:pt>
+                <c:pt idx="192">
+                  <c:v/>
+                </c:pt>
+                <c:pt idx="193">
+                  <c:v>19.8776</c:v>
+                </c:pt>
+                <c:pt idx="194">
+                  <c:v/>
+                </c:pt>
+                <c:pt idx="195">
+                  <c:v/>
+                </c:pt>
+                <c:pt idx="196">
+                  <c:v/>
+                </c:pt>
+                <c:pt idx="197">
+                  <c:v/>
+                </c:pt>
+                <c:pt idx="198">
+                  <c:v/>
+                </c:pt>
+                <c:pt idx="199">
+                  <c:v/>
+                </c:pt>
+                <c:pt idx="200">
+                  <c:v/>
+                </c:pt>
+                <c:pt idx="201">
+                  <c:v/>
+                </c:pt>
+                <c:pt idx="202">
+                  <c:v/>
+                </c:pt>
+                <c:pt idx="203">
+                  <c:v/>
+                </c:pt>
+                <c:pt idx="204">
+                  <c:v/>
+                </c:pt>
+                <c:pt idx="205">
+                  <c:v>19.8929</c:v>
+                </c:pt>
+                <c:pt idx="206">
+                  <c:v/>
+                </c:pt>
+                <c:pt idx="207">
+                  <c:v/>
+                </c:pt>
+                <c:pt idx="208">
+                  <c:v/>
+                </c:pt>
+                <c:pt idx="209">
+                  <c:v/>
+                </c:pt>
+                <c:pt idx="210">
+                  <c:v/>
+                </c:pt>
+                <c:pt idx="211">
+                  <c:v/>
+                </c:pt>
+                <c:pt idx="212">
+                  <c:v/>
+                </c:pt>
+                <c:pt idx="213">
+                  <c:v/>
+                </c:pt>
+                <c:pt idx="214">
+                  <c:v/>
+                </c:pt>
+                <c:pt idx="215">
+                  <c:v/>
+                </c:pt>
+                <c:pt idx="216">
+                  <c:v/>
+                </c:pt>
+                <c:pt idx="217">
+                  <c:v/>
+                </c:pt>
+                <c:pt idx="218">
+                  <c:v/>
+                </c:pt>
+                <c:pt idx="219">
+                  <c:v/>
+                </c:pt>
+                <c:pt idx="220">
+                  <c:v>20.0301</c:v>
+                </c:pt>
+                <c:pt idx="221">
+                  <c:v/>
+                </c:pt>
+                <c:pt idx="222">
+                  <c:v/>
+                </c:pt>
+                <c:pt idx="223">
+                  <c:v/>
+                </c:pt>
+                <c:pt idx="224">
+                  <c:v/>
+                </c:pt>
+                <c:pt idx="225">
+                  <c:v/>
+                </c:pt>
+                <c:pt idx="226">
+                  <c:v/>
+                </c:pt>
+                <c:pt idx="227">
+                  <c:v/>
+                </c:pt>
+                <c:pt idx="228">
+                  <c:v/>
+                </c:pt>
+                <c:pt idx="229">
+                  <c:v/>
+                </c:pt>
+                <c:pt idx="230">
+                  <c:v>21.2999</c:v>
+                </c:pt>
+                <c:pt idx="231">
+                  <c:v/>
+                </c:pt>
+                <c:pt idx="232">
+                  <c:v/>
+                </c:pt>
+                <c:pt idx="233">
+                  <c:v/>
+                </c:pt>
+                <c:pt idx="234">
+                  <c:v/>
+                </c:pt>
+                <c:pt idx="235">
+                  <c:v/>
+                </c:pt>
+                <c:pt idx="236">
+                  <c:v/>
+                </c:pt>
+                <c:pt idx="237">
+                  <c:v/>
+                </c:pt>
+                <c:pt idx="238">
+                  <c:v/>
+                </c:pt>
+                <c:pt idx="239">
+                  <c:v/>
+                </c:pt>
+                <c:pt idx="240">
+                  <c:v/>
+                </c:pt>
+                <c:pt idx="241">
+                  <c:v/>
+                </c:pt>
+                <c:pt idx="242">
+                  <c:v>21.4846</c:v>
+                </c:pt>
+                <c:pt idx="243">
+                  <c:v/>
+                </c:pt>
+                <c:pt idx="244">
+                  <c:v/>
+                </c:pt>
+                <c:pt idx="245">
+                  <c:v/>
+                </c:pt>
+                <c:pt idx="246">
+                  <c:v/>
+                </c:pt>
+                <c:pt idx="247">
+                  <c:v/>
+                </c:pt>
+                <c:pt idx="248">
+                  <c:v/>
+                </c:pt>
+                <c:pt idx="249">
+                  <c:v/>
+                </c:pt>
+                <c:pt idx="250">
+                  <c:v/>
+                </c:pt>
+                <c:pt idx="251">
+                  <c:v/>
+                </c:pt>
+                <c:pt idx="252">
+                  <c:v/>
+                </c:pt>
+                <c:pt idx="253">
+                  <c:v/>
+                </c:pt>
+                <c:pt idx="254">
+                  <c:v/>
+                </c:pt>
+                <c:pt idx="255">
                   <c:v>23.0922</c:v>
                 </c:pt>
               </c:numCache>
@@ -5184,7 +8052,7 @@
           <a:p>
             <a:r>
               <a:rPr lang="en-US" dirty="0"/>
-              <a:t>Overview of the Arm port of the evolutionary quantization project: what was built, what was measured, what was learned. Tiers T0-T3 are done (the Graviton3 run cost about two dollars); the Apple M4 block (T4) is the one remaining paid step.</a:t>
+              <a:t>Overview of the Arm port of the evolutionary quantization project: what was built, what was measured, what was learned. All tiers are done: the Graviton3 run cost about two dollars, and the Apple M4 block (T4) about thirty.</a:t>
             </a:r>
             <a:endParaRPr lang="en-US" dirty="0"/>
           </a:p>
@@ -5888,7 +8756,7 @@
           <a:p>
             <a:r>
               <a:rPr lang="en-US" dirty="0"/>
-              <a:t>Partial table from a run still in progress: the 8B model's genomes are measured in a random priority order after the reference, the uniform baselines and the sensitivity-greedy chain, so any prefix is a random sample. Accuracy is KL divergence against the Q8_0 reference of the same model, converted to exp(KLD)-1. Speed is llama-bench decode with 8 threads. This slide is generated from the synced table at build time and has to be rebuilt, and probably retitled, when the run finishes. The GA-versus-greedy comparison needs at least 90% coverage.</a:t>
+              <a:t>All 256 genomes of the 8B model were measured on the M4 in the KleidiAI configuration (138 s each, 10.2 hours), plus 12 genomes in the stock configuration. Accuracy is KL divergence against the Q8_0 reference converted to exp(KLD)-1; speed is llama-bench decode with 8 threads; energy comes from powermetrics CPU power. The genetic search with 400 evaluations over ten seeds reaches 0.9999 of the exact front's hypervolume, and so does the nine-genome sensitivity-greedy chain. An additive per-block fit explains seconds per token with R2 0.997, joules per token 0.995, KL divergence 0.993, so the search problem is nearly separable on this hardware.</a:t>
             </a:r>
             <a:endParaRPr lang="en-US" dirty="0"/>
           </a:p>
@@ -5976,7 +8844,7 @@
           <a:p>
             <a:r>
               <a:rPr lang="en-US" dirty="0"/>
-              <a:t>Closing slide: four lessons and the concrete next steps. The limits are stated explicitly so the results are not over-read. Tiers T0-T3 are complete; the M4 block is running, with the selftest and thread scan done and the measurement tables still being filled.</a:t>
+              <a:t>Phi-3-mini, every genome of the Q8_0/Q4_0 space measured in both the KleidiAI and the stock builds on the M4 (about 45 seconds per genome and configuration). The curves are the per-genome ratio KleidiAI over stock, grouped by how many of the eight blocks are Q4_0. KleidiAI only changes the Q8_0 path: at zero Q4_0 blocks it gives +78% prefill and +8% decode but 31x the KL divergence and 19% more energy per token; with all blocks Q4_0 the two builds agree on accuracy and KleidiAI is slightly slower. Hypervolume is measured against the stock reference genome, so the stock front's 6% advantage is the cost of shipping the KleidiAI path.</a:t>
             </a:r>
             <a:endParaRPr lang="en-US" dirty="0"/>
           </a:p>
@@ -6000,6 +8868,94 @@
             <a:fld id="{F7021451-1387-4CA6-816F-3879F97B5CBC}" type="slidenum">
               <a:rPr lang="en-US"/>
               <a:t>18</a:t>
+            </a:fld>
+            <a:endParaRPr lang="en-US"/>
+          </a:p>
+        </p:txBody>
+      </p:sp>
+    </p:spTree>
+    <p:extLst>
+      <p:ext uri="{BB962C8B-B14F-4D97-AF65-F5344CB8AC3E}">
+        <p14:creationId xmlns:p14="http://schemas.microsoft.com/office/powerpoint/2010/main" val="1024086991"/>
+      </p:ext>
+    </p:extLst>
+  </p:cSld>
+  <p:clrMapOvr>
+    <a:masterClrMapping/>
+  </p:clrMapOvr>
+</p:notes>
+</file>
+
+<file path=ppt/notesSlides/notesSlide19.xml><?xml version="1.0" encoding="utf-8"?>
+<p:notes xmlns:a="http://schemas.openxmlformats.org/drawingml/2006/main" xmlns:r="http://schemas.openxmlformats.org/officeDocument/2006/relationships" xmlns:p="http://schemas.openxmlformats.org/presentationml/2006/main">
+  <p:cSld>
+    <p:spTree>
+      <p:nvGrpSpPr>
+        <p:cNvPr id="1" name=""/>
+        <p:cNvGrpSpPr/>
+        <p:nvPr/>
+      </p:nvGrpSpPr>
+      <p:grpSpPr>
+        <a:xfrm>
+          <a:off x="0" y="0"/>
+          <a:ext cx="0" cy="0"/>
+          <a:chOff x="0" y="0"/>
+          <a:chExt cx="0" cy="0"/>
+        </a:xfrm>
+      </p:grpSpPr>
+      <p:sp>
+        <p:nvSpPr>
+          <p:cNvPr id="2" name="Slide Image Placeholder 1"/>
+          <p:cNvSpPr>
+            <a:spLocks noGrp="1" noRot="1" noChangeAspect="1"/>
+          </p:cNvSpPr>
+          <p:nvPr>
+            <p:ph type="sldImg"/>
+          </p:nvPr>
+        </p:nvSpPr>
+        <p:spPr/>
+      </p:sp>
+      <p:sp>
+        <p:nvSpPr>
+          <p:cNvPr id="3" name="Notes Placeholder 2"/>
+          <p:cNvSpPr>
+            <a:spLocks noGrp="1"/>
+          </p:cNvSpPr>
+          <p:nvPr>
+            <p:ph type="body" idx="1"/>
+          </p:nvPr>
+        </p:nvSpPr>
+        <p:spPr/>
+        <p:txBody>
+          <a:bodyPr/>
+          <a:lstStyle/>
+          <a:p>
+            <a:r>
+              <a:rPr lang="en-US" dirty="0"/>
+              <a:t>Closing slide: four lessons and the concrete next steps. The limits are stated explicitly so the results are not over-read. All tiers T0-T4 are complete: the M4 block measured both models over the full space.</a:t>
+            </a:r>
+            <a:endParaRPr lang="en-US" dirty="0"/>
+          </a:p>
+        </p:txBody>
+      </p:sp>
+      <p:sp>
+        <p:nvSpPr>
+          <p:cNvPr id="4" name="Slide Number Placeholder 3"/>
+          <p:cNvSpPr>
+            <a:spLocks noGrp="1"/>
+          </p:cNvSpPr>
+          <p:nvPr>
+            <p:ph type="sldNum" sz="quarter" idx="10"/>
+          </p:nvPr>
+        </p:nvSpPr>
+        <p:spPr/>
+        <p:txBody>
+          <a:bodyPr/>
+          <a:lstStyle/>
+          <a:p>
+            <a:fld id="{F7021451-1387-4CA6-816F-3879F97B5CBC}" type="slidenum">
+              <a:rPr lang="en-US"/>
+              <a:t>19</a:t>
             </a:fld>
             <a:endParaRPr lang="en-US"/>
           </a:p>
@@ -6328,7 +9284,7 @@
           <a:p>
             <a:r>
               <a:rPr lang="en-US" dirty="0"/>
-              <a:t>Green badges are complete (T0-T3). The Graviton3 run found the KleidiAI Q8_0 accuracy loss at full scale. The Mac costs about $30 (1.23 USD/h) with a 24-hour minimum, so every check that does not need M4 hardware was moved to the desktop, the 3080 or emulation.</a:t>
+              <a:t>Green badges are complete (T0-T4). The Graviton3 run found the KleidiAI Q8_0 accuracy loss at full scale. The Mac costs about $30 (1.23 USD/h) with a 24-hour minimum, so every check that does not need M4 hardware was moved to the desktop, the 3080 or emulation.</a:t>
             </a:r>
             <a:endParaRPr lang="en-US" dirty="0"/>
           </a:p>
@@ -7611,7 +10567,7 @@
                 <a:ea typeface="Calibri" pitchFamily="34" charset="-122"/>
                 <a:cs typeface="Calibri" pitchFamily="34" charset="-120"/>
               </a:rPr>
-              <a:t>Branch mac-m4  |  tiers T0-T3 complete (desktop, RTX 3080, aarch64 emulation, AWS Graviton3)  |  Apple M4 run in progress (selftest passed)</a:t>
+              <a:t>Branch mac-m4  |  all tiers complete: desktop, RTX 3080, aarch64 emulation, AWS Graviton3, Apple M4</a:t>
             </a:r>
             <a:endParaRPr lang="en-US" sz="1400" dirty="0"/>
           </a:p>
@@ -14109,7 +17065,7 @@
                 <a:ea typeface="+mj-lt" pitchFamily="34" charset="-122"/>
                 <a:cs typeface="+mj-lt" pitchFamily="34" charset="-120"/>
               </a:rPr>
-              <a:t>Llama-3.1-8B on the M4, measured so far (75 of 256 genomes)</a:t>
+              <a:t>Llama-3.1-8B on the M4: all 256 genomes measured</a:t>
             </a:r>
             <a:endParaRPr lang="en-US" sz="2800" dirty="0"/>
           </a:p>
@@ -14133,14 +17089,14 @@
       </p:graphicFrame>
       <p:sp>
         <p:nvSpPr>
-          <p:cNvPr id="4" name="stat range value"/>
+          <p:cNvPr id="4" name="stat front value"/>
           <p:cNvSpPr txBox="1"/>
           <p:nvPr/>
         </p:nvSpPr>
         <p:spPr>
           <a:xfrm>
             <a:off x="7863840" y="1371600"/>
-            <a:ext cx="3749040" cy="685800"/>
+            <a:ext cx="1828800" cy="685800"/>
           </a:xfrm>
           <a:prstGeom prst="rect">
             <a:avLst/>
@@ -14164,7 +17120,7 @@
                 <a:ea typeface="Cambria" pitchFamily="34" charset="-122"/>
                 <a:cs typeface="Cambria" pitchFamily="34" charset="-120"/>
               </a:rPr>
-              <a:t>14.3 to 23.1</a:t>
+              <a:t>27</a:t>
             </a:r>
             <a:endParaRPr lang="en-US" sz="4000" dirty="0"/>
           </a:p>
@@ -14172,14 +17128,14 @@
       </p:sp>
       <p:sp>
         <p:nvSpPr>
-          <p:cNvPr id="5" name="stat range label"/>
+          <p:cNvPr id="5" name="stat front label"/>
           <p:cNvSpPr txBox="1"/>
           <p:nvPr/>
         </p:nvSpPr>
         <p:spPr>
           <a:xfrm>
             <a:off x="7863840" y="2084832"/>
-            <a:ext cx="3749040" cy="640080"/>
+            <a:ext cx="1828800" cy="640080"/>
           </a:xfrm>
           <a:prstGeom prst="rect">
             <a:avLst/>
@@ -14203,7 +17159,7 @@
                 <a:ea typeface="Calibri" pitchFamily="34" charset="-122"/>
                 <a:cs typeface="Calibri" pitchFamily="34" charset="-120"/>
               </a:rPr>
-              <a:t>measured decode tokens/s across the genomes (the slowest is near uniform Q8_0; +62% to the fastest)</a:t>
+              <a:t>Pareto front points (accuracy, speed, energy)</a:t>
             </a:r>
             <a:endParaRPr lang="en-US" sz="1400" dirty="0"/>
           </a:p>
@@ -14211,7 +17167,85 @@
       </p:sp>
       <p:sp>
         <p:nvSpPr>
-          <p:cNvPr id="6" name="interim card"/>
+          <p:cNvPr id="6" name="stat hv value"/>
+          <p:cNvSpPr txBox="1"/>
+          <p:nvPr/>
+        </p:nvSpPr>
+        <p:spPr>
+          <a:xfrm>
+            <a:off x="9692640" y="1371600"/>
+            <a:ext cx="1920240" cy="685800"/>
+          </a:xfrm>
+          <a:prstGeom prst="rect">
+            <a:avLst/>
+          </a:prstGeom>
+          <a:noFill/>
+          <a:ln/>
+        </p:spPr>
+        <p:txBody>
+          <a:bodyPr wrap="square" lIns="0" tIns="0" rIns="0" bIns="0" rtlCol="0" anchor="b"/>
+          <a:lstStyle/>
+          <a:p>
+            <a:pPr indent="0" marL="0">
+              <a:buNone/>
+            </a:pPr>
+            <a:r>
+              <a:rPr lang="en-US" sz="4000" b="1" dirty="0">
+                <a:solidFill>
+                  <a:srgbClr val="2E9E8A"/>
+                </a:solidFill>
+                <a:latin typeface="Cambria" pitchFamily="34" charset="0"/>
+                <a:ea typeface="Cambria" pitchFamily="34" charset="-122"/>
+                <a:cs typeface="Cambria" pitchFamily="34" charset="-120"/>
+              </a:rPr>
+              <a:t>0.9999</a:t>
+            </a:r>
+            <a:endParaRPr lang="en-US" sz="4000" dirty="0"/>
+          </a:p>
+        </p:txBody>
+      </p:sp>
+      <p:sp>
+        <p:nvSpPr>
+          <p:cNvPr id="7" name="stat hv label"/>
+          <p:cNvSpPr txBox="1"/>
+          <p:nvPr/>
+        </p:nvSpPr>
+        <p:spPr>
+          <a:xfrm>
+            <a:off x="9692640" y="2084832"/>
+            <a:ext cx="1920240" cy="640080"/>
+          </a:xfrm>
+          <a:prstGeom prst="rect">
+            <a:avLst/>
+          </a:prstGeom>
+          <a:noFill/>
+          <a:ln/>
+        </p:spPr>
+        <p:txBody>
+          <a:bodyPr wrap="square" lIns="0" tIns="0" rIns="0" bIns="0" rtlCol="0" anchor="t"/>
+          <a:lstStyle/>
+          <a:p>
+            <a:pPr indent="0" marL="0">
+              <a:buNone/>
+            </a:pPr>
+            <a:r>
+              <a:rPr lang="en-US" sz="1400" dirty="0">
+                <a:solidFill>
+                  <a:schemeClr val="tx1"/>
+                </a:solidFill>
+                <a:latin typeface="Calibri" pitchFamily="34" charset="0"/>
+                <a:ea typeface="Calibri" pitchFamily="34" charset="-122"/>
+                <a:cs typeface="Calibri" pitchFamily="34" charset="-120"/>
+              </a:rPr>
+              <a:t>hypervolume ratio: GA (400 evals) and the greedy rule</a:t>
+            </a:r>
+            <a:endParaRPr lang="en-US" sz="1400" dirty="0"/>
+          </a:p>
+        </p:txBody>
+      </p:sp>
+      <p:sp>
+        <p:nvSpPr>
+          <p:cNvPr id="8" name="result card"/>
           <p:cNvSpPr/>
           <p:nvPr/>
         </p:nvSpPr>
@@ -14226,11 +17260,11 @@
             </a:avLst>
           </a:prstGeom>
           <a:solidFill>
-            <a:schemeClr val="tx2"/>
+            <a:schemeClr val="bg2"/>
           </a:solidFill>
           <a:ln w="12700">
             <a:solidFill>
-              <a:schemeClr val="tx2"/>
+              <a:schemeClr val="bg2"/>
             </a:solidFill>
             <a:prstDash val="solid"/>
           </a:ln>
@@ -14238,7 +17272,7 @@
       </p:sp>
       <p:sp>
         <p:nvSpPr>
-          <p:cNvPr id="7" name="interim head"/>
+          <p:cNvPr id="9" name="result head"/>
           <p:cNvSpPr txBox="1"/>
           <p:nvPr/>
         </p:nvSpPr>
@@ -14263,13 +17297,13 @@
             <a:r>
               <a:rPr lang="en-US" sz="1600" b="1" dirty="0">
                 <a:solidFill>
-                  <a:schemeClr val="accent2"/>
+                  <a:schemeClr val="tx2"/>
                 </a:solidFill>
                 <a:latin typeface="Calibri" pitchFamily="34" charset="0"/>
                 <a:ea typeface="Calibri" pitchFamily="34" charset="-122"/>
                 <a:cs typeface="Calibri" pitchFamily="34" charset="-120"/>
               </a:rPr>
-              <a:t>INTERIM: not the final result</a:t>
+              <a:t>What the measurements say</a:t>
             </a:r>
             <a:endParaRPr lang="en-US" sz="1600" dirty="0"/>
           </a:p>
@@ -14277,7 +17311,7 @@
       </p:sp>
       <p:sp>
         <p:nvSpPr>
-          <p:cNvPr id="8" name="interim bullets"/>
+          <p:cNvPr id="10" name="result bullets"/>
           <p:cNvSpPr txBox="1"/>
           <p:nvPr/>
         </p:nvSpPr>
@@ -14306,13 +17340,13 @@
             <a:r>
               <a:rPr lang="en-US" sz="1250" dirty="0">
                 <a:solidFill>
-                  <a:schemeClr val="bg1"/>
+                  <a:schemeClr val="tx1"/>
                 </a:solidFill>
                 <a:latin typeface="Calibri" pitchFamily="34" charset="0"/>
                 <a:ea typeface="Calibri" pitchFamily="34" charset="-122"/>
                 <a:cs typeface="Calibri" pitchFamily="34" charset="-120"/>
               </a:rPr>
-              <a:t>17 front points among 75 genomes: a random sample of the space, so not yet the true front</a:t>
+              <a:t>Speed, energy and accuracy are almost additive over the 8 blocks (R2 0.993-0.997): a sensitivity ordering already gives the front</a:t>
             </a:r>
             <a:endParaRPr lang="en-US" sz="1250" dirty="0"/>
           </a:p>
@@ -14327,13 +17361,13 @@
             <a:r>
               <a:rPr lang="en-US" sz="1250" dirty="0">
                 <a:solidFill>
-                  <a:schemeClr val="bg1"/>
+                  <a:schemeClr val="tx1"/>
                 </a:solidFill>
                 <a:latin typeface="Calibri" pitchFamily="34" charset="0"/>
                 <a:ea typeface="Calibri" pitchFamily="34" charset="-122"/>
                 <a:cs typeface="Calibri" pitchFamily="34" charset="-120"/>
               </a:rPr>
-              <a:t>Final numbers, with energy and the genetic-search comparison, come from rebuilding this deck after the run</a:t>
+              <a:t>Energy per token tracks decode time (correlation 0.9975): three objectives act as about two</a:t>
             </a:r>
             <a:endParaRPr lang="en-US" sz="1250" dirty="0"/>
           </a:p>
@@ -14348,13 +17382,13 @@
             <a:r>
               <a:rPr lang="en-US" sz="1250" dirty="0">
                 <a:solidFill>
-                  <a:schemeClr val="bg1"/>
+                  <a:schemeClr val="tx1"/>
                 </a:solidFill>
                 <a:latin typeface="Calibri" pitchFamily="34" charset="0"/>
                 <a:ea typeface="Calibri" pitchFamily="34" charset="-122"/>
                 <a:cs typeface="Calibri" pitchFamily="34" charset="-120"/>
               </a:rPr>
-              <a:t>Genomes are measured once and analysed offline, so the search itself costs no hardware time</a:t>
+              <a:t>Decode ranges from 14.3 to 23.1 tokens/s (+62%); uniform Q4_0 is the fastest genome</a:t>
             </a:r>
             <a:endParaRPr lang="en-US" sz="1250" dirty="0"/>
           </a:p>
@@ -14462,6 +17496,443 @@
             <a:r>
               <a:rPr lang="en-US" sz="2800" b="1" dirty="0">
                 <a:solidFill>
+                  <a:schemeClr val="tx2"/>
+                </a:solidFill>
+                <a:latin typeface="+mj-lt" pitchFamily="34" charset="0"/>
+                <a:ea typeface="+mj-lt" pitchFamily="34" charset="-122"/>
+                <a:cs typeface="+mj-lt" pitchFamily="34" charset="-120"/>
+              </a:rPr>
+              <a:t>Phi-3 on the M4: KleidiAI costs accuracy and energy only on the Q8_0 blocks</a:t>
+            </a:r>
+            <a:endParaRPr lang="en-US" sz="2800" dirty="0"/>
+          </a:p>
+        </p:txBody>
+      </p:sp>
+      <p:graphicFrame>
+        <p:nvGraphicFramePr>
+          <p:cNvPr id="3" name="Chart 0" descr=""/>
+          <p:cNvGraphicFramePr/>
+          <p:nvPr/>
+        </p:nvGraphicFramePr>
+        <p:xfrm>
+          <a:off x="548640" y="1371600"/>
+          <a:ext cx="6583680" cy="4663440"/>
+        </p:xfrm>
+        <a:graphic xmlns:a="http://schemas.openxmlformats.org/drawingml/2006/main">
+          <a:graphicData uri="http://schemas.openxmlformats.org/drawingml/2006/chart">
+            <c:chart xmlns:c="http://schemas.openxmlformats.org/drawingml/2006/chart" r:id="rId1"/>
+          </a:graphicData>
+        </a:graphic>
+      </p:graphicFrame>
+      <p:sp>
+        <p:nvSpPr>
+          <p:cNvPr id="4" name="stat kld value"/>
+          <p:cNvSpPr txBox="1"/>
+          <p:nvPr/>
+        </p:nvSpPr>
+        <p:spPr>
+          <a:xfrm>
+            <a:off x="7498080" y="1371600"/>
+            <a:ext cx="2011680" cy="685800"/>
+          </a:xfrm>
+          <a:prstGeom prst="rect">
+            <a:avLst/>
+          </a:prstGeom>
+          <a:noFill/>
+          <a:ln/>
+        </p:spPr>
+        <p:txBody>
+          <a:bodyPr wrap="square" lIns="0" tIns="0" rIns="0" bIns="0" rtlCol="0" anchor="b"/>
+          <a:lstStyle/>
+          <a:p>
+            <a:pPr indent="0" marL="0">
+              <a:buNone/>
+            </a:pPr>
+            <a:r>
+              <a:rPr lang="en-US" sz="4000" b="1" dirty="0">
+                <a:solidFill>
+                  <a:srgbClr val="D1495B"/>
+                </a:solidFill>
+                <a:latin typeface="Cambria" pitchFamily="34" charset="0"/>
+                <a:ea typeface="Cambria" pitchFamily="34" charset="-122"/>
+                <a:cs typeface="Cambria" pitchFamily="34" charset="-120"/>
+              </a:rPr>
+              <a:t>x31</a:t>
+            </a:r>
+            <a:endParaRPr lang="en-US" sz="4000" dirty="0"/>
+          </a:p>
+        </p:txBody>
+      </p:sp>
+      <p:sp>
+        <p:nvSpPr>
+          <p:cNvPr id="5" name="stat kld label"/>
+          <p:cNvSpPr txBox="1"/>
+          <p:nvPr/>
+        </p:nvSpPr>
+        <p:spPr>
+          <a:xfrm>
+            <a:off x="7498080" y="2084832"/>
+            <a:ext cx="2011680" cy="640080"/>
+          </a:xfrm>
+          <a:prstGeom prst="rect">
+            <a:avLst/>
+          </a:prstGeom>
+          <a:noFill/>
+          <a:ln/>
+        </p:spPr>
+        <p:txBody>
+          <a:bodyPr wrap="square" lIns="0" tIns="0" rIns="0" bIns="0" rtlCol="0" anchor="t"/>
+          <a:lstStyle/>
+          <a:p>
+            <a:pPr indent="0" marL="0">
+              <a:buNone/>
+            </a:pPr>
+            <a:r>
+              <a:rPr lang="en-US" sz="1400" dirty="0">
+                <a:solidFill>
+                  <a:schemeClr val="tx1"/>
+                </a:solidFill>
+                <a:latin typeface="Calibri" pitchFamily="34" charset="0"/>
+                <a:ea typeface="Calibri" pitchFamily="34" charset="-122"/>
+                <a:cs typeface="Calibri" pitchFamily="34" charset="-120"/>
+              </a:rPr>
+              <a:t>KL divergence of all-Q8_0 under KleidiAI vs stock; x1.0 for all-Q4_0</a:t>
+            </a:r>
+            <a:endParaRPr lang="en-US" sz="1400" dirty="0"/>
+          </a:p>
+        </p:txBody>
+      </p:sp>
+      <p:sp>
+        <p:nvSpPr>
+          <p:cNvPr id="6" name="stat hv6 value"/>
+          <p:cNvSpPr txBox="1"/>
+          <p:nvPr/>
+        </p:nvSpPr>
+        <p:spPr>
+          <a:xfrm>
+            <a:off x="9601200" y="1371600"/>
+            <a:ext cx="2011680" cy="685800"/>
+          </a:xfrm>
+          <a:prstGeom prst="rect">
+            <a:avLst/>
+          </a:prstGeom>
+          <a:noFill/>
+          <a:ln/>
+        </p:spPr>
+        <p:txBody>
+          <a:bodyPr wrap="square" lIns="0" tIns="0" rIns="0" bIns="0" rtlCol="0" anchor="b"/>
+          <a:lstStyle/>
+          <a:p>
+            <a:pPr indent="0" marL="0">
+              <a:buNone/>
+            </a:pPr>
+            <a:r>
+              <a:rPr lang="en-US" sz="4000" b="1" dirty="0">
+                <a:solidFill>
+                  <a:srgbClr val="0A7EA4"/>
+                </a:solidFill>
+                <a:latin typeface="Cambria" pitchFamily="34" charset="0"/>
+                <a:ea typeface="Cambria" pitchFamily="34" charset="-122"/>
+                <a:cs typeface="Cambria" pitchFamily="34" charset="-120"/>
+              </a:rPr>
+              <a:t>6%</a:t>
+            </a:r>
+            <a:endParaRPr lang="en-US" sz="4000" dirty="0"/>
+          </a:p>
+        </p:txBody>
+      </p:sp>
+      <p:sp>
+        <p:nvSpPr>
+          <p:cNvPr id="7" name="stat hv6 label"/>
+          <p:cNvSpPr txBox="1"/>
+          <p:nvPr/>
+        </p:nvSpPr>
+        <p:spPr>
+          <a:xfrm>
+            <a:off x="9601200" y="2084832"/>
+            <a:ext cx="2011680" cy="640080"/>
+          </a:xfrm>
+          <a:prstGeom prst="rect">
+            <a:avLst/>
+          </a:prstGeom>
+          <a:noFill/>
+          <a:ln/>
+        </p:spPr>
+        <p:txBody>
+          <a:bodyPr wrap="square" lIns="0" tIns="0" rIns="0" bIns="0" rtlCol="0" anchor="t"/>
+          <a:lstStyle/>
+          <a:p>
+            <a:pPr indent="0" marL="0">
+              <a:buNone/>
+            </a:pPr>
+            <a:r>
+              <a:rPr lang="en-US" sz="1400" dirty="0">
+                <a:solidFill>
+                  <a:schemeClr val="tx1"/>
+                </a:solidFill>
+                <a:latin typeface="Calibri" pitchFamily="34" charset="0"/>
+                <a:ea typeface="Calibri" pitchFamily="34" charset="-122"/>
+                <a:cs typeface="Calibri" pitchFamily="34" charset="-120"/>
+              </a:rPr>
+              <a:t>more hypervolume on the stock front than on the KleidiAI front</a:t>
+            </a:r>
+            <a:endParaRPr lang="en-US" sz="1400" dirty="0"/>
+          </a:p>
+        </p:txBody>
+      </p:sp>
+      <p:sp>
+        <p:nvSpPr>
+          <p:cNvPr id="8" name="phi card"/>
+          <p:cNvSpPr/>
+          <p:nvPr/>
+        </p:nvSpPr>
+        <p:spPr>
+          <a:xfrm>
+            <a:off x="7498080" y="3063240"/>
+            <a:ext cx="4114800" cy="2971800"/>
+          </a:xfrm>
+          <a:prstGeom prst="roundRect">
+            <a:avLst>
+              <a:gd name="adj" fmla="val 2462"/>
+            </a:avLst>
+          </a:prstGeom>
+          <a:solidFill>
+            <a:schemeClr val="bg2"/>
+          </a:solidFill>
+          <a:ln w="12700">
+            <a:solidFill>
+              <a:schemeClr val="bg2"/>
+            </a:solidFill>
+            <a:prstDash val="solid"/>
+          </a:ln>
+        </p:spPr>
+      </p:sp>
+      <p:sp>
+        <p:nvSpPr>
+          <p:cNvPr id="9" name="phi head"/>
+          <p:cNvSpPr txBox="1"/>
+          <p:nvPr/>
+        </p:nvSpPr>
+        <p:spPr>
+          <a:xfrm>
+            <a:off x="7680960" y="3154680"/>
+            <a:ext cx="3749040" cy="365760"/>
+          </a:xfrm>
+          <a:prstGeom prst="rect">
+            <a:avLst/>
+          </a:prstGeom>
+          <a:noFill/>
+          <a:ln/>
+        </p:spPr>
+        <p:txBody>
+          <a:bodyPr wrap="square" lIns="0" tIns="0" rIns="0" bIns="0" rtlCol="0" anchor="ctr"/>
+          <a:lstStyle/>
+          <a:p>
+            <a:pPr indent="0" marL="0">
+              <a:buNone/>
+            </a:pPr>
+            <a:r>
+              <a:rPr lang="en-US" sz="1600" b="1" dirty="0">
+                <a:solidFill>
+                  <a:schemeClr val="tx2"/>
+                </a:solidFill>
+                <a:latin typeface="Calibri" pitchFamily="34" charset="0"/>
+                <a:ea typeface="Calibri" pitchFamily="34" charset="-122"/>
+                <a:cs typeface="Calibri" pitchFamily="34" charset="-120"/>
+              </a:rPr>
+              <a:t>Both configurations fully measured</a:t>
+            </a:r>
+            <a:endParaRPr lang="en-US" sz="1600" dirty="0"/>
+          </a:p>
+        </p:txBody>
+      </p:sp>
+      <p:sp>
+        <p:nvSpPr>
+          <p:cNvPr id="10" name="phi bullets"/>
+          <p:cNvSpPr txBox="1"/>
+          <p:nvPr/>
+        </p:nvSpPr>
+        <p:spPr>
+          <a:xfrm>
+            <a:off x="7680960" y="3566160"/>
+            <a:ext cx="3749040" cy="2423160"/>
+          </a:xfrm>
+          <a:prstGeom prst="rect">
+            <a:avLst/>
+          </a:prstGeom>
+          <a:noFill/>
+          <a:ln/>
+        </p:spPr>
+        <p:txBody>
+          <a:bodyPr wrap="square" lIns="0" tIns="0" rIns="0" bIns="0" rtlCol="0" anchor="t"/>
+          <a:lstStyle/>
+          <a:p>
+            <a:pPr marL="203200" indent="-203200">
+              <a:spcAft>
+                <a:spcPts val="600"/>
+              </a:spcAft>
+              <a:buSzPct val="100000"/>
+              <a:buChar char="•"/>
+            </a:pPr>
+            <a:r>
+              <a:rPr lang="en-US" sz="1250" dirty="0">
+                <a:solidFill>
+                  <a:schemeClr val="tx1"/>
+                </a:solidFill>
+                <a:latin typeface="Calibri" pitchFamily="34" charset="0"/>
+                <a:ea typeface="Calibri" pitchFamily="34" charset="-122"/>
+                <a:cs typeface="Calibri" pitchFamily="34" charset="-120"/>
+              </a:rPr>
+              <a:t>256 genomes in each configuration; fronts of 36 (KleidiAI) and 35 (stock) points</a:t>
+            </a:r>
+            <a:endParaRPr lang="en-US" sz="1250" dirty="0"/>
+          </a:p>
+          <a:p>
+            <a:pPr marL="203200" indent="-203200">
+              <a:spcAft>
+                <a:spcPts val="600"/>
+              </a:spcAft>
+              <a:buSzPct val="100000"/>
+              <a:buChar char="•"/>
+            </a:pPr>
+            <a:r>
+              <a:rPr lang="en-US" sz="1250" dirty="0">
+                <a:solidFill>
+                  <a:schemeClr val="tx1"/>
+                </a:solidFill>
+                <a:latin typeface="Calibri" pitchFamily="34" charset="0"/>
+                <a:ea typeface="Calibri" pitchFamily="34" charset="-122"/>
+                <a:cs typeface="Calibri" pitchFamily="34" charset="-120"/>
+              </a:rPr>
+              <a:t>The GA reaches 0.9998 and 0.9999 of the true hypervolume</a:t>
+            </a:r>
+            <a:endParaRPr lang="en-US" sz="1250" dirty="0"/>
+          </a:p>
+          <a:p>
+            <a:pPr marL="203200" indent="-203200">
+              <a:spcAft>
+                <a:spcPts val="600"/>
+              </a:spcAft>
+              <a:buSzPct val="100000"/>
+              <a:buChar char="•"/>
+            </a:pPr>
+            <a:r>
+              <a:rPr lang="en-US" sz="1250" dirty="0">
+                <a:solidFill>
+                  <a:schemeClr val="tx1"/>
+                </a:solidFill>
+                <a:latin typeface="Calibri" pitchFamily="34" charset="0"/>
+                <a:ea typeface="Calibri" pitchFamily="34" charset="-122"/>
+                <a:cs typeface="Calibri" pitchFamily="34" charset="-120"/>
+              </a:rPr>
+              <a:t>Under KleidiAI the accuracy cost is the one quantity that is not additive (R2 0.83 vs 0.99 stock)</a:t>
+            </a:r>
+            <a:endParaRPr lang="en-US" sz="1250" dirty="0"/>
+          </a:p>
+        </p:txBody>
+      </p:sp>
+      <p:sp>
+        <p:nvSpPr>
+          <p:cNvPr id="25" name="Slide Number Placeholder 0"/>
+          <p:cNvSpPr>
+            <a:spLocks noGrp="1"/>
+          </p:cNvSpPr>
+          <p:nvPr>
+            <p:ph type="sldNum" sz="quarter" idx="4294967295"/>
+          </p:nvPr>
+        </p:nvSpPr>
+        <p:spPr>
+          <a:xfrm>
+            <a:off x="11155680" y="6400800"/>
+            <a:ext cx="548640" cy="274320"/>
+          </a:xfrm>
+          <a:prstGeom prst="rect">
+            <a:avLst/>
+          </a:prstGeom>
+          <a:extLst>
+            <a:ext uri="{C572A759-6A51-4108-AA02-DFA0A04FC94B}">
+              <ma14:wrappingTextBoxFlag xmlns:ma14="http://schemas.microsoft.com/office/mac/drawingml/2011/main" val="0"/>
+            </a:ext>
+          </a:extLst>
+        </p:spPr>
+        <p:txBody>
+          <a:bodyPr/>
+          <a:lstStyle>
+            <a:lvl1pPr>
+              <a:defRPr sz="1100">
+                <a:solidFill>
+                  <a:schemeClr val="accent5"/>
+                </a:solidFill>
+                <a:latin typeface="Calibri"/>
+                <a:ea typeface="Calibri"/>
+                <a:cs typeface="Calibri"/>
+              </a:defRPr>
+            </a:lvl1pPr>
+          </a:lstStyle>
+          <a:p>
+            <a:pPr algn="r"/>
+            <a:fld id="{F7021451-1387-4CA6-816F-3879F97B5CBC}" type="slidenum">
+              <a:rPr b="0" lang="en-US"/>
+              <a:t>18</a:t>
+            </a:fld>
+            <a:endParaRPr lang="en-US"/>
+          </a:p>
+        </p:txBody>
+      </p:sp>
+    </p:spTree>
+  </p:cSld>
+  <p:clrMapOvr>
+    <a:masterClrMapping/>
+  </p:clrMapOvr>
+</p:sld>
+</file>
+
+<file path=ppt/slides/slide19.xml><?xml version="1.0" encoding="utf-8"?>
+<p:sld xmlns:a="http://schemas.openxmlformats.org/drawingml/2006/main" xmlns:r="http://schemas.openxmlformats.org/officeDocument/2006/relationships" xmlns:p="http://schemas.openxmlformats.org/presentationml/2006/main">
+  <p:cSld name="Slide 19">
+    <p:spTree>
+      <p:nvGrpSpPr>
+        <p:cNvPr id="1" name=""/>
+        <p:cNvGrpSpPr/>
+        <p:nvPr/>
+      </p:nvGrpSpPr>
+      <p:grpSpPr>
+        <a:xfrm>
+          <a:off x="0" y="0"/>
+          <a:ext cx="0" cy="0"/>
+          <a:chOff x="0" y="0"/>
+          <a:chExt cx="0" cy="0"/>
+        </a:xfrm>
+      </p:grpSpPr>
+      <p:sp>
+        <p:nvSpPr>
+          <p:cNvPr id="2" name="Text 0"/>
+          <p:cNvSpPr/>
+          <p:nvPr>
+            <p:ph idx="100" type="title" hasCustomPrompt="1"/>
+          </p:nvPr>
+        </p:nvSpPr>
+        <p:spPr>
+          <a:xfrm>
+            <a:off x="548640" y="320040"/>
+            <a:ext cx="11064240" cy="868680"/>
+          </a:xfrm>
+          <a:prstGeom prst="rect">
+            <a:avLst/>
+          </a:prstGeom>
+          <a:noFill/>
+          <a:ln/>
+        </p:spPr>
+        <p:txBody>
+          <a:bodyPr wrap="square" lIns="0" tIns="0" rIns="0" bIns="0" rtlCol="0" anchor="ctr"/>
+          <a:lstStyle/>
+          <a:p>
+            <a:pPr algn="l" indent="0" marL="0">
+              <a:buNone/>
+            </a:pPr>
+            <a:r>
+              <a:rPr lang="en-US" sz="2800" b="1" dirty="0">
+                <a:solidFill>
                   <a:schemeClr val="bg1"/>
                 </a:solidFill>
                 <a:latin typeface="+mj-lt" pitchFamily="34" charset="0"/>
@@ -15145,7 +18616,7 @@
                 <a:ea typeface="Calibri" pitchFamily="34" charset="-122"/>
                 <a:cs typeface="Calibri" pitchFamily="34" charset="-120"/>
               </a:rPr>
-              <a:t>M4 run in progress: KleidiAI over all 256 genomes of two models, stock for the 12 baseline genomes; then the final front, energy and GA-versus-greedy analysis</a:t>
+              <a:t>Done on the M4: both spaces measured (256 genomes per model and configuration, 8B stock for 12). Next: choose operating points on the front by accuracy budget</a:t>
             </a:r>
             <a:endParaRPr lang="en-US" sz="1400" dirty="0"/>
           </a:p>
@@ -15166,7 +18637,7 @@
                 <a:ea typeface="Calibri" pitchFamily="34" charset="-122"/>
                 <a:cs typeface="Calibri" pitchFamily="34" charset="-120"/>
               </a:rPr>
-              <a:t>Refresh the M4 slides from the finished tables (rebuild this deck) and compare the GA with the sensitivity-greedy baseline on measured data</a:t>
+              <a:t>Test where the GA could still win: the non-additive accuracy cost under KleidiAI, and thread count as a gene (speed against energy)</a:t>
             </a:r>
             <a:endParaRPr lang="en-US" sz="1400" dirty="0"/>
           </a:p>
@@ -15229,7 +18700,7 @@
                 <a:ea typeface="Calibri" pitchFamily="34" charset="-122"/>
                 <a:cs typeface="Calibri" pitchFamily="34" charset="-120"/>
               </a:rPr>
-              <a:t>Honest limits today: M4 tables are partial until the run ends; the dry-run searches used simulated speed and energy; no perf-counter data yet</a:t>
+              <a:t>Honest limits: one machine and one run per genome; energy is CPU power only; no hardware performance counters; greedy comparison missing for Phi-3</a:t>
             </a:r>
             <a:endParaRPr lang="en-US" sz="1400" dirty="0"/>
           </a:p>
@@ -15277,7 +18748,7 @@
             <a:pPr algn="r"/>
             <a:fld id="{F7021451-1387-4CA6-816F-3879F97B5CBC}" type="slidenum">
               <a:rPr b="0" lang="en-US"/>
-              <a:t>18</a:t>
+              <a:t>19</a:t>
             </a:fld>
             <a:endParaRPr lang="en-US"/>
           </a:p>
@@ -18878,11 +22349,11 @@
             <a:avLst/>
           </a:prstGeom>
           <a:solidFill>
-            <a:schemeClr val="accent2"/>
+            <a:schemeClr val="accent3"/>
           </a:solidFill>
           <a:ln w="12700">
             <a:solidFill>
-              <a:schemeClr val="accent2"/>
+              <a:schemeClr val="accent3"/>
             </a:solidFill>
             <a:prstDash val="solid"/>
           </a:ln>
@@ -18999,7 +22470,7 @@
                 <a:ea typeface="Calibri" pitchFamily="34" charset="-122"/>
                 <a:cs typeface="Calibri" pitchFamily="34" charset="-120"/>
               </a:rPr>
-              <a:t>The only source of M4 speed and energy; 24-hour minimum on a Dedicated Host</a:t>
+              <a:t>The only source of M4 speed and energy: both models measured over the full space in one 24-hour Dedicated Host block</a:t>
             </a:r>
             <a:endParaRPr lang="en-US" sz="1400" dirty="0"/>
           </a:p>
@@ -19032,13 +22503,13 @@
             <a:r>
               <a:rPr lang="en-US" sz="1400" b="1" dirty="0">
                 <a:solidFill>
-                  <a:srgbClr val="9A5B00"/>
+                  <a:schemeClr val="accent3"/>
                 </a:solidFill>
                 <a:latin typeface="Calibri" pitchFamily="34" charset="0"/>
                 <a:ea typeface="Calibri" pitchFamily="34" charset="-122"/>
                 <a:cs typeface="Calibri" pitchFamily="34" charset="-120"/>
               </a:rPr>
-              <a:t>about $30 for 24 h</a:t>
+              <a:t>done: about $30</a:t>
             </a:r>
             <a:endParaRPr lang="en-US" sz="1400" dirty="0"/>
           </a:p>

</xml_diff>